<commit_message>
Add benchmark slides to PPT (JAFFE LOSO, CK+ CV, SOTA comparison)
- Slide 97: Benchmark results table (best per dataset + pattern)
- Slide 98: SOTA comparison (CK+ and JAFFE vs paper 2023-2025)
- Slide 99: Temuan 16-19 (2x2 layout with mini tables)

Co-Authored-By: Claude Opus 4.6 (1M context) <noreply@anthropic.com>
</commit_message>
<xml_diff>
--- a/docs/PPT Bimbingan.pptx
+++ b/docs/PPT Bimbingan.pptx
@@ -104,6 +104,9 @@
     <p:sldId id="353" r:id="rId103"/>
     <p:sldId id="349" r:id="rId99"/>
     <p:sldId id="348" r:id="rId98"/>
+    <p:sldId id="355" r:id="rId105"/>
+    <p:sldId id="356" r:id="rId106"/>
+    <p:sldId id="357" r:id="rId107"/>
     <p:sldId id="337" r:id="rId87"/>
     <p:sldId id="338" r:id="rId65"/>
   </p:sldIdLst>
@@ -11541,6 +11544,2265 @@
 </p:sld>
 </file>
 
+<file path=ppt/slides/slide100.xml><?xml version="1.0" encoding="utf-8"?>
+<p:sld xmlns:a="http://schemas.openxmlformats.org/drawingml/2006/main" xmlns:p="http://schemas.openxmlformats.org/presentationml/2006/main" xmlns:r="http://schemas.openxmlformats.org/officeDocument/2006/relationships">
+  <p:cSld>
+    <p:spTree>
+      <p:nvGrpSpPr>
+        <p:cNvPr id="1" name=""/>
+        <p:cNvGrpSpPr/>
+        <p:nvPr/>
+      </p:nvGrpSpPr>
+      <p:grpSpPr/>
+      <p:sp>
+        <p:nvSpPr>
+          <p:cNvPr id="2" name="TextBox 1"/>
+          <p:cNvSpPr txBox="1"/>
+          <p:nvPr/>
+        </p:nvSpPr>
+        <p:spPr>
+          <a:xfrm>
+            <a:off x="274320" y="109728"/>
+            <a:ext cx="8595360" cy="502920"/>
+          </a:xfrm>
+          <a:prstGeom prst="rect">
+            <a:avLst/>
+          </a:prstGeom>
+          <a:noFill/>
+        </p:spPr>
+        <p:txBody>
+          <a:bodyPr wrap="none">
+            <a:spAutoFit/>
+          </a:bodyPr>
+          <a:lstStyle/>
+          <a:p>
+            <a:pPr algn="l"/>
+            <a:r>
+              <a:rPr sz="1800" b="1" i="0">
+                <a:solidFill>
+                  <a:srgbClr val="202020"/>
+                </a:solidFill>
+              </a:rPr>
+              <a:t>Perbandingan dengan Paper State-of-the-Art</a:t>
+            </a:r>
+          </a:p>
+        </p:txBody>
+      </p:sp>
+      <p:sp>
+        <p:nvSpPr>
+          <p:cNvPr id="3" name="TextBox 2"/>
+          <p:cNvSpPr txBox="1"/>
+          <p:nvPr/>
+        </p:nvSpPr>
+        <p:spPr>
+          <a:xfrm>
+            <a:off x="274320" y="658368"/>
+            <a:ext cx="8595360" cy="228600"/>
+          </a:xfrm>
+          <a:prstGeom prst="rect">
+            <a:avLst/>
+          </a:prstGeom>
+          <a:noFill/>
+        </p:spPr>
+        <p:txBody>
+          <a:bodyPr wrap="none">
+            <a:spAutoFit/>
+          </a:bodyPr>
+          <a:lstStyle/>
+          <a:p>
+            <a:pPr algn="l"/>
+            <a:r>
+              <a:rPr sz="1000" b="1" i="0">
+                <a:solidFill>
+                  <a:srgbClr val="1A73E8"/>
+                </a:solidFill>
+              </a:rPr>
+              <a:t>CK+ (10-Fold CV)</a:t>
+            </a:r>
+          </a:p>
+        </p:txBody>
+      </p:sp>
+      <p:graphicFrame>
+        <p:nvGraphicFramePr>
+          <p:cNvPr id="4" name="Table 3"/>
+          <p:cNvGraphicFramePr>
+            <a:graphicFrameLocks noGrp="1"/>
+          </p:cNvGraphicFramePr>
+          <p:nvPr/>
+        </p:nvGraphicFramePr>
+        <p:xfrm>
+          <a:off x="274320" y="914400"/>
+          <a:ext cx="8595358" cy="1554480"/>
+        </p:xfrm>
+        <a:graphic>
+          <a:graphicData uri="http://schemas.openxmlformats.org/drawingml/2006/table">
+            <a:tbl>
+              <a:tblPr firstRow="1" bandRow="1"/>
+              <a:tblGrid>
+                <a:gridCol w="1910080"/>
+                <a:gridCol w="848924"/>
+                <a:gridCol w="3183466"/>
+                <a:gridCol w="2652888"/>
+              </a:tblGrid>
+              <a:tr h="259080">
+                <a:tc>
+                  <a:txBody>
+                    <a:bodyPr/>
+                    <a:lstStyle/>
+                    <a:p>
+                      <a:pPr algn="ctr"/>
+                      <a:r>
+                        <a:rPr sz="900" b="1">
+                          <a:solidFill>
+                            <a:srgbClr val="FFFFFF"/>
+                          </a:solidFill>
+                        </a:rPr>
+                        <a:t>Paper</a:t>
+                      </a:r>
+                    </a:p>
+                  </a:txBody>
+                  <a:tcPr>
+                    <a:solidFill>
+                      <a:srgbClr val="1A73E8"/>
+                    </a:solidFill>
+                  </a:tcPr>
+                </a:tc>
+                <a:tc>
+                  <a:txBody>
+                    <a:bodyPr/>
+                    <a:lstStyle/>
+                    <a:p>
+                      <a:pPr algn="ctr"/>
+                      <a:r>
+                        <a:rPr sz="900" b="1">
+                          <a:solidFill>
+                            <a:srgbClr val="FFFFFF"/>
+                          </a:solidFill>
+                        </a:rPr>
+                        <a:t>Tahun</a:t>
+                      </a:r>
+                    </a:p>
+                  </a:txBody>
+                  <a:tcPr>
+                    <a:solidFill>
+                      <a:srgbClr val="1A73E8"/>
+                    </a:solidFill>
+                  </a:tcPr>
+                </a:tc>
+                <a:tc>
+                  <a:txBody>
+                    <a:bodyPr/>
+                    <a:lstStyle/>
+                    <a:p>
+                      <a:pPr algn="ctr"/>
+                      <a:r>
+                        <a:rPr sz="900" b="1">
+                          <a:solidFill>
+                            <a:srgbClr val="FFFFFF"/>
+                          </a:solidFill>
+                        </a:rPr>
+                        <a:t>Metode</a:t>
+                      </a:r>
+                    </a:p>
+                  </a:txBody>
+                  <a:tcPr>
+                    <a:solidFill>
+                      <a:srgbClr val="1A73E8"/>
+                    </a:solidFill>
+                  </a:tcPr>
+                </a:tc>
+                <a:tc>
+                  <a:txBody>
+                    <a:bodyPr/>
+                    <a:lstStyle/>
+                    <a:p>
+                      <a:pPr algn="ctr"/>
+                      <a:r>
+                        <a:rPr sz="900" b="1">
+                          <a:solidFill>
+                            <a:srgbClr val="FFFFFF"/>
+                          </a:solidFill>
+                        </a:rPr>
+                        <a:t>Acc/F1</a:t>
+                      </a:r>
+                    </a:p>
+                  </a:txBody>
+                  <a:tcPr>
+                    <a:solidFill>
+                      <a:srgbClr val="1A73E8"/>
+                    </a:solidFill>
+                  </a:tcPr>
+                </a:tc>
+              </a:tr>
+              <a:tr h="259080">
+                <a:tc>
+                  <a:txBody>
+                    <a:bodyPr/>
+                    <a:lstStyle/>
+                    <a:p>
+                      <a:pPr algn="l"/>
+                      <a:r>
+                        <a:rPr sz="850" b="1">
+                          <a:solidFill>
+                            <a:srgbClr val="202020"/>
+                          </a:solidFill>
+                        </a:rPr>
+                        <a:t>Dada et al.</a:t>
+                      </a:r>
+                    </a:p>
+                  </a:txBody>
+                  <a:tcPr>
+                    <a:solidFill>
+                      <a:srgbClr val="E8F0FE"/>
+                    </a:solidFill>
+                  </a:tcPr>
+                </a:tc>
+                <a:tc>
+                  <a:txBody>
+                    <a:bodyPr/>
+                    <a:lstStyle/>
+                    <a:p>
+                      <a:pPr algn="l"/>
+                      <a:r>
+                        <a:rPr sz="850" b="0">
+                          <a:solidFill>
+                            <a:srgbClr val="202020"/>
+                          </a:solidFill>
+                        </a:rPr>
+                        <a:t>2023</a:t>
+                      </a:r>
+                    </a:p>
+                  </a:txBody>
+                  <a:tcPr>
+                    <a:solidFill>
+                      <a:srgbClr val="E8F0FE"/>
+                    </a:solidFill>
+                  </a:tcPr>
+                </a:tc>
+                <a:tc>
+                  <a:txBody>
+                    <a:bodyPr/>
+                    <a:lstStyle/>
+                    <a:p>
+                      <a:pPr algn="ctr"/>
+                      <a:r>
+                        <a:rPr sz="850" b="0">
+                          <a:solidFill>
+                            <a:srgbClr val="202020"/>
+                          </a:solidFill>
+                        </a:rPr>
+                        <a:t>CNN-10</a:t>
+                      </a:r>
+                    </a:p>
+                  </a:txBody>
+                  <a:tcPr>
+                    <a:solidFill>
+                      <a:srgbClr val="E8F0FE"/>
+                    </a:solidFill>
+                  </a:tcPr>
+                </a:tc>
+                <a:tc>
+                  <a:txBody>
+                    <a:bodyPr/>
+                    <a:lstStyle/>
+                    <a:p>
+                      <a:pPr algn="ctr"/>
+                      <a:r>
+                        <a:rPr sz="850" b="0">
+                          <a:solidFill>
+                            <a:srgbClr val="202020"/>
+                          </a:solidFill>
+                        </a:rPr>
+                        <a:t>99.9% (acc)</a:t>
+                      </a:r>
+                    </a:p>
+                  </a:txBody>
+                  <a:tcPr>
+                    <a:solidFill>
+                      <a:srgbClr val="E8F0FE"/>
+                    </a:solidFill>
+                  </a:tcPr>
+                </a:tc>
+              </a:tr>
+              <a:tr h="259080">
+                <a:tc>
+                  <a:txBody>
+                    <a:bodyPr/>
+                    <a:lstStyle/>
+                    <a:p>
+                      <a:pPr algn="l"/>
+                      <a:r>
+                        <a:rPr sz="850" b="1">
+                          <a:solidFill>
+                            <a:srgbClr val="202020"/>
+                          </a:solidFill>
+                        </a:rPr>
+                        <a:t>AA-DCN</a:t>
+                      </a:r>
+                    </a:p>
+                  </a:txBody>
+                  <a:tcPr>
+                    <a:solidFill>
+                      <a:srgbClr val="FFFFFF"/>
+                    </a:solidFill>
+                  </a:tcPr>
+                </a:tc>
+                <a:tc>
+                  <a:txBody>
+                    <a:bodyPr/>
+                    <a:lstStyle/>
+                    <a:p>
+                      <a:pPr algn="l"/>
+                      <a:r>
+                        <a:rPr sz="850" b="0">
+                          <a:solidFill>
+                            <a:srgbClr val="202020"/>
+                          </a:solidFill>
+                        </a:rPr>
+                        <a:t>2024</a:t>
+                      </a:r>
+                    </a:p>
+                  </a:txBody>
+                  <a:tcPr>
+                    <a:solidFill>
+                      <a:srgbClr val="FFFFFF"/>
+                    </a:solidFill>
+                  </a:tcPr>
+                </a:tc>
+                <a:tc>
+                  <a:txBody>
+                    <a:bodyPr/>
+                    <a:lstStyle/>
+                    <a:p>
+                      <a:pPr algn="ctr"/>
+                      <a:r>
+                        <a:rPr sz="850" b="0">
+                          <a:solidFill>
+                            <a:srgbClr val="202020"/>
+                          </a:solidFill>
+                        </a:rPr>
+                        <a:t>Anti-aliased Deep Conv</a:t>
+                      </a:r>
+                    </a:p>
+                  </a:txBody>
+                  <a:tcPr>
+                    <a:solidFill>
+                      <a:srgbClr val="FFFFFF"/>
+                    </a:solidFill>
+                  </a:tcPr>
+                </a:tc>
+                <a:tc>
+                  <a:txBody>
+                    <a:bodyPr/>
+                    <a:lstStyle/>
+                    <a:p>
+                      <a:pPr algn="ctr"/>
+                      <a:r>
+                        <a:rPr sz="850" b="0">
+                          <a:solidFill>
+                            <a:srgbClr val="202020"/>
+                          </a:solidFill>
+                        </a:rPr>
+                        <a:t>99.26% (acc)</a:t>
+                      </a:r>
+                    </a:p>
+                  </a:txBody>
+                  <a:tcPr>
+                    <a:solidFill>
+                      <a:srgbClr val="FFFFFF"/>
+                    </a:solidFill>
+                  </a:tcPr>
+                </a:tc>
+              </a:tr>
+              <a:tr h="259080">
+                <a:tc>
+                  <a:txBody>
+                    <a:bodyPr/>
+                    <a:lstStyle/>
+                    <a:p>
+                      <a:pPr algn="l"/>
+                      <a:r>
+                        <a:rPr sz="850" b="1">
+                          <a:solidFill>
+                            <a:srgbClr val="202020"/>
+                          </a:solidFill>
+                        </a:rPr>
+                        <a:t>GhostNet</a:t>
+                      </a:r>
+                    </a:p>
+                  </a:txBody>
+                  <a:tcPr>
+                    <a:solidFill>
+                      <a:srgbClr val="E8F0FE"/>
+                    </a:solidFill>
+                  </a:tcPr>
+                </a:tc>
+                <a:tc>
+                  <a:txBody>
+                    <a:bodyPr/>
+                    <a:lstStyle/>
+                    <a:p>
+                      <a:pPr algn="l"/>
+                      <a:r>
+                        <a:rPr sz="850" b="0">
+                          <a:solidFill>
+                            <a:srgbClr val="202020"/>
+                          </a:solidFill>
+                        </a:rPr>
+                        <a:t>2024</a:t>
+                      </a:r>
+                    </a:p>
+                  </a:txBody>
+                  <a:tcPr>
+                    <a:solidFill>
+                      <a:srgbClr val="E8F0FE"/>
+                    </a:solidFill>
+                  </a:tcPr>
+                </a:tc>
+                <a:tc>
+                  <a:txBody>
+                    <a:bodyPr/>
+                    <a:lstStyle/>
+                    <a:p>
+                      <a:pPr algn="ctr"/>
+                      <a:r>
+                        <a:rPr sz="850" b="0">
+                          <a:solidFill>
+                            <a:srgbClr val="202020"/>
+                          </a:solidFill>
+                        </a:rPr>
+                        <a:t>Face+Speech+EEG</a:t>
+                      </a:r>
+                    </a:p>
+                  </a:txBody>
+                  <a:tcPr>
+                    <a:solidFill>
+                      <a:srgbClr val="E8F0FE"/>
+                    </a:solidFill>
+                  </a:tcPr>
+                </a:tc>
+                <a:tc>
+                  <a:txBody>
+                    <a:bodyPr/>
+                    <a:lstStyle/>
+                    <a:p>
+                      <a:pPr algn="ctr"/>
+                      <a:r>
+                        <a:rPr sz="850" b="0">
+                          <a:solidFill>
+                            <a:srgbClr val="202020"/>
+                          </a:solidFill>
+                        </a:rPr>
+                        <a:t>98.27% (acc)</a:t>
+                      </a:r>
+                    </a:p>
+                  </a:txBody>
+                  <a:tcPr>
+                    <a:solidFill>
+                      <a:srgbClr val="E8F0FE"/>
+                    </a:solidFill>
+                  </a:tcPr>
+                </a:tc>
+              </a:tr>
+              <a:tr h="259080">
+                <a:tc>
+                  <a:txBody>
+                    <a:bodyPr/>
+                    <a:lstStyle/>
+                    <a:p>
+                      <a:pPr algn="l"/>
+                      <a:r>
+                        <a:rPr sz="850" b="1">
+                          <a:solidFill>
+                            <a:srgbClr val="202020"/>
+                          </a:solidFill>
+                        </a:rPr>
+                        <a:t>b-skeleton+CNN</a:t>
+                      </a:r>
+                    </a:p>
+                  </a:txBody>
+                  <a:tcPr>
+                    <a:solidFill>
+                      <a:srgbClr val="FFFFFF"/>
+                    </a:solidFill>
+                  </a:tcPr>
+                </a:tc>
+                <a:tc>
+                  <a:txBody>
+                    <a:bodyPr/>
+                    <a:lstStyle/>
+                    <a:p>
+                      <a:pPr algn="l"/>
+                      <a:r>
+                        <a:rPr sz="850" b="0">
+                          <a:solidFill>
+                            <a:srgbClr val="202020"/>
+                          </a:solidFill>
+                        </a:rPr>
+                        <a:t>2024</a:t>
+                      </a:r>
+                    </a:p>
+                  </a:txBody>
+                  <a:tcPr>
+                    <a:solidFill>
+                      <a:srgbClr val="FFFFFF"/>
+                    </a:solidFill>
+                  </a:tcPr>
+                </a:tc>
+                <a:tc>
+                  <a:txBody>
+                    <a:bodyPr/>
+                    <a:lstStyle/>
+                    <a:p>
+                      <a:pPr algn="ctr"/>
+                      <a:r>
+                        <a:rPr sz="850" b="0">
+                          <a:solidFill>
+                            <a:srgbClr val="202020"/>
+                          </a:solidFill>
+                        </a:rPr>
+                        <a:t>Landmark + CNN</a:t>
+                      </a:r>
+                    </a:p>
+                  </a:txBody>
+                  <a:tcPr>
+                    <a:solidFill>
+                      <a:srgbClr val="FFFFFF"/>
+                    </a:solidFill>
+                  </a:tcPr>
+                </a:tc>
+                <a:tc>
+                  <a:txBody>
+                    <a:bodyPr/>
+                    <a:lstStyle/>
+                    <a:p>
+                      <a:pPr algn="ctr"/>
+                      <a:r>
+                        <a:rPr sz="850" b="0">
+                          <a:solidFill>
+                            <a:srgbClr val="202020"/>
+                          </a:solidFill>
+                        </a:rPr>
+                        <a:t>96.19% (acc)</a:t>
+                      </a:r>
+                    </a:p>
+                  </a:txBody>
+                  <a:tcPr>
+                    <a:solidFill>
+                      <a:srgbClr val="FFFFFF"/>
+                    </a:solidFill>
+                  </a:tcPr>
+                </a:tc>
+              </a:tr>
+              <a:tr h="259080">
+                <a:tc>
+                  <a:txBody>
+                    <a:bodyPr/>
+                    <a:lstStyle/>
+                    <a:p>
+                      <a:pPr algn="l"/>
+                      <a:r>
+                        <a:rPr sz="850" b="1">
+                          <a:solidFill>
+                            <a:srgbClr val="202020"/>
+                          </a:solidFill>
+                        </a:rPr>
+                        <a:t>Penelitian ini</a:t>
+                      </a:r>
+                    </a:p>
+                  </a:txBody>
+                  <a:tcPr>
+                    <a:solidFill>
+                      <a:srgbClr val="C6EFCE"/>
+                    </a:solidFill>
+                  </a:tcPr>
+                </a:tc>
+                <a:tc>
+                  <a:txBody>
+                    <a:bodyPr/>
+                    <a:lstStyle/>
+                    <a:p>
+                      <a:pPr algn="l"/>
+                      <a:r>
+                        <a:rPr sz="850" b="1">
+                          <a:solidFill>
+                            <a:srgbClr val="202020"/>
+                          </a:solidFill>
+                        </a:rPr>
+                        <a:t>2026</a:t>
+                      </a:r>
+                    </a:p>
+                  </a:txBody>
+                  <a:tcPr>
+                    <a:solidFill>
+                      <a:srgbClr val="C6EFCE"/>
+                    </a:solidFill>
+                  </a:tcPr>
+                </a:tc>
+                <a:tc>
+                  <a:txBody>
+                    <a:bodyPr/>
+                    <a:lstStyle/>
+                    <a:p>
+                      <a:pPr algn="ctr"/>
+                      <a:r>
+                        <a:rPr sz="850" b="1">
+                          <a:solidFill>
+                            <a:srgbClr val="202020"/>
+                          </a:solidFill>
+                        </a:rPr>
+                        <a:t>Intermediate TL (ResNet18)</a:t>
+                      </a:r>
+                    </a:p>
+                  </a:txBody>
+                  <a:tcPr>
+                    <a:solidFill>
+                      <a:srgbClr val="C6EFCE"/>
+                    </a:solidFill>
+                  </a:tcPr>
+                </a:tc>
+                <a:tc>
+                  <a:txBody>
+                    <a:bodyPr/>
+                    <a:lstStyle/>
+                    <a:p>
+                      <a:pPr algn="ctr"/>
+                      <a:r>
+                        <a:rPr sz="850" b="1">
+                          <a:solidFill>
+                            <a:srgbClr val="202020"/>
+                          </a:solidFill>
+                        </a:rPr>
+                        <a:t>91.9% / F1: 0.783</a:t>
+                      </a:r>
+                    </a:p>
+                  </a:txBody>
+                  <a:tcPr>
+                    <a:solidFill>
+                      <a:srgbClr val="C6EFCE"/>
+                    </a:solidFill>
+                  </a:tcPr>
+                </a:tc>
+              </a:tr>
+            </a:tbl>
+          </a:graphicData>
+        </a:graphic>
+      </p:graphicFrame>
+      <p:sp>
+        <p:nvSpPr>
+          <p:cNvPr id="5" name="TextBox 4"/>
+          <p:cNvSpPr txBox="1"/>
+          <p:nvPr/>
+        </p:nvSpPr>
+        <p:spPr>
+          <a:xfrm>
+            <a:off x="274320" y="2560320"/>
+            <a:ext cx="8595360" cy="228600"/>
+          </a:xfrm>
+          <a:prstGeom prst="rect">
+            <a:avLst/>
+          </a:prstGeom>
+          <a:noFill/>
+        </p:spPr>
+        <p:txBody>
+          <a:bodyPr wrap="none">
+            <a:spAutoFit/>
+          </a:bodyPr>
+          <a:lstStyle/>
+          <a:p>
+            <a:pPr algn="l"/>
+            <a:r>
+              <a:rPr sz="1000" b="1" i="0">
+                <a:solidFill>
+                  <a:srgbClr val="1A73E8"/>
+                </a:solidFill>
+              </a:rPr>
+              <a:t>JAFFE (LOSO)</a:t>
+            </a:r>
+          </a:p>
+        </p:txBody>
+      </p:sp>
+      <p:graphicFrame>
+        <p:nvGraphicFramePr>
+          <p:cNvPr id="6" name="Table 5"/>
+          <p:cNvGraphicFramePr>
+            <a:graphicFrameLocks noGrp="1"/>
+          </p:cNvGraphicFramePr>
+          <p:nvPr/>
+        </p:nvGraphicFramePr>
+        <p:xfrm>
+          <a:off x="274320" y="2834640"/>
+          <a:ext cx="8595358" cy="1234440"/>
+        </p:xfrm>
+        <a:graphic>
+          <a:graphicData uri="http://schemas.openxmlformats.org/drawingml/2006/table">
+            <a:tbl>
+              <a:tblPr firstRow="1" bandRow="1"/>
+              <a:tblGrid>
+                <a:gridCol w="2071171"/>
+                <a:gridCol w="828468"/>
+                <a:gridCol w="3106756"/>
+                <a:gridCol w="2588963"/>
+              </a:tblGrid>
+              <a:tr h="246888">
+                <a:tc>
+                  <a:txBody>
+                    <a:bodyPr/>
+                    <a:lstStyle/>
+                    <a:p>
+                      <a:pPr algn="ctr"/>
+                      <a:r>
+                        <a:rPr sz="900" b="1">
+                          <a:solidFill>
+                            <a:srgbClr val="FFFFFF"/>
+                          </a:solidFill>
+                        </a:rPr>
+                        <a:t>Paper</a:t>
+                      </a:r>
+                    </a:p>
+                  </a:txBody>
+                  <a:tcPr>
+                    <a:solidFill>
+                      <a:srgbClr val="1A73E8"/>
+                    </a:solidFill>
+                  </a:tcPr>
+                </a:tc>
+                <a:tc>
+                  <a:txBody>
+                    <a:bodyPr/>
+                    <a:lstStyle/>
+                    <a:p>
+                      <a:pPr algn="ctr"/>
+                      <a:r>
+                        <a:rPr sz="900" b="1">
+                          <a:solidFill>
+                            <a:srgbClr val="FFFFFF"/>
+                          </a:solidFill>
+                        </a:rPr>
+                        <a:t>Tahun</a:t>
+                      </a:r>
+                    </a:p>
+                  </a:txBody>
+                  <a:tcPr>
+                    <a:solidFill>
+                      <a:srgbClr val="1A73E8"/>
+                    </a:solidFill>
+                  </a:tcPr>
+                </a:tc>
+                <a:tc>
+                  <a:txBody>
+                    <a:bodyPr/>
+                    <a:lstStyle/>
+                    <a:p>
+                      <a:pPr algn="ctr"/>
+                      <a:r>
+                        <a:rPr sz="900" b="1">
+                          <a:solidFill>
+                            <a:srgbClr val="FFFFFF"/>
+                          </a:solidFill>
+                        </a:rPr>
+                        <a:t>Metode</a:t>
+                      </a:r>
+                    </a:p>
+                  </a:txBody>
+                  <a:tcPr>
+                    <a:solidFill>
+                      <a:srgbClr val="1A73E8"/>
+                    </a:solidFill>
+                  </a:tcPr>
+                </a:tc>
+                <a:tc>
+                  <a:txBody>
+                    <a:bodyPr/>
+                    <a:lstStyle/>
+                    <a:p>
+                      <a:pPr algn="ctr"/>
+                      <a:r>
+                        <a:rPr sz="900" b="1">
+                          <a:solidFill>
+                            <a:srgbClr val="FFFFFF"/>
+                          </a:solidFill>
+                        </a:rPr>
+                        <a:t>Acc/F1</a:t>
+                      </a:r>
+                    </a:p>
+                  </a:txBody>
+                  <a:tcPr>
+                    <a:solidFill>
+                      <a:srgbClr val="1A73E8"/>
+                    </a:solidFill>
+                  </a:tcPr>
+                </a:tc>
+              </a:tr>
+              <a:tr h="246888">
+                <a:tc>
+                  <a:txBody>
+                    <a:bodyPr/>
+                    <a:lstStyle/>
+                    <a:p>
+                      <a:pPr algn="l"/>
+                      <a:r>
+                        <a:rPr sz="850" b="1">
+                          <a:solidFill>
+                            <a:srgbClr val="202020"/>
+                          </a:solidFill>
+                        </a:rPr>
+                        <a:t>AA-DCN</a:t>
+                      </a:r>
+                    </a:p>
+                  </a:txBody>
+                  <a:tcPr>
+                    <a:solidFill>
+                      <a:srgbClr val="E8F0FE"/>
+                    </a:solidFill>
+                  </a:tcPr>
+                </a:tc>
+                <a:tc>
+                  <a:txBody>
+                    <a:bodyPr/>
+                    <a:lstStyle/>
+                    <a:p>
+                      <a:pPr algn="l"/>
+                      <a:r>
+                        <a:rPr sz="850" b="0">
+                          <a:solidFill>
+                            <a:srgbClr val="202020"/>
+                          </a:solidFill>
+                        </a:rPr>
+                        <a:t>2024</a:t>
+                      </a:r>
+                    </a:p>
+                  </a:txBody>
+                  <a:tcPr>
+                    <a:solidFill>
+                      <a:srgbClr val="E8F0FE"/>
+                    </a:solidFill>
+                  </a:tcPr>
+                </a:tc>
+                <a:tc>
+                  <a:txBody>
+                    <a:bodyPr/>
+                    <a:lstStyle/>
+                    <a:p>
+                      <a:pPr algn="ctr"/>
+                      <a:r>
+                        <a:rPr sz="850" b="0">
+                          <a:solidFill>
+                            <a:srgbClr val="202020"/>
+                          </a:solidFill>
+                        </a:rPr>
+                        <a:t>Anti-aliased Deep Conv</a:t>
+                      </a:r>
+                    </a:p>
+                  </a:txBody>
+                  <a:tcPr>
+                    <a:solidFill>
+                      <a:srgbClr val="E8F0FE"/>
+                    </a:solidFill>
+                  </a:tcPr>
+                </a:tc>
+                <a:tc>
+                  <a:txBody>
+                    <a:bodyPr/>
+                    <a:lstStyle/>
+                    <a:p>
+                      <a:pPr algn="ctr"/>
+                      <a:r>
+                        <a:rPr sz="850" b="0">
+                          <a:solidFill>
+                            <a:srgbClr val="202020"/>
+                          </a:solidFill>
+                        </a:rPr>
+                        <a:t>98.0% (acc)</a:t>
+                      </a:r>
+                    </a:p>
+                  </a:txBody>
+                  <a:tcPr>
+                    <a:solidFill>
+                      <a:srgbClr val="E8F0FE"/>
+                    </a:solidFill>
+                  </a:tcPr>
+                </a:tc>
+              </a:tr>
+              <a:tr h="246888">
+                <a:tc>
+                  <a:txBody>
+                    <a:bodyPr/>
+                    <a:lstStyle/>
+                    <a:p>
+                      <a:pPr algn="l"/>
+                      <a:r>
+                        <a:rPr sz="850" b="1">
+                          <a:solidFill>
+                            <a:srgbClr val="202020"/>
+                          </a:solidFill>
+                        </a:rPr>
+                        <a:t>Fine-grained fusion</a:t>
+                      </a:r>
+                    </a:p>
+                  </a:txBody>
+                  <a:tcPr>
+                    <a:solidFill>
+                      <a:srgbClr val="FFFFFF"/>
+                    </a:solidFill>
+                  </a:tcPr>
+                </a:tc>
+                <a:tc>
+                  <a:txBody>
+                    <a:bodyPr/>
+                    <a:lstStyle/>
+                    <a:p>
+                      <a:pPr algn="l"/>
+                      <a:r>
+                        <a:rPr sz="850" b="0">
+                          <a:solidFill>
+                            <a:srgbClr val="202020"/>
+                          </a:solidFill>
+                        </a:rPr>
+                        <a:t>2025</a:t>
+                      </a:r>
+                    </a:p>
+                  </a:txBody>
+                  <a:tcPr>
+                    <a:solidFill>
+                      <a:srgbClr val="FFFFFF"/>
+                    </a:solidFill>
+                  </a:tcPr>
+                </a:tc>
+                <a:tc>
+                  <a:txBody>
+                    <a:bodyPr/>
+                    <a:lstStyle/>
+                    <a:p>
+                      <a:pPr algn="ctr"/>
+                      <a:r>
+                        <a:rPr sz="850" b="0">
+                          <a:solidFill>
+                            <a:srgbClr val="202020"/>
+                          </a:solidFill>
+                        </a:rPr>
+                        <a:t>Landmark + image</a:t>
+                      </a:r>
+                    </a:p>
+                  </a:txBody>
+                  <a:tcPr>
+                    <a:solidFill>
+                      <a:srgbClr val="FFFFFF"/>
+                    </a:solidFill>
+                  </a:tcPr>
+                </a:tc>
+                <a:tc>
+                  <a:txBody>
+                    <a:bodyPr/>
+                    <a:lstStyle/>
+                    <a:p>
+                      <a:pPr algn="ctr"/>
+                      <a:r>
+                        <a:rPr sz="850" b="0">
+                          <a:solidFill>
+                            <a:srgbClr val="202020"/>
+                          </a:solidFill>
+                        </a:rPr>
+                        <a:t>97.61% (acc)</a:t>
+                      </a:r>
+                    </a:p>
+                  </a:txBody>
+                  <a:tcPr>
+                    <a:solidFill>
+                      <a:srgbClr val="FFFFFF"/>
+                    </a:solidFill>
+                  </a:tcPr>
+                </a:tc>
+              </a:tr>
+              <a:tr h="246888">
+                <a:tc>
+                  <a:txBody>
+                    <a:bodyPr/>
+                    <a:lstStyle/>
+                    <a:p>
+                      <a:pPr algn="l"/>
+                      <a:r>
+                        <a:rPr sz="850" b="1">
+                          <a:solidFill>
+                            <a:srgbClr val="202020"/>
+                          </a:solidFill>
+                        </a:rPr>
+                        <a:t>b-skeleton+CNN</a:t>
+                      </a:r>
+                    </a:p>
+                  </a:txBody>
+                  <a:tcPr>
+                    <a:solidFill>
+                      <a:srgbClr val="E8F0FE"/>
+                    </a:solidFill>
+                  </a:tcPr>
+                </a:tc>
+                <a:tc>
+                  <a:txBody>
+                    <a:bodyPr/>
+                    <a:lstStyle/>
+                    <a:p>
+                      <a:pPr algn="l"/>
+                      <a:r>
+                        <a:rPr sz="850" b="0">
+                          <a:solidFill>
+                            <a:srgbClr val="202020"/>
+                          </a:solidFill>
+                        </a:rPr>
+                        <a:t>2024</a:t>
+                      </a:r>
+                    </a:p>
+                  </a:txBody>
+                  <a:tcPr>
+                    <a:solidFill>
+                      <a:srgbClr val="E8F0FE"/>
+                    </a:solidFill>
+                  </a:tcPr>
+                </a:tc>
+                <a:tc>
+                  <a:txBody>
+                    <a:bodyPr/>
+                    <a:lstStyle/>
+                    <a:p>
+                      <a:pPr algn="ctr"/>
+                      <a:r>
+                        <a:rPr sz="850" b="0">
+                          <a:solidFill>
+                            <a:srgbClr val="202020"/>
+                          </a:solidFill>
+                        </a:rPr>
+                        <a:t>Landmark geometric</a:t>
+                      </a:r>
+                    </a:p>
+                  </a:txBody>
+                  <a:tcPr>
+                    <a:solidFill>
+                      <a:srgbClr val="E8F0FE"/>
+                    </a:solidFill>
+                  </a:tcPr>
+                </a:tc>
+                <a:tc>
+                  <a:txBody>
+                    <a:bodyPr/>
+                    <a:lstStyle/>
+                    <a:p>
+                      <a:pPr algn="ctr"/>
+                      <a:r>
+                        <a:rPr sz="850" b="0">
+                          <a:solidFill>
+                            <a:srgbClr val="202020"/>
+                          </a:solidFill>
+                        </a:rPr>
+                        <a:t>89.23% (acc)</a:t>
+                      </a:r>
+                    </a:p>
+                  </a:txBody>
+                  <a:tcPr>
+                    <a:solidFill>
+                      <a:srgbClr val="E8F0FE"/>
+                    </a:solidFill>
+                  </a:tcPr>
+                </a:tc>
+              </a:tr>
+              <a:tr h="246888">
+                <a:tc>
+                  <a:txBody>
+                    <a:bodyPr/>
+                    <a:lstStyle/>
+                    <a:p>
+                      <a:pPr algn="l"/>
+                      <a:r>
+                        <a:rPr sz="850" b="1">
+                          <a:solidFill>
+                            <a:srgbClr val="202020"/>
+                          </a:solidFill>
+                        </a:rPr>
+                        <a:t>Penelitian ini</a:t>
+                      </a:r>
+                    </a:p>
+                  </a:txBody>
+                  <a:tcPr>
+                    <a:solidFill>
+                      <a:srgbClr val="C6EFCE"/>
+                    </a:solidFill>
+                  </a:tcPr>
+                </a:tc>
+                <a:tc>
+                  <a:txBody>
+                    <a:bodyPr/>
+                    <a:lstStyle/>
+                    <a:p>
+                      <a:pPr algn="l"/>
+                      <a:r>
+                        <a:rPr sz="850" b="1">
+                          <a:solidFill>
+                            <a:srgbClr val="202020"/>
+                          </a:solidFill>
+                        </a:rPr>
+                        <a:t>2026</a:t>
+                      </a:r>
+                    </a:p>
+                  </a:txBody>
+                  <a:tcPr>
+                    <a:solidFill>
+                      <a:srgbClr val="C6EFCE"/>
+                    </a:solidFill>
+                  </a:tcPr>
+                </a:tc>
+                <a:tc>
+                  <a:txBody>
+                    <a:bodyPr/>
+                    <a:lstStyle/>
+                    <a:p>
+                      <a:pPr algn="ctr"/>
+                      <a:r>
+                        <a:rPr sz="850" b="1">
+                          <a:solidFill>
+                            <a:srgbClr val="202020"/>
+                          </a:solidFill>
+                        </a:rPr>
+                        <a:t>Late Fusion (CNN+FCNN)</a:t>
+                      </a:r>
+                    </a:p>
+                  </a:txBody>
+                  <a:tcPr>
+                    <a:solidFill>
+                      <a:srgbClr val="C6EFCE"/>
+                    </a:solidFill>
+                  </a:tcPr>
+                </a:tc>
+                <a:tc>
+                  <a:txBody>
+                    <a:bodyPr/>
+                    <a:lstStyle/>
+                    <a:p>
+                      <a:pPr algn="ctr"/>
+                      <a:r>
+                        <a:rPr sz="850" b="1">
+                          <a:solidFill>
+                            <a:srgbClr val="202020"/>
+                          </a:solidFill>
+                        </a:rPr>
+                        <a:t>54.0% / F1: 0.467</a:t>
+                      </a:r>
+                    </a:p>
+                  </a:txBody>
+                  <a:tcPr>
+                    <a:solidFill>
+                      <a:srgbClr val="C6EFCE"/>
+                    </a:solidFill>
+                  </a:tcPr>
+                </a:tc>
+              </a:tr>
+            </a:tbl>
+          </a:graphicData>
+        </a:graphic>
+      </p:graphicFrame>
+      <p:sp>
+        <p:nvSpPr>
+          <p:cNvPr id="7" name="TextBox 6"/>
+          <p:cNvSpPr txBox="1"/>
+          <p:nvPr/>
+        </p:nvSpPr>
+        <p:spPr>
+          <a:xfrm>
+            <a:off x="274320" y="4160520"/>
+            <a:ext cx="8595360" cy="320040"/>
+          </a:xfrm>
+          <a:prstGeom prst="rect">
+            <a:avLst/>
+          </a:prstGeom>
+          <a:noFill/>
+        </p:spPr>
+        <p:txBody>
+          <a:bodyPr wrap="square">
+            <a:spAutoFit/>
+          </a:bodyPr>
+          <a:lstStyle/>
+          <a:p>
+            <a:pPr algn="l"/>
+            <a:r>
+              <a:rPr sz="750" b="0" i="1">
+                <a:solidFill>
+                  <a:srgbClr val="666666"/>
+                </a:solidFill>
+              </a:rPr>
+              <a:t>Catatan: Paper SOTA pakai arsitektur lebih besar (VGG/EfficientNet), sebagian random split. Penelitian ini pakai ResNet18 + subject-wise CV/LOSO yang lebih ketat.</a:t>
+            </a:r>
+          </a:p>
+        </p:txBody>
+      </p:sp>
+    </p:spTree>
+  </p:cSld>
+  <p:clrMapOvr>
+    <a:masterClrMapping/>
+  </p:clrMapOvr>
+</p:sld>
+</file>
+
+<file path=ppt/slides/slide101.xml><?xml version="1.0" encoding="utf-8"?>
+<p:sld xmlns:a="http://schemas.openxmlformats.org/drawingml/2006/main" xmlns:p="http://schemas.openxmlformats.org/presentationml/2006/main" xmlns:r="http://schemas.openxmlformats.org/officeDocument/2006/relationships">
+  <p:cSld>
+    <p:spTree>
+      <p:nvGrpSpPr>
+        <p:cNvPr id="1" name=""/>
+        <p:cNvGrpSpPr/>
+        <p:nvPr/>
+      </p:nvGrpSpPr>
+      <p:grpSpPr/>
+      <p:sp>
+        <p:nvSpPr>
+          <p:cNvPr id="2" name="TextBox 1"/>
+          <p:cNvSpPr txBox="1"/>
+          <p:nvPr/>
+        </p:nvSpPr>
+        <p:spPr>
+          <a:xfrm>
+            <a:off x="274320" y="109728"/>
+            <a:ext cx="8595360" cy="502920"/>
+          </a:xfrm>
+          <a:prstGeom prst="rect">
+            <a:avLst/>
+          </a:prstGeom>
+          <a:noFill/>
+        </p:spPr>
+        <p:txBody>
+          <a:bodyPr wrap="none">
+            <a:spAutoFit/>
+          </a:bodyPr>
+          <a:lstStyle/>
+          <a:p>
+            <a:pPr algn="l"/>
+            <a:r>
+              <a:rPr sz="1800" b="1" i="0">
+                <a:solidFill>
+                  <a:srgbClr val="202020"/>
+                </a:solidFill>
+              </a:rPr>
+              <a:t>Analisis Hasil -- Temuan Benchmark</a:t>
+            </a:r>
+          </a:p>
+        </p:txBody>
+      </p:sp>
+      <p:sp>
+        <p:nvSpPr>
+          <p:cNvPr id="3" name="TextBox 2"/>
+          <p:cNvSpPr txBox="1"/>
+          <p:nvPr/>
+        </p:nvSpPr>
+        <p:spPr>
+          <a:xfrm>
+            <a:off x="274320" y="713232"/>
+            <a:ext cx="4114800" cy="228600"/>
+          </a:xfrm>
+          <a:prstGeom prst="rect">
+            <a:avLst/>
+          </a:prstGeom>
+          <a:noFill/>
+        </p:spPr>
+        <p:txBody>
+          <a:bodyPr wrap="none">
+            <a:spAutoFit/>
+          </a:bodyPr>
+          <a:lstStyle/>
+          <a:p>
+            <a:pPr algn="l"/>
+            <a:r>
+              <a:rPr sz="850" b="1" i="0">
+                <a:solidFill>
+                  <a:srgbClr val="1A73E8"/>
+                </a:solidFill>
+              </a:rPr>
+              <a:t>Temuan 16: CK+ jauh lebih tinggi dari dataset sendiri</a:t>
+            </a:r>
+          </a:p>
+        </p:txBody>
+      </p:sp>
+      <p:graphicFrame>
+        <p:nvGraphicFramePr>
+          <p:cNvPr id="4" name="Table 3"/>
+          <p:cNvGraphicFramePr>
+            <a:graphicFrameLocks noGrp="1"/>
+          </p:cNvGraphicFramePr>
+          <p:nvPr/>
+        </p:nvGraphicFramePr>
+        <p:xfrm>
+          <a:off x="274320" y="987552"/>
+          <a:ext cx="4114800" cy="822960"/>
+        </p:xfrm>
+        <a:graphic>
+          <a:graphicData uri="http://schemas.openxmlformats.org/drawingml/2006/table">
+            <a:tbl>
+              <a:tblPr firstRow="1" bandRow="1"/>
+              <a:tblGrid>
+                <a:gridCol w="2286000"/>
+                <a:gridCol w="1828800"/>
+              </a:tblGrid>
+              <a:tr h="205740">
+                <a:tc>
+                  <a:txBody>
+                    <a:bodyPr/>
+                    <a:lstStyle/>
+                    <a:p>
+                      <a:pPr algn="ctr"/>
+                      <a:r>
+                        <a:rPr sz="850" b="1">
+                          <a:solidFill>
+                            <a:srgbClr val="FFFFFF"/>
+                          </a:solidFill>
+                        </a:rPr>
+                        <a:t>Dataset</a:t>
+                      </a:r>
+                    </a:p>
+                  </a:txBody>
+                  <a:tcPr>
+                    <a:solidFill>
+                      <a:srgbClr val="1A73E8"/>
+                    </a:solidFill>
+                  </a:tcPr>
+                </a:tc>
+                <a:tc>
+                  <a:txBody>
+                    <a:bodyPr/>
+                    <a:lstStyle/>
+                    <a:p>
+                      <a:pPr algn="ctr"/>
+                      <a:r>
+                        <a:rPr sz="850" b="1">
+                          <a:solidFill>
+                            <a:srgbClr val="FFFFFF"/>
+                          </a:solidFill>
+                        </a:rPr>
+                        <a:t>Best F1</a:t>
+                      </a:r>
+                    </a:p>
+                  </a:txBody>
+                  <a:tcPr>
+                    <a:solidFill>
+                      <a:srgbClr val="1A73E8"/>
+                    </a:solidFill>
+                  </a:tcPr>
+                </a:tc>
+              </a:tr>
+              <a:tr h="205740">
+                <a:tc>
+                  <a:txBody>
+                    <a:bodyPr/>
+                    <a:lstStyle/>
+                    <a:p>
+                      <a:pPr algn="l"/>
+                      <a:r>
+                        <a:rPr sz="850" b="1">
+                          <a:solidFill>
+                            <a:srgbClr val="202020"/>
+                          </a:solidFill>
+                        </a:rPr>
+                        <a:t>CK+ (lab)</a:t>
+                      </a:r>
+                    </a:p>
+                  </a:txBody>
+                  <a:tcPr>
+                    <a:solidFill>
+                      <a:srgbClr val="E8F0FE"/>
+                    </a:solidFill>
+                  </a:tcPr>
+                </a:tc>
+                <a:tc>
+                  <a:txBody>
+                    <a:bodyPr/>
+                    <a:lstStyle/>
+                    <a:p>
+                      <a:pPr algn="l"/>
+                      <a:r>
+                        <a:rPr sz="850" b="0">
+                          <a:solidFill>
+                            <a:srgbClr val="202020"/>
+                          </a:solidFill>
+                        </a:rPr>
+                        <a:t>0.783</a:t>
+                      </a:r>
+                    </a:p>
+                  </a:txBody>
+                  <a:tcPr>
+                    <a:solidFill>
+                      <a:srgbClr val="E8F0FE"/>
+                    </a:solidFill>
+                  </a:tcPr>
+                </a:tc>
+              </a:tr>
+              <a:tr h="205740">
+                <a:tc>
+                  <a:txBody>
+                    <a:bodyPr/>
+                    <a:lstStyle/>
+                    <a:p>
+                      <a:pPr algn="l"/>
+                      <a:r>
+                        <a:rPr sz="850" b="1">
+                          <a:solidFill>
+                            <a:srgbClr val="202020"/>
+                          </a:solidFill>
+                        </a:rPr>
+                        <a:t>JAFFE (lab)</a:t>
+                      </a:r>
+                    </a:p>
+                  </a:txBody>
+                  <a:tcPr>
+                    <a:solidFill>
+                      <a:srgbClr val="FFFFFF"/>
+                    </a:solidFill>
+                  </a:tcPr>
+                </a:tc>
+                <a:tc>
+                  <a:txBody>
+                    <a:bodyPr/>
+                    <a:lstStyle/>
+                    <a:p>
+                      <a:pPr algn="l"/>
+                      <a:r>
+                        <a:rPr sz="850" b="0">
+                          <a:solidFill>
+                            <a:srgbClr val="202020"/>
+                          </a:solidFill>
+                        </a:rPr>
+                        <a:t>0.467</a:t>
+                      </a:r>
+                    </a:p>
+                  </a:txBody>
+                  <a:tcPr>
+                    <a:solidFill>
+                      <a:srgbClr val="FFFFFF"/>
+                    </a:solidFill>
+                  </a:tcPr>
+                </a:tc>
+              </a:tr>
+              <a:tr h="205740">
+                <a:tc>
+                  <a:txBody>
+                    <a:bodyPr/>
+                    <a:lstStyle/>
+                    <a:p>
+                      <a:pPr algn="l"/>
+                      <a:r>
+                        <a:rPr sz="850" b="1">
+                          <a:solidFill>
+                            <a:srgbClr val="202020"/>
+                          </a:solidFill>
+                        </a:rPr>
+                        <a:t>Dataset sendiri</a:t>
+                      </a:r>
+                    </a:p>
+                  </a:txBody>
+                  <a:tcPr>
+                    <a:solidFill>
+                      <a:srgbClr val="E8F0FE"/>
+                    </a:solidFill>
+                  </a:tcPr>
+                </a:tc>
+                <a:tc>
+                  <a:txBody>
+                    <a:bodyPr/>
+                    <a:lstStyle/>
+                    <a:p>
+                      <a:pPr algn="l"/>
+                      <a:r>
+                        <a:rPr sz="850" b="0">
+                          <a:solidFill>
+                            <a:srgbClr val="202020"/>
+                          </a:solidFill>
+                        </a:rPr>
+                        <a:t>0.370</a:t>
+                      </a:r>
+                    </a:p>
+                  </a:txBody>
+                  <a:tcPr>
+                    <a:solidFill>
+                      <a:srgbClr val="E8F0FE"/>
+                    </a:solidFill>
+                  </a:tcPr>
+                </a:tc>
+              </a:tr>
+            </a:tbl>
+          </a:graphicData>
+        </a:graphic>
+      </p:graphicFrame>
+      <p:sp>
+        <p:nvSpPr>
+          <p:cNvPr id="5" name="TextBox 4"/>
+          <p:cNvSpPr txBox="1"/>
+          <p:nvPr/>
+        </p:nvSpPr>
+        <p:spPr>
+          <a:xfrm>
+            <a:off x="4572000" y="713232"/>
+            <a:ext cx="4206240" cy="228600"/>
+          </a:xfrm>
+          <a:prstGeom prst="rect">
+            <a:avLst/>
+          </a:prstGeom>
+          <a:noFill/>
+        </p:spPr>
+        <p:txBody>
+          <a:bodyPr wrap="none">
+            <a:spAutoFit/>
+          </a:bodyPr>
+          <a:lstStyle/>
+          <a:p>
+            <a:pPr algn="l"/>
+            <a:r>
+              <a:rPr sz="850" b="1" i="0">
+                <a:solidFill>
+                  <a:srgbClr val="1A73E8"/>
+                </a:solidFill>
+              </a:rPr>
+              <a:t>Temuan 17: Transfer Learning konsisten terbaik</a:t>
+            </a:r>
+          </a:p>
+        </p:txBody>
+      </p:sp>
+      <p:graphicFrame>
+        <p:nvGraphicFramePr>
+          <p:cNvPr id="6" name="Table 5"/>
+          <p:cNvGraphicFramePr>
+            <a:graphicFrameLocks noGrp="1"/>
+          </p:cNvGraphicFramePr>
+          <p:nvPr/>
+        </p:nvGraphicFramePr>
+        <p:xfrm>
+          <a:off x="4572000" y="987552"/>
+          <a:ext cx="4206240" cy="1005840"/>
+        </p:xfrm>
+        <a:graphic>
+          <a:graphicData uri="http://schemas.openxmlformats.org/drawingml/2006/table">
+            <a:tbl>
+              <a:tblPr firstRow="1" bandRow="1"/>
+              <a:tblGrid>
+                <a:gridCol w="2011680"/>
+                <a:gridCol w="2194560"/>
+              </a:tblGrid>
+              <a:tr h="201168">
+                <a:tc>
+                  <a:txBody>
+                    <a:bodyPr/>
+                    <a:lstStyle/>
+                    <a:p>
+                      <a:pPr algn="ctr"/>
+                      <a:r>
+                        <a:rPr sz="850" b="1">
+                          <a:solidFill>
+                            <a:srgbClr val="FFFFFF"/>
+                          </a:solidFill>
+                        </a:rPr>
+                        <a:t>Dataset</a:t>
+                      </a:r>
+                    </a:p>
+                  </a:txBody>
+                  <a:tcPr>
+                    <a:solidFill>
+                      <a:srgbClr val="1A73E8"/>
+                    </a:solidFill>
+                  </a:tcPr>
+                </a:tc>
+                <a:tc>
+                  <a:txBody>
+                    <a:bodyPr/>
+                    <a:lstStyle/>
+                    <a:p>
+                      <a:pPr algn="ctr"/>
+                      <a:r>
+                        <a:rPr sz="850" b="1">
+                          <a:solidFill>
+                            <a:srgbClr val="FFFFFF"/>
+                          </a:solidFill>
+                        </a:rPr>
+                        <a:t>Best Model</a:t>
+                      </a:r>
+                    </a:p>
+                  </a:txBody>
+                  <a:tcPr>
+                    <a:solidFill>
+                      <a:srgbClr val="1A73E8"/>
+                    </a:solidFill>
+                  </a:tcPr>
+                </a:tc>
+              </a:tr>
+              <a:tr h="201168">
+                <a:tc>
+                  <a:txBody>
+                    <a:bodyPr/>
+                    <a:lstStyle/>
+                    <a:p>
+                      <a:pPr algn="l"/>
+                      <a:r>
+                        <a:rPr sz="850" b="1">
+                          <a:solidFill>
+                            <a:srgbClr val="202020"/>
+                          </a:solidFill>
+                        </a:rPr>
+                        <a:t>CK+ 7c</a:t>
+                      </a:r>
+                    </a:p>
+                  </a:txBody>
+                  <a:tcPr>
+                    <a:solidFill>
+                      <a:srgbClr val="E8F0FE"/>
+                    </a:solidFill>
+                  </a:tcPr>
+                </a:tc>
+                <a:tc>
+                  <a:txBody>
+                    <a:bodyPr/>
+                    <a:lstStyle/>
+                    <a:p>
+                      <a:pPr algn="l"/>
+                      <a:r>
+                        <a:rPr sz="850" b="0">
+                          <a:solidFill>
+                            <a:srgbClr val="202020"/>
+                          </a:solidFill>
+                        </a:rPr>
+                        <a:t>Intermediate TL</a:t>
+                      </a:r>
+                    </a:p>
+                  </a:txBody>
+                  <a:tcPr>
+                    <a:solidFill>
+                      <a:srgbClr val="E8F0FE"/>
+                    </a:solidFill>
+                  </a:tcPr>
+                </a:tc>
+              </a:tr>
+              <a:tr h="201168">
+                <a:tc>
+                  <a:txBody>
+                    <a:bodyPr/>
+                    <a:lstStyle/>
+                    <a:p>
+                      <a:pPr algn="l"/>
+                      <a:r>
+                        <a:rPr sz="850" b="1">
+                          <a:solidFill>
+                            <a:srgbClr val="202020"/>
+                          </a:solidFill>
+                        </a:rPr>
+                        <a:t>CK+ 4c</a:t>
+                      </a:r>
+                    </a:p>
+                  </a:txBody>
+                  <a:tcPr>
+                    <a:solidFill>
+                      <a:srgbClr val="FFFFFF"/>
+                    </a:solidFill>
+                  </a:tcPr>
+                </a:tc>
+                <a:tc>
+                  <a:txBody>
+                    <a:bodyPr/>
+                    <a:lstStyle/>
+                    <a:p>
+                      <a:pPr algn="l"/>
+                      <a:r>
+                        <a:rPr sz="850" b="0">
+                          <a:solidFill>
+                            <a:srgbClr val="202020"/>
+                          </a:solidFill>
+                        </a:rPr>
+                        <a:t>CNN TL</a:t>
+                      </a:r>
+                    </a:p>
+                  </a:txBody>
+                  <a:tcPr>
+                    <a:solidFill>
+                      <a:srgbClr val="FFFFFF"/>
+                    </a:solidFill>
+                  </a:tcPr>
+                </a:tc>
+              </a:tr>
+              <a:tr h="201168">
+                <a:tc>
+                  <a:txBody>
+                    <a:bodyPr/>
+                    <a:lstStyle/>
+                    <a:p>
+                      <a:pPr algn="l"/>
+                      <a:r>
+                        <a:rPr sz="850" b="1">
+                          <a:solidFill>
+                            <a:srgbClr val="202020"/>
+                          </a:solidFill>
+                        </a:rPr>
+                        <a:t>JAFFE</a:t>
+                      </a:r>
+                    </a:p>
+                  </a:txBody>
+                  <a:tcPr>
+                    <a:solidFill>
+                      <a:srgbClr val="E8F0FE"/>
+                    </a:solidFill>
+                  </a:tcPr>
+                </a:tc>
+                <a:tc>
+                  <a:txBody>
+                    <a:bodyPr/>
+                    <a:lstStyle/>
+                    <a:p>
+                      <a:pPr algn="l"/>
+                      <a:r>
+                        <a:rPr sz="850" b="0">
+                          <a:solidFill>
+                            <a:srgbClr val="202020"/>
+                          </a:solidFill>
+                        </a:rPr>
+                        <a:t>Late Fusion (CNN+FCNN)</a:t>
+                      </a:r>
+                    </a:p>
+                  </a:txBody>
+                  <a:tcPr>
+                    <a:solidFill>
+                      <a:srgbClr val="E8F0FE"/>
+                    </a:solidFill>
+                  </a:tcPr>
+                </a:tc>
+              </a:tr>
+              <a:tr h="201168">
+                <a:tc>
+                  <a:txBody>
+                    <a:bodyPr/>
+                    <a:lstStyle/>
+                    <a:p>
+                      <a:pPr algn="l"/>
+                      <a:r>
+                        <a:rPr sz="850" b="1">
+                          <a:solidFill>
+                            <a:srgbClr val="202020"/>
+                          </a:solidFill>
+                        </a:rPr>
+                        <a:t>Dataset sendiri</a:t>
+                      </a:r>
+                    </a:p>
+                  </a:txBody>
+                  <a:tcPr>
+                    <a:solidFill>
+                      <a:srgbClr val="FFFFFF"/>
+                    </a:solidFill>
+                  </a:tcPr>
+                </a:tc>
+                <a:tc>
+                  <a:txBody>
+                    <a:bodyPr/>
+                    <a:lstStyle/>
+                    <a:p>
+                      <a:pPr algn="l"/>
+                      <a:r>
+                        <a:rPr sz="850" b="0">
+                          <a:solidFill>
+                            <a:srgbClr val="202020"/>
+                          </a:solidFill>
+                        </a:rPr>
+                        <a:t>Intermediate TL</a:t>
+                      </a:r>
+                    </a:p>
+                  </a:txBody>
+                  <a:tcPr>
+                    <a:solidFill>
+                      <a:srgbClr val="FFFFFF"/>
+                    </a:solidFill>
+                  </a:tcPr>
+                </a:tc>
+              </a:tr>
+            </a:tbl>
+          </a:graphicData>
+        </a:graphic>
+      </p:graphicFrame>
+      <p:sp>
+        <p:nvSpPr>
+          <p:cNvPr id="7" name="TextBox 6"/>
+          <p:cNvSpPr txBox="1"/>
+          <p:nvPr/>
+        </p:nvSpPr>
+        <p:spPr>
+          <a:xfrm>
+            <a:off x="274320" y="1965960"/>
+            <a:ext cx="4114800" cy="228600"/>
+          </a:xfrm>
+          <a:prstGeom prst="rect">
+            <a:avLst/>
+          </a:prstGeom>
+          <a:noFill/>
+        </p:spPr>
+        <p:txBody>
+          <a:bodyPr wrap="none">
+            <a:spAutoFit/>
+          </a:bodyPr>
+          <a:lstStyle/>
+          <a:p>
+            <a:pPr algn="l"/>
+            <a:r>
+              <a:rPr sz="850" b="1" i="0">
+                <a:solidFill>
+                  <a:srgbClr val="1A73E8"/>
+                </a:solidFill>
+              </a:rPr>
+              <a:t>Temuan 18: Dataset sendiri paling menantang</a:t>
+            </a:r>
+          </a:p>
+        </p:txBody>
+      </p:sp>
+      <p:sp>
+        <p:nvSpPr>
+          <p:cNvPr id="8" name="TextBox 7"/>
+          <p:cNvSpPr txBox="1"/>
+          <p:nvPr/>
+        </p:nvSpPr>
+        <p:spPr>
+          <a:xfrm>
+            <a:off x="274320" y="2240280"/>
+            <a:ext cx="4114800" cy="1005840"/>
+          </a:xfrm>
+          <a:prstGeom prst="rect">
+            <a:avLst/>
+          </a:prstGeom>
+          <a:solidFill>
+            <a:srgbClr val="FCE4E4"/>
+          </a:solidFill>
+        </p:spPr>
+        <p:txBody>
+          <a:bodyPr wrap="square">
+            <a:spAutoFit/>
+          </a:bodyPr>
+          <a:lstStyle/>
+          <a:p>
+            <a:pPr algn="l"/>
+            <a:r>
+              <a:rPr sz="900" b="1" i="0">
+                <a:solidFill>
+                  <a:srgbClr val="D93C3C"/>
+                </a:solidFill>
+              </a:rPr>
+              <a:t>Alasan performa rendah:</a:t>
+            </a:r>
+          </a:p>
+          <a:p>
+            <a:pPr algn="l"/>
+            <a:r>
+              <a:rPr sz="850" b="0" i="0">
+                <a:solidFill>
+                  <a:srgbClr val="202020"/>
+                </a:solidFill>
+              </a:rPr>
+              <a:t>1. Ekspresi natural (bukan lab-induced)</a:t>
+            </a:r>
+          </a:p>
+          <a:p>
+            <a:pPr algn="l"/>
+            <a:r>
+              <a:rPr sz="850" b="0" i="0">
+                <a:solidFill>
+                  <a:srgbClr val="202020"/>
+                </a:solidFill>
+              </a:rPr>
+              <a:t>2. Sangat imbalanced (neutral 82%)</a:t>
+            </a:r>
+          </a:p>
+          <a:p>
+            <a:pPr algn="l"/>
+            <a:r>
+              <a:rPr sz="850" b="0" i="0">
+                <a:solidFill>
+                  <a:srgbClr val="202020"/>
+                </a:solidFill>
+              </a:rPr>
+              <a:t>3. Variasi pencahayaan &amp; posisi</a:t>
+            </a:r>
+          </a:p>
+          <a:p>
+            <a:pPr algn="l"/>
+            <a:r>
+              <a:rPr sz="850" b="0" i="0">
+                <a:solidFill>
+                  <a:srgbClr val="202020"/>
+                </a:solidFill>
+              </a:rPr>
+              <a:t>4. Micro-expression saat programming</a:t>
+            </a:r>
+          </a:p>
+        </p:txBody>
+      </p:sp>
+      <p:sp>
+        <p:nvSpPr>
+          <p:cNvPr id="9" name="TextBox 8"/>
+          <p:cNvSpPr txBox="1"/>
+          <p:nvPr/>
+        </p:nvSpPr>
+        <p:spPr>
+          <a:xfrm>
+            <a:off x="4572000" y="1965960"/>
+            <a:ext cx="4206240" cy="228600"/>
+          </a:xfrm>
+          <a:prstGeom prst="rect">
+            <a:avLst/>
+          </a:prstGeom>
+          <a:noFill/>
+        </p:spPr>
+        <p:txBody>
+          <a:bodyPr wrap="none">
+            <a:spAutoFit/>
+          </a:bodyPr>
+          <a:lstStyle/>
+          <a:p>
+            <a:pPr algn="l"/>
+            <a:r>
+              <a:rPr sz="850" b="1" i="0">
+                <a:solidFill>
+                  <a:srgbClr val="1A73E8"/>
+                </a:solidFill>
+              </a:rPr>
+              <a:t>Temuan 19: Std deviation = stabilitas model</a:t>
+            </a:r>
+          </a:p>
+        </p:txBody>
+      </p:sp>
+      <p:graphicFrame>
+        <p:nvGraphicFramePr>
+          <p:cNvPr id="10" name="Table 9"/>
+          <p:cNvGraphicFramePr>
+            <a:graphicFrameLocks noGrp="1"/>
+          </p:cNvGraphicFramePr>
+          <p:nvPr/>
+        </p:nvGraphicFramePr>
+        <p:xfrm>
+          <a:off x="4572000" y="2240280"/>
+          <a:ext cx="4206240" cy="822960"/>
+        </p:xfrm>
+        <a:graphic>
+          <a:graphicData uri="http://schemas.openxmlformats.org/drawingml/2006/table">
+            <a:tbl>
+              <a:tblPr firstRow="1" bandRow="1"/>
+              <a:tblGrid>
+                <a:gridCol w="1645920"/>
+                <a:gridCol w="1097280"/>
+                <a:gridCol w="1463040"/>
+              </a:tblGrid>
+              <a:tr h="205740">
+                <a:tc>
+                  <a:txBody>
+                    <a:bodyPr/>
+                    <a:lstStyle/>
+                    <a:p>
+                      <a:pPr algn="ctr"/>
+                      <a:r>
+                        <a:rPr sz="850" b="1">
+                          <a:solidFill>
+                            <a:srgbClr val="FFFFFF"/>
+                          </a:solidFill>
+                        </a:rPr>
+                        <a:t>Dataset</a:t>
+                      </a:r>
+                    </a:p>
+                  </a:txBody>
+                  <a:tcPr>
+                    <a:solidFill>
+                      <a:srgbClr val="1A73E8"/>
+                    </a:solidFill>
+                  </a:tcPr>
+                </a:tc>
+                <a:tc>
+                  <a:txBody>
+                    <a:bodyPr/>
+                    <a:lstStyle/>
+                    <a:p>
+                      <a:pPr algn="ctr"/>
+                      <a:r>
+                        <a:rPr sz="850" b="1">
+                          <a:solidFill>
+                            <a:srgbClr val="FFFFFF"/>
+                          </a:solidFill>
+                        </a:rPr>
+                        <a:t>Best F1</a:t>
+                      </a:r>
+                    </a:p>
+                  </a:txBody>
+                  <a:tcPr>
+                    <a:solidFill>
+                      <a:srgbClr val="1A73E8"/>
+                    </a:solidFill>
+                  </a:tcPr>
+                </a:tc>
+                <a:tc>
+                  <a:txBody>
+                    <a:bodyPr/>
+                    <a:lstStyle/>
+                    <a:p>
+                      <a:pPr algn="ctr"/>
+                      <a:r>
+                        <a:rPr sz="850" b="1">
+                          <a:solidFill>
+                            <a:srgbClr val="FFFFFF"/>
+                          </a:solidFill>
+                        </a:rPr>
+                        <a:t>Std</a:t>
+                      </a:r>
+                    </a:p>
+                  </a:txBody>
+                  <a:tcPr>
+                    <a:solidFill>
+                      <a:srgbClr val="1A73E8"/>
+                    </a:solidFill>
+                  </a:tcPr>
+                </a:tc>
+              </a:tr>
+              <a:tr h="205740">
+                <a:tc>
+                  <a:txBody>
+                    <a:bodyPr/>
+                    <a:lstStyle/>
+                    <a:p>
+                      <a:pPr algn="l"/>
+                      <a:r>
+                        <a:rPr sz="850" b="1">
+                          <a:solidFill>
+                            <a:srgbClr val="202020"/>
+                          </a:solidFill>
+                        </a:rPr>
+                        <a:t>CK+</a:t>
+                      </a:r>
+                    </a:p>
+                  </a:txBody>
+                  <a:tcPr>
+                    <a:solidFill>
+                      <a:srgbClr val="E8F0FE"/>
+                    </a:solidFill>
+                  </a:tcPr>
+                </a:tc>
+                <a:tc>
+                  <a:txBody>
+                    <a:bodyPr/>
+                    <a:lstStyle/>
+                    <a:p>
+                      <a:pPr algn="l"/>
+                      <a:r>
+                        <a:rPr sz="850" b="0">
+                          <a:solidFill>
+                            <a:srgbClr val="202020"/>
+                          </a:solidFill>
+                        </a:rPr>
+                        <a:t>0.783</a:t>
+                      </a:r>
+                    </a:p>
+                  </a:txBody>
+                  <a:tcPr>
+                    <a:solidFill>
+                      <a:srgbClr val="E8F0FE"/>
+                    </a:solidFill>
+                  </a:tcPr>
+                </a:tc>
+                <a:tc>
+                  <a:txBody>
+                    <a:bodyPr/>
+                    <a:lstStyle/>
+                    <a:p>
+                      <a:pPr algn="ctr"/>
+                      <a:r>
+                        <a:rPr sz="850" b="0">
+                          <a:solidFill>
+                            <a:srgbClr val="202020"/>
+                          </a:solidFill>
+                        </a:rPr>
+                        <a:t>0.107 (stabil)</a:t>
+                      </a:r>
+                    </a:p>
+                  </a:txBody>
+                  <a:tcPr>
+                    <a:solidFill>
+                      <a:srgbClr val="E8F0FE"/>
+                    </a:solidFill>
+                  </a:tcPr>
+                </a:tc>
+              </a:tr>
+              <a:tr h="205740">
+                <a:tc>
+                  <a:txBody>
+                    <a:bodyPr/>
+                    <a:lstStyle/>
+                    <a:p>
+                      <a:pPr algn="l"/>
+                      <a:r>
+                        <a:rPr sz="850" b="1">
+                          <a:solidFill>
+                            <a:srgbClr val="202020"/>
+                          </a:solidFill>
+                        </a:rPr>
+                        <a:t>JAFFE</a:t>
+                      </a:r>
+                    </a:p>
+                  </a:txBody>
+                  <a:tcPr>
+                    <a:solidFill>
+                      <a:srgbClr val="FFFFFF"/>
+                    </a:solidFill>
+                  </a:tcPr>
+                </a:tc>
+                <a:tc>
+                  <a:txBody>
+                    <a:bodyPr/>
+                    <a:lstStyle/>
+                    <a:p>
+                      <a:pPr algn="l"/>
+                      <a:r>
+                        <a:rPr sz="850" b="0">
+                          <a:solidFill>
+                            <a:srgbClr val="202020"/>
+                          </a:solidFill>
+                        </a:rPr>
+                        <a:t>0.467</a:t>
+                      </a:r>
+                    </a:p>
+                  </a:txBody>
+                  <a:tcPr>
+                    <a:solidFill>
+                      <a:srgbClr val="FFFFFF"/>
+                    </a:solidFill>
+                  </a:tcPr>
+                </a:tc>
+                <a:tc>
+                  <a:txBody>
+                    <a:bodyPr/>
+                    <a:lstStyle/>
+                    <a:p>
+                      <a:pPr algn="ctr"/>
+                      <a:r>
+                        <a:rPr sz="850" b="0">
+                          <a:solidFill>
+                            <a:srgbClr val="202020"/>
+                          </a:solidFill>
+                        </a:rPr>
+                        <a:t>0.092 (moderat)</a:t>
+                      </a:r>
+                    </a:p>
+                  </a:txBody>
+                  <a:tcPr>
+                    <a:solidFill>
+                      <a:srgbClr val="FFFFFF"/>
+                    </a:solidFill>
+                  </a:tcPr>
+                </a:tc>
+              </a:tr>
+              <a:tr h="205740">
+                <a:tc>
+                  <a:txBody>
+                    <a:bodyPr/>
+                    <a:lstStyle/>
+                    <a:p>
+                      <a:pPr algn="l"/>
+                      <a:r>
+                        <a:rPr sz="850" b="1">
+                          <a:solidFill>
+                            <a:srgbClr val="202020"/>
+                          </a:solidFill>
+                        </a:rPr>
+                        <a:t>Dataset sendiri</a:t>
+                      </a:r>
+                    </a:p>
+                  </a:txBody>
+                  <a:tcPr>
+                    <a:solidFill>
+                      <a:srgbClr val="E8F0FE"/>
+                    </a:solidFill>
+                  </a:tcPr>
+                </a:tc>
+                <a:tc>
+                  <a:txBody>
+                    <a:bodyPr/>
+                    <a:lstStyle/>
+                    <a:p>
+                      <a:pPr algn="l"/>
+                      <a:r>
+                        <a:rPr sz="850" b="0">
+                          <a:solidFill>
+                            <a:srgbClr val="202020"/>
+                          </a:solidFill>
+                        </a:rPr>
+                        <a:t>0.370</a:t>
+                      </a:r>
+                    </a:p>
+                  </a:txBody>
+                  <a:tcPr>
+                    <a:solidFill>
+                      <a:srgbClr val="E8F0FE"/>
+                    </a:solidFill>
+                  </a:tcPr>
+                </a:tc>
+                <a:tc>
+                  <a:txBody>
+                    <a:bodyPr/>
+                    <a:lstStyle/>
+                    <a:p>
+                      <a:pPr algn="ctr"/>
+                      <a:r>
+                        <a:rPr sz="850" b="0">
+                          <a:solidFill>
+                            <a:srgbClr val="202020"/>
+                          </a:solidFill>
+                        </a:rPr>
+                        <a:t>0.125 (variabel)</a:t>
+                      </a:r>
+                    </a:p>
+                  </a:txBody>
+                  <a:tcPr>
+                    <a:solidFill>
+                      <a:srgbClr val="E8F0FE"/>
+                    </a:solidFill>
+                  </a:tcPr>
+                </a:tc>
+              </a:tr>
+            </a:tbl>
+          </a:graphicData>
+        </a:graphic>
+      </p:graphicFrame>
+      <p:sp>
+        <p:nvSpPr>
+          <p:cNvPr id="11" name="TextBox 10"/>
+          <p:cNvSpPr txBox="1"/>
+          <p:nvPr/>
+        </p:nvSpPr>
+        <p:spPr>
+          <a:xfrm>
+            <a:off x="274320" y="3383280"/>
+            <a:ext cx="8503920" cy="320040"/>
+          </a:xfrm>
+          <a:prstGeom prst="rect">
+            <a:avLst/>
+          </a:prstGeom>
+          <a:solidFill>
+            <a:srgbClr val="E8F0FE"/>
+          </a:solidFill>
+        </p:spPr>
+        <p:txBody>
+          <a:bodyPr wrap="square">
+            <a:spAutoFit/>
+          </a:bodyPr>
+          <a:lstStyle/>
+          <a:p>
+            <a:pPr algn="ctr"/>
+            <a:r>
+              <a:rPr sz="850" b="1" i="0">
+                <a:solidFill>
+                  <a:srgbClr val="202020"/>
+                </a:solidFill>
+              </a:rPr>
+              <a:t>Kesimpulan: Arsitektur bekerja baik di dataset standar (CK+ 0.783) -- performa rendah di dataset sendiri karena karakteristik data natural programming, bukan kelemahan arsitektur</a:t>
+            </a:r>
+          </a:p>
+        </p:txBody>
+      </p:sp>
+    </p:spTree>
+  </p:cSld>
+  <p:clrMapOvr>
+    <a:masterClrMapping/>
+  </p:clrMapOvr>
+</p:sld>
+</file>
+
 <file path=ppt/slides/slide11.xml><?xml version="1.0" encoding="utf-8"?>
 <p:sld xmlns:a="http://schemas.openxmlformats.org/drawingml/2006/main" xmlns:r="http://schemas.openxmlformats.org/officeDocument/2006/relationships" xmlns:mc="http://schemas.openxmlformats.org/markup-compatibility/2006" xmlns:mv="urn:schemas-microsoft-com:mac:vml" xmlns:p="http://schemas.openxmlformats.org/presentationml/2006/main" xmlns:c="http://schemas.openxmlformats.org/drawingml/2006/chart" xmlns:dgm="http://schemas.openxmlformats.org/drawingml/2006/diagram" xmlns:o="urn:schemas-microsoft-com:office:office" xmlns:v="urn:schemas-microsoft-com:vml" xmlns:pvml="urn:schemas-microsoft-com:office:powerpoint" xmlns:com="http://schemas.openxmlformats.org/drawingml/2006/compatibility" xmlns:p14="http://schemas.microsoft.com/office/powerpoint/2010/main" xmlns:p15="http://schemas.microsoft.com/office/powerpoint/2012/main" xmlns:ahyp="http://schemas.microsoft.com/office/drawing/2018/hyperlinkcolor">
   <p:cSld>
@@ -50074,6 +52336,795 @@
             </a:pPr>
             <a:r>
               <a:t>Terimakasih</a:t>
+            </a:r>
+          </a:p>
+        </p:txBody>
+      </p:sp>
+    </p:spTree>
+  </p:cSld>
+  <p:clrMapOvr>
+    <a:masterClrMapping/>
+  </p:clrMapOvr>
+</p:sld>
+</file>
+
+<file path=ppt/slides/slide99.xml><?xml version="1.0" encoding="utf-8"?>
+<p:sld xmlns:a="http://schemas.openxmlformats.org/drawingml/2006/main" xmlns:p="http://schemas.openxmlformats.org/presentationml/2006/main" xmlns:r="http://schemas.openxmlformats.org/officeDocument/2006/relationships">
+  <p:cSld>
+    <p:spTree>
+      <p:nvGrpSpPr>
+        <p:cNvPr id="1" name=""/>
+        <p:cNvGrpSpPr/>
+        <p:nvPr/>
+      </p:nvGrpSpPr>
+      <p:grpSpPr/>
+      <p:sp>
+        <p:nvSpPr>
+          <p:cNvPr id="2" name="TextBox 1"/>
+          <p:cNvSpPr txBox="1"/>
+          <p:nvPr/>
+        </p:nvSpPr>
+        <p:spPr>
+          <a:xfrm>
+            <a:off x="274320" y="109728"/>
+            <a:ext cx="8595360" cy="502920"/>
+          </a:xfrm>
+          <a:prstGeom prst="rect">
+            <a:avLst/>
+          </a:prstGeom>
+          <a:noFill/>
+        </p:spPr>
+        <p:txBody>
+          <a:bodyPr wrap="none">
+            <a:spAutoFit/>
+          </a:bodyPr>
+          <a:lstStyle/>
+          <a:p>
+            <a:pPr algn="l"/>
+            <a:r>
+              <a:rPr sz="1800" b="1" i="0">
+                <a:solidFill>
+                  <a:srgbClr val="202020"/>
+                </a:solidFill>
+              </a:rPr>
+              <a:t>Benchmark: JAFFE (LOSO) &amp; CK+ (10-Fold CV)</a:t>
+            </a:r>
+          </a:p>
+        </p:txBody>
+      </p:sp>
+      <p:sp>
+        <p:nvSpPr>
+          <p:cNvPr id="3" name="TextBox 2"/>
+          <p:cNvSpPr txBox="1"/>
+          <p:nvPr/>
+        </p:nvSpPr>
+        <p:spPr>
+          <a:xfrm>
+            <a:off x="274320" y="658368"/>
+            <a:ext cx="8595360" cy="228600"/>
+          </a:xfrm>
+          <a:prstGeom prst="rect">
+            <a:avLst/>
+          </a:prstGeom>
+          <a:noFill/>
+        </p:spPr>
+        <p:txBody>
+          <a:bodyPr wrap="none">
+            <a:spAutoFit/>
+          </a:bodyPr>
+          <a:lstStyle/>
+          <a:p>
+            <a:pPr algn="l"/>
+            <a:r>
+              <a:rPr sz="1000" b="1" i="0">
+                <a:solidFill>
+                  <a:srgbClr val="202020"/>
+                </a:solidFill>
+              </a:rPr>
+              <a:t>Best Model per Dataset (Macro F1)</a:t>
+            </a:r>
+          </a:p>
+        </p:txBody>
+      </p:sp>
+      <p:graphicFrame>
+        <p:nvGraphicFramePr>
+          <p:cNvPr id="4" name="Table 3"/>
+          <p:cNvGraphicFramePr>
+            <a:graphicFrameLocks noGrp="1"/>
+          </p:cNvGraphicFramePr>
+          <p:nvPr/>
+        </p:nvGraphicFramePr>
+        <p:xfrm>
+          <a:off x="274320" y="914400"/>
+          <a:ext cx="8595359" cy="2011680"/>
+        </p:xfrm>
+        <a:graphic>
+          <a:graphicData uri="http://schemas.openxmlformats.org/drawingml/2006/table">
+            <a:tbl>
+              <a:tblPr firstRow="1" bandRow="1"/>
+              <a:tblGrid>
+                <a:gridCol w="2455817"/>
+                <a:gridCol w="1674420"/>
+                <a:gridCol w="2232561"/>
+                <a:gridCol w="2232561"/>
+              </a:tblGrid>
+              <a:tr h="287382">
+                <a:tc>
+                  <a:txBody>
+                    <a:bodyPr/>
+                    <a:lstStyle/>
+                    <a:p>
+                      <a:pPr algn="ctr"/>
+                      <a:r>
+                        <a:rPr sz="950" b="1">
+                          <a:solidFill>
+                            <a:srgbClr val="FFFFFF"/>
+                          </a:solidFill>
+                        </a:rPr>
+                        <a:t>Dataset</a:t>
+                      </a:r>
+                    </a:p>
+                  </a:txBody>
+                  <a:tcPr>
+                    <a:solidFill>
+                      <a:srgbClr val="1A73E8"/>
+                    </a:solidFill>
+                  </a:tcPr>
+                </a:tc>
+                <a:tc>
+                  <a:txBody>
+                    <a:bodyPr/>
+                    <a:lstStyle/>
+                    <a:p>
+                      <a:pPr algn="ctr"/>
+                      <a:r>
+                        <a:rPr sz="950" b="1">
+                          <a:solidFill>
+                            <a:srgbClr val="FFFFFF"/>
+                          </a:solidFill>
+                        </a:rPr>
+                        <a:t>Evaluasi</a:t>
+                      </a:r>
+                    </a:p>
+                  </a:txBody>
+                  <a:tcPr>
+                    <a:solidFill>
+                      <a:srgbClr val="1A73E8"/>
+                    </a:solidFill>
+                  </a:tcPr>
+                </a:tc>
+                <a:tc>
+                  <a:txBody>
+                    <a:bodyPr/>
+                    <a:lstStyle/>
+                    <a:p>
+                      <a:pPr algn="ctr"/>
+                      <a:r>
+                        <a:rPr sz="950" b="1">
+                          <a:solidFill>
+                            <a:srgbClr val="FFFFFF"/>
+                          </a:solidFill>
+                        </a:rPr>
+                        <a:t>Best Model</a:t>
+                      </a:r>
+                    </a:p>
+                  </a:txBody>
+                  <a:tcPr>
+                    <a:solidFill>
+                      <a:srgbClr val="1A73E8"/>
+                    </a:solidFill>
+                  </a:tcPr>
+                </a:tc>
+                <a:tc>
+                  <a:txBody>
+                    <a:bodyPr/>
+                    <a:lstStyle/>
+                    <a:p>
+                      <a:pPr algn="ctr"/>
+                      <a:r>
+                        <a:rPr sz="950" b="1">
+                          <a:solidFill>
+                            <a:srgbClr val="FFFFFF"/>
+                          </a:solidFill>
+                        </a:rPr>
+                        <a:t>Macro F1</a:t>
+                      </a:r>
+                    </a:p>
+                  </a:txBody>
+                  <a:tcPr>
+                    <a:solidFill>
+                      <a:srgbClr val="1A73E8"/>
+                    </a:solidFill>
+                  </a:tcPr>
+                </a:tc>
+              </a:tr>
+              <a:tr h="287382">
+                <a:tc>
+                  <a:txBody>
+                    <a:bodyPr/>
+                    <a:lstStyle/>
+                    <a:p>
+                      <a:pPr algn="l"/>
+                      <a:r>
+                        <a:rPr sz="950" b="1">
+                          <a:solidFill>
+                            <a:srgbClr val="202020"/>
+                          </a:solidFill>
+                        </a:rPr>
+                        <a:t>CK+ 7-class</a:t>
+                      </a:r>
+                    </a:p>
+                  </a:txBody>
+                  <a:tcPr>
+                    <a:solidFill>
+                      <a:srgbClr val="C6EFCE"/>
+                    </a:solidFill>
+                  </a:tcPr>
+                </a:tc>
+                <a:tc>
+                  <a:txBody>
+                    <a:bodyPr/>
+                    <a:lstStyle/>
+                    <a:p>
+                      <a:pPr algn="l"/>
+                      <a:r>
+                        <a:rPr sz="950" b="1">
+                          <a:solidFill>
+                            <a:srgbClr val="202020"/>
+                          </a:solidFill>
+                        </a:rPr>
+                        <a:t>10-Fold CV</a:t>
+                      </a:r>
+                    </a:p>
+                  </a:txBody>
+                  <a:tcPr>
+                    <a:solidFill>
+                      <a:srgbClr val="C6EFCE"/>
+                    </a:solidFill>
+                  </a:tcPr>
+                </a:tc>
+                <a:tc>
+                  <a:txBody>
+                    <a:bodyPr/>
+                    <a:lstStyle/>
+                    <a:p>
+                      <a:pPr algn="ctr"/>
+                      <a:r>
+                        <a:rPr sz="950" b="1">
+                          <a:solidFill>
+                            <a:srgbClr val="202020"/>
+                          </a:solidFill>
+                        </a:rPr>
+                        <a:t>Intermediate TL</a:t>
+                      </a:r>
+                    </a:p>
+                  </a:txBody>
+                  <a:tcPr>
+                    <a:solidFill>
+                      <a:srgbClr val="C6EFCE"/>
+                    </a:solidFill>
+                  </a:tcPr>
+                </a:tc>
+                <a:tc>
+                  <a:txBody>
+                    <a:bodyPr/>
+                    <a:lstStyle/>
+                    <a:p>
+                      <a:pPr algn="ctr"/>
+                      <a:r>
+                        <a:rPr sz="950" b="1">
+                          <a:solidFill>
+                            <a:srgbClr val="202020"/>
+                          </a:solidFill>
+                        </a:rPr>
+                        <a:t>0.783 +/- 0.107</a:t>
+                      </a:r>
+                    </a:p>
+                  </a:txBody>
+                  <a:tcPr>
+                    <a:solidFill>
+                      <a:srgbClr val="C6EFCE"/>
+                    </a:solidFill>
+                  </a:tcPr>
+                </a:tc>
+              </a:tr>
+              <a:tr h="287382">
+                <a:tc>
+                  <a:txBody>
+                    <a:bodyPr/>
+                    <a:lstStyle/>
+                    <a:p>
+                      <a:pPr algn="l"/>
+                      <a:r>
+                        <a:rPr sz="950" b="1">
+                          <a:solidFill>
+                            <a:srgbClr val="202020"/>
+                          </a:solidFill>
+                        </a:rPr>
+                        <a:t>CK+ 4-class</a:t>
+                      </a:r>
+                    </a:p>
+                  </a:txBody>
+                  <a:tcPr>
+                    <a:solidFill>
+                      <a:srgbClr val="FFFFFF"/>
+                    </a:solidFill>
+                  </a:tcPr>
+                </a:tc>
+                <a:tc>
+                  <a:txBody>
+                    <a:bodyPr/>
+                    <a:lstStyle/>
+                    <a:p>
+                      <a:pPr algn="l"/>
+                      <a:r>
+                        <a:rPr sz="950" b="0">
+                          <a:solidFill>
+                            <a:srgbClr val="202020"/>
+                          </a:solidFill>
+                        </a:rPr>
+                        <a:t>10-Fold CV</a:t>
+                      </a:r>
+                    </a:p>
+                  </a:txBody>
+                  <a:tcPr>
+                    <a:solidFill>
+                      <a:srgbClr val="FFFFFF"/>
+                    </a:solidFill>
+                  </a:tcPr>
+                </a:tc>
+                <a:tc>
+                  <a:txBody>
+                    <a:bodyPr/>
+                    <a:lstStyle/>
+                    <a:p>
+                      <a:pPr algn="ctr"/>
+                      <a:r>
+                        <a:rPr sz="950" b="0">
+                          <a:solidFill>
+                            <a:srgbClr val="202020"/>
+                          </a:solidFill>
+                        </a:rPr>
+                        <a:t>CNN TL</a:t>
+                      </a:r>
+                    </a:p>
+                  </a:txBody>
+                  <a:tcPr>
+                    <a:solidFill>
+                      <a:srgbClr val="FFFFFF"/>
+                    </a:solidFill>
+                  </a:tcPr>
+                </a:tc>
+                <a:tc>
+                  <a:txBody>
+                    <a:bodyPr/>
+                    <a:lstStyle/>
+                    <a:p>
+                      <a:pPr algn="ctr"/>
+                      <a:r>
+                        <a:rPr sz="950" b="0">
+                          <a:solidFill>
+                            <a:srgbClr val="202020"/>
+                          </a:solidFill>
+                        </a:rPr>
+                        <a:t>0.755 +/- 0.079</a:t>
+                      </a:r>
+                    </a:p>
+                  </a:txBody>
+                  <a:tcPr>
+                    <a:solidFill>
+                      <a:srgbClr val="FFFFFF"/>
+                    </a:solidFill>
+                  </a:tcPr>
+                </a:tc>
+              </a:tr>
+              <a:tr h="287382">
+                <a:tc>
+                  <a:txBody>
+                    <a:bodyPr/>
+                    <a:lstStyle/>
+                    <a:p>
+                      <a:pPr algn="l"/>
+                      <a:r>
+                        <a:rPr sz="950" b="1">
+                          <a:solidFill>
+                            <a:srgbClr val="202020"/>
+                          </a:solidFill>
+                        </a:rPr>
+                        <a:t>JAFFE 7-class</a:t>
+                      </a:r>
+                    </a:p>
+                  </a:txBody>
+                  <a:tcPr>
+                    <a:solidFill>
+                      <a:srgbClr val="E8F0FE"/>
+                    </a:solidFill>
+                  </a:tcPr>
+                </a:tc>
+                <a:tc>
+                  <a:txBody>
+                    <a:bodyPr/>
+                    <a:lstStyle/>
+                    <a:p>
+                      <a:pPr algn="l"/>
+                      <a:r>
+                        <a:rPr sz="950" b="0">
+                          <a:solidFill>
+                            <a:srgbClr val="202020"/>
+                          </a:solidFill>
+                        </a:rPr>
+                        <a:t>LOSO (10)</a:t>
+                      </a:r>
+                    </a:p>
+                  </a:txBody>
+                  <a:tcPr>
+                    <a:solidFill>
+                      <a:srgbClr val="E8F0FE"/>
+                    </a:solidFill>
+                  </a:tcPr>
+                </a:tc>
+                <a:tc>
+                  <a:txBody>
+                    <a:bodyPr/>
+                    <a:lstStyle/>
+                    <a:p>
+                      <a:pPr algn="ctr"/>
+                      <a:r>
+                        <a:rPr sz="950" b="0">
+                          <a:solidFill>
+                            <a:srgbClr val="202020"/>
+                          </a:solidFill>
+                        </a:rPr>
+                        <a:t>Late Fusion</a:t>
+                      </a:r>
+                    </a:p>
+                  </a:txBody>
+                  <a:tcPr>
+                    <a:solidFill>
+                      <a:srgbClr val="E8F0FE"/>
+                    </a:solidFill>
+                  </a:tcPr>
+                </a:tc>
+                <a:tc>
+                  <a:txBody>
+                    <a:bodyPr/>
+                    <a:lstStyle/>
+                    <a:p>
+                      <a:pPr algn="ctr"/>
+                      <a:r>
+                        <a:rPr sz="950" b="0">
+                          <a:solidFill>
+                            <a:srgbClr val="202020"/>
+                          </a:solidFill>
+                        </a:rPr>
+                        <a:t>0.467 +/- 0.092</a:t>
+                      </a:r>
+                    </a:p>
+                  </a:txBody>
+                  <a:tcPr>
+                    <a:solidFill>
+                      <a:srgbClr val="E8F0FE"/>
+                    </a:solidFill>
+                  </a:tcPr>
+                </a:tc>
+              </a:tr>
+              <a:tr h="287382">
+                <a:tc>
+                  <a:txBody>
+                    <a:bodyPr/>
+                    <a:lstStyle/>
+                    <a:p>
+                      <a:pPr algn="l"/>
+                      <a:r>
+                        <a:rPr sz="950" b="1">
+                          <a:solidFill>
+                            <a:srgbClr val="202020"/>
+                          </a:solidFill>
+                        </a:rPr>
+                        <a:t>JAFFE 4-class</a:t>
+                      </a:r>
+                    </a:p>
+                  </a:txBody>
+                  <a:tcPr>
+                    <a:solidFill>
+                      <a:srgbClr val="FFFFFF"/>
+                    </a:solidFill>
+                  </a:tcPr>
+                </a:tc>
+                <a:tc>
+                  <a:txBody>
+                    <a:bodyPr/>
+                    <a:lstStyle/>
+                    <a:p>
+                      <a:pPr algn="l"/>
+                      <a:r>
+                        <a:rPr sz="950" b="0">
+                          <a:solidFill>
+                            <a:srgbClr val="202020"/>
+                          </a:solidFill>
+                        </a:rPr>
+                        <a:t>LOSO (10)</a:t>
+                      </a:r>
+                    </a:p>
+                  </a:txBody>
+                  <a:tcPr>
+                    <a:solidFill>
+                      <a:srgbClr val="FFFFFF"/>
+                    </a:solidFill>
+                  </a:tcPr>
+                </a:tc>
+                <a:tc>
+                  <a:txBody>
+                    <a:bodyPr/>
+                    <a:lstStyle/>
+                    <a:p>
+                      <a:pPr algn="ctr"/>
+                      <a:r>
+                        <a:rPr sz="950" b="0">
+                          <a:solidFill>
+                            <a:srgbClr val="202020"/>
+                          </a:solidFill>
+                        </a:rPr>
+                        <a:t>Late Fusion</a:t>
+                      </a:r>
+                    </a:p>
+                  </a:txBody>
+                  <a:tcPr>
+                    <a:solidFill>
+                      <a:srgbClr val="FFFFFF"/>
+                    </a:solidFill>
+                  </a:tcPr>
+                </a:tc>
+                <a:tc>
+                  <a:txBody>
+                    <a:bodyPr/>
+                    <a:lstStyle/>
+                    <a:p>
+                      <a:pPr algn="ctr"/>
+                      <a:r>
+                        <a:rPr sz="950" b="0">
+                          <a:solidFill>
+                            <a:srgbClr val="202020"/>
+                          </a:solidFill>
+                        </a:rPr>
+                        <a:t>0.530 +/- 0.126</a:t>
+                      </a:r>
+                    </a:p>
+                  </a:txBody>
+                  <a:tcPr>
+                    <a:solidFill>
+                      <a:srgbClr val="FFFFFF"/>
+                    </a:solidFill>
+                  </a:tcPr>
+                </a:tc>
+              </a:tr>
+              <a:tr h="287382">
+                <a:tc>
+                  <a:txBody>
+                    <a:bodyPr/>
+                    <a:lstStyle/>
+                    <a:p>
+                      <a:pPr algn="l"/>
+                      <a:r>
+                        <a:rPr sz="950" b="1">
+                          <a:solidFill>
+                            <a:srgbClr val="202020"/>
+                          </a:solidFill>
+                        </a:rPr>
+                        <a:t>Dataset sendiri 4c</a:t>
+                      </a:r>
+                    </a:p>
+                  </a:txBody>
+                  <a:tcPr>
+                    <a:solidFill>
+                      <a:srgbClr val="E8F0FE"/>
+                    </a:solidFill>
+                  </a:tcPr>
+                </a:tc>
+                <a:tc>
+                  <a:txBody>
+                    <a:bodyPr/>
+                    <a:lstStyle/>
+                    <a:p>
+                      <a:pPr algn="l"/>
+                      <a:r>
+                        <a:rPr sz="950" b="0">
+                          <a:solidFill>
+                            <a:srgbClr val="202020"/>
+                          </a:solidFill>
+                        </a:rPr>
+                        <a:t>5-Fold CV</a:t>
+                      </a:r>
+                    </a:p>
+                  </a:txBody>
+                  <a:tcPr>
+                    <a:solidFill>
+                      <a:srgbClr val="E8F0FE"/>
+                    </a:solidFill>
+                  </a:tcPr>
+                </a:tc>
+                <a:tc>
+                  <a:txBody>
+                    <a:bodyPr/>
+                    <a:lstStyle/>
+                    <a:p>
+                      <a:pPr algn="ctr"/>
+                      <a:r>
+                        <a:rPr sz="950" b="0">
+                          <a:solidFill>
+                            <a:srgbClr val="202020"/>
+                          </a:solidFill>
+                        </a:rPr>
+                        <a:t>Intermediate TL</a:t>
+                      </a:r>
+                    </a:p>
+                  </a:txBody>
+                  <a:tcPr>
+                    <a:solidFill>
+                      <a:srgbClr val="E8F0FE"/>
+                    </a:solidFill>
+                  </a:tcPr>
+                </a:tc>
+                <a:tc>
+                  <a:txBody>
+                    <a:bodyPr/>
+                    <a:lstStyle/>
+                    <a:p>
+                      <a:pPr algn="ctr"/>
+                      <a:r>
+                        <a:rPr sz="950" b="0">
+                          <a:solidFill>
+                            <a:srgbClr val="202020"/>
+                          </a:solidFill>
+                        </a:rPr>
+                        <a:t>0.435 +/- 0.068</a:t>
+                      </a:r>
+                    </a:p>
+                  </a:txBody>
+                  <a:tcPr>
+                    <a:solidFill>
+                      <a:srgbClr val="E8F0FE"/>
+                    </a:solidFill>
+                  </a:tcPr>
+                </a:tc>
+              </a:tr>
+              <a:tr h="287388">
+                <a:tc>
+                  <a:txBody>
+                    <a:bodyPr/>
+                    <a:lstStyle/>
+                    <a:p>
+                      <a:pPr algn="l"/>
+                      <a:r>
+                        <a:rPr sz="950" b="1">
+                          <a:solidFill>
+                            <a:srgbClr val="202020"/>
+                          </a:solidFill>
+                        </a:rPr>
+                        <a:t>Dataset sendiri 4c</a:t>
+                      </a:r>
+                    </a:p>
+                  </a:txBody>
+                  <a:tcPr>
+                    <a:solidFill>
+                      <a:srgbClr val="FFFFFF"/>
+                    </a:solidFill>
+                  </a:tcPr>
+                </a:tc>
+                <a:tc>
+                  <a:txBody>
+                    <a:bodyPr/>
+                    <a:lstStyle/>
+                    <a:p>
+                      <a:pPr algn="l"/>
+                      <a:r>
+                        <a:rPr sz="950" b="0">
+                          <a:solidFill>
+                            <a:srgbClr val="202020"/>
+                          </a:solidFill>
+                        </a:rPr>
+                        <a:t>LOSO (37)</a:t>
+                      </a:r>
+                    </a:p>
+                  </a:txBody>
+                  <a:tcPr>
+                    <a:solidFill>
+                      <a:srgbClr val="FFFFFF"/>
+                    </a:solidFill>
+                  </a:tcPr>
+                </a:tc>
+                <a:tc>
+                  <a:txBody>
+                    <a:bodyPr/>
+                    <a:lstStyle/>
+                    <a:p>
+                      <a:pPr algn="ctr"/>
+                      <a:r>
+                        <a:rPr sz="950" b="0">
+                          <a:solidFill>
+                            <a:srgbClr val="202020"/>
+                          </a:solidFill>
+                        </a:rPr>
+                        <a:t>Intermediate TL</a:t>
+                      </a:r>
+                    </a:p>
+                  </a:txBody>
+                  <a:tcPr>
+                    <a:solidFill>
+                      <a:srgbClr val="FFFFFF"/>
+                    </a:solidFill>
+                  </a:tcPr>
+                </a:tc>
+                <a:tc>
+                  <a:txBody>
+                    <a:bodyPr/>
+                    <a:lstStyle/>
+                    <a:p>
+                      <a:pPr algn="ctr"/>
+                      <a:r>
+                        <a:rPr sz="950" b="0">
+                          <a:solidFill>
+                            <a:srgbClr val="202020"/>
+                          </a:solidFill>
+                        </a:rPr>
+                        <a:t>0.370 +/- 0.125</a:t>
+                      </a:r>
+                    </a:p>
+                  </a:txBody>
+                  <a:tcPr>
+                    <a:solidFill>
+                      <a:srgbClr val="FFFFFF"/>
+                    </a:solidFill>
+                  </a:tcPr>
+                </a:tc>
+              </a:tr>
+            </a:tbl>
+          </a:graphicData>
+        </a:graphic>
+      </p:graphicFrame>
+      <p:sp>
+        <p:nvSpPr>
+          <p:cNvPr id="5" name="TextBox 4"/>
+          <p:cNvSpPr txBox="1"/>
+          <p:nvPr/>
+        </p:nvSpPr>
+        <p:spPr>
+          <a:xfrm>
+            <a:off x="274320" y="3063240"/>
+            <a:ext cx="8595360" cy="502920"/>
+          </a:xfrm>
+          <a:prstGeom prst="rect">
+            <a:avLst/>
+          </a:prstGeom>
+          <a:solidFill>
+            <a:srgbClr val="E8F0FE"/>
+          </a:solidFill>
+        </p:spPr>
+        <p:txBody>
+          <a:bodyPr wrap="square">
+            <a:spAutoFit/>
+          </a:bodyPr>
+          <a:lstStyle/>
+          <a:p>
+            <a:pPr algn="ctr"/>
+            <a:r>
+              <a:rPr sz="1000" b="1" i="0">
+                <a:solidFill>
+                  <a:srgbClr val="202020"/>
+                </a:solidFill>
+              </a:rPr>
+              <a:t>Pola: CK+ (0.783) &gt;&gt; JAFFE (0.467) &gt; Dataset sendiri (0.370)</a:t>
+            </a:r>
+          </a:p>
+          <a:p>
+            <a:pPr algn="ctr"/>
+            <a:r>
+              <a:rPr sz="900" b="0" i="0">
+                <a:solidFill>
+                  <a:srgbClr val="666666"/>
+                </a:solidFill>
+              </a:rPr>
+              <a:t>Semakin natural ekspresinya dan semakin imbalanced, semakin rendah performanya</a:t>
             </a:r>
           </a:p>
         </p:txBody>

</xml_diff>

<commit_message>
Expand SOTA comparison note in slide 103 with full disclaimer
4 points: larger architectures, random split vs subject-wise,
simpler ResNet18 + stricter evaluation, accuracy vs Macro F1

Co-Authored-By: Claude Opus 4.6 (1M context) <noreply@anthropic.com>
</commit_message>
<xml_diff>
--- a/docs/PPT Bimbingan.pptx
+++ b/docs/PPT Bimbingan.pptx
@@ -14996,7 +14996,7 @@
         <p:spPr>
           <a:xfrm>
             <a:off x="274320" y="4160520"/>
-            <a:ext cx="8595360" cy="320040"/>
+            <a:ext cx="8595360" cy="685800"/>
           </a:xfrm>
           <a:prstGeom prst="rect">
             <a:avLst/>
@@ -15011,12 +15011,56 @@
           <a:p>
             <a:pPr algn="l"/>
             <a:r>
-              <a:rPr sz="750" b="0" i="1">
+              <a:rPr sz="800" b="1">
                 <a:solidFill>
                   <a:srgbClr val="666666"/>
                 </a:solidFill>
               </a:rPr>
-              <a:t>Catatan: Paper SOTA pakai arsitektur lebih besar (VGG/EfficientNet), sebagian random split. Penelitian ini pakai ResNet18 + subject-wise CV/LOSO yang lebih ketat.</a:t>
+              <a:t>Catatan: Perbandingan tidak sepenuhnya apple-to-apple karena:</a:t>
+            </a:r>
+          </a:p>
+          <a:p>
+            <a:pPr algn="l"/>
+            <a:r>
+              <a:rPr sz="750" i="1">
+                <a:solidFill>
+                  <a:srgbClr val="666666"/>
+                </a:solidFill>
+              </a:rPr>
+              <a:t>- Paper SOTA umumnya pakai arsitektur lebih besar (VGG16, EfficientNet, ViT)</a:t>
+            </a:r>
+          </a:p>
+          <a:p>
+            <a:pPr algn="l"/>
+            <a:r>
+              <a:rPr sz="750" i="1">
+                <a:solidFill>
+                  <a:srgbClr val="666666"/>
+                </a:solidFill>
+              </a:rPr>
+              <a:t>- Sebagian paper pakai random split (data leakage), bukan subject-wise</a:t>
+            </a:r>
+          </a:p>
+          <a:p>
+            <a:pPr algn="l"/>
+            <a:r>
+              <a:rPr sz="750" i="1">
+                <a:solidFill>
+                  <a:srgbClr val="666666"/>
+                </a:solidFill>
+              </a:rPr>
+              <a:t>- Penelitian ini pakai arsitektur sederhana (ResNet18) + subject-wise CV/LOSO yang lebih ketat</a:t>
+            </a:r>
+          </a:p>
+          <a:p>
+            <a:pPr algn="l"/>
+            <a:r>
+              <a:rPr sz="750" i="1">
+                <a:solidFill>
+                  <a:srgbClr val="666666"/>
+                </a:solidFill>
+              </a:rPr>
+              <a:t>- Metrik berbeda: paper lain lapor accuracy, penelitian ini fokus Macro F1 (lebih jujur untuk imbalanced)</a:t>
             </a:r>
           </a:p>
         </p:txBody>

</xml_diff>

<commit_message>
Add subject-wise vs random split argument to SOTA comparison
Paper SOTA (99%+) likely use random split with data leakage.
Our subject-wise evaluation is stricter but more valid.
Proven: random split inflates results +30-47% on own dataset.

Co-Authored-By: Claude Opus 4.6 (1M context) <noreply@anthropic.com>
</commit_message>
<xml_diff>
--- a/docs/PPT Bimbingan.pptx
+++ b/docs/PPT Bimbingan.pptx
@@ -14996,7 +14996,7 @@
         <p:spPr>
           <a:xfrm>
             <a:off x="274320" y="4160520"/>
-            <a:ext cx="8595360" cy="685800"/>
+            <a:ext cx="8595360" cy="914400"/>
           </a:xfrm>
           <a:prstGeom prst="rect">
             <a:avLst/>
@@ -15011,12 +15011,35 @@
           <a:p>
             <a:pPr algn="l"/>
             <a:r>
-              <a:rPr sz="800" b="1">
+              <a:rPr sz="850" b="1">
                 <a:solidFill>
                   <a:srgbClr val="666666"/>
                 </a:solidFill>
               </a:rPr>
-              <a:t>Catatan: Perbandingan tidak sepenuhnya apple-to-apple karena:</a:t>
+              <a:t>Catatan Penting:</a:t>
+            </a:r>
+          </a:p>
+          <a:p>
+            <a:pPr algn="l"/>
+          </a:p>
+          <a:p>
+            <a:pPr algn="l"/>
+          </a:p>
+          <a:p>
+            <a:pPr algn="l"/>
+          </a:p>
+          <a:p>
+            <a:pPr algn="l"/>
+          </a:p>
+          <a:p>
+            <a:pPr algn="l"/>
+            <a:r>
+              <a:rPr sz="750" i="1">
+                <a:solidFill>
+                  <a:srgbClr val="666666"/>
+                </a:solidFill>
+              </a:rPr>
+              <a:t>- Paper SOTA (99%+) kemungkinan besar pakai random split (data leakage) -- bukan subject-wise</a:t>
             </a:r>
           </a:p>
           <a:p>
@@ -15027,7 +15050,7 @@
                   <a:srgbClr val="666666"/>
                 </a:solidFill>
               </a:rPr>
-              <a:t>- Paper SOTA umumnya pakai arsitektur lebih besar (VGG16, EfficientNet, ViT)</a:t>
+              <a:t>- Penelitian ini pakai subject-wise CV/LOSO yang lebih ketat -- hasil lebih rendah tapi lebih valid</a:t>
             </a:r>
           </a:p>
           <a:p>
@@ -15038,7 +15061,7 @@
                   <a:srgbClr val="666666"/>
                 </a:solidFill>
               </a:rPr>
-              <a:t>- Sebagian paper pakai random split (data leakage), bukan subject-wise</a:t>
+              <a:t>- Paper SOTA pakai arsitektur besar (VGG16, EfficientNet, ViT) vs penelitian ini ResNet18 sederhana</a:t>
             </a:r>
           </a:p>
           <a:p>
@@ -15049,7 +15072,7 @@
                   <a:srgbClr val="666666"/>
                 </a:solidFill>
               </a:rPr>
-              <a:t>- Penelitian ini pakai arsitektur sederhana (ResNet18) + subject-wise CV/LOSO yang lebih ketat</a:t>
+              <a:t>- Metrik: paper lain lapor accuracy, penelitian ini fokus Macro F1 (lebih jujur untuk imbalanced)</a:t>
             </a:r>
           </a:p>
           <a:p>
@@ -15060,7 +15083,7 @@
                   <a:srgbClr val="666666"/>
                 </a:solidFill>
               </a:rPr>
-              <a:t>- Metrik berbeda: paper lain lapor accuracy, penelitian ini fokus Macro F1 (lebih jujur untuk imbalanced)</a:t>
+              <a:t>- Bukti: di dataset sendiri, random split naik +30-47% vs subject-wise -- angka SOTA bisa inflate serupa</a:t>
             </a:r>
           </a:p>
         </p:txBody>

</xml_diff>

<commit_message>
Add validation progress slide (slide 105)
- Status table: 1 validator active, 2 awaiting recommendation from Pak Fitra
- Tool info: Streamlit link, 128 samples, ~30-45 min
- Questions for supervisor: validator recommendations, honorarium

Co-Authored-By: Claude Opus 4.6 (1M context) <noreply@anthropic.com>
</commit_message>
<xml_diff>
--- a/docs/PPT Bimbingan.pptx
+++ b/docs/PPT Bimbingan.pptx
@@ -112,6 +112,7 @@
     <p:sldId id="355" r:id="rId105"/>
     <p:sldId id="356" r:id="rId106"/>
     <p:sldId id="357" r:id="rId107"/>
+    <p:sldId id="363" r:id="rId113"/>
     <p:sldId id="337" r:id="rId87"/>
     <p:sldId id="338" r:id="rId65"/>
   </p:sldIdLst>
@@ -16939,6 +16940,712 @@
 </p:sld>
 </file>
 
+<file path=ppt/slides/slide107.xml><?xml version="1.0" encoding="utf-8"?>
+<p:sld xmlns:a="http://schemas.openxmlformats.org/drawingml/2006/main" xmlns:p="http://schemas.openxmlformats.org/presentationml/2006/main" xmlns:r="http://schemas.openxmlformats.org/officeDocument/2006/relationships">
+  <p:cSld>
+    <p:spTree>
+      <p:nvGrpSpPr>
+        <p:cNvPr id="1" name=""/>
+        <p:cNvGrpSpPr/>
+        <p:nvPr/>
+      </p:nvGrpSpPr>
+      <p:grpSpPr/>
+      <p:sp>
+        <p:nvSpPr>
+          <p:cNvPr id="2" name="TextBox 1"/>
+          <p:cNvSpPr txBox="1"/>
+          <p:nvPr/>
+        </p:nvSpPr>
+        <p:spPr>
+          <a:xfrm>
+            <a:off x="274320" y="109728"/>
+            <a:ext cx="8595360" cy="502920"/>
+          </a:xfrm>
+          <a:prstGeom prst="rect">
+            <a:avLst/>
+          </a:prstGeom>
+          <a:noFill/>
+        </p:spPr>
+        <p:txBody>
+          <a:bodyPr wrap="none">
+            <a:spAutoFit/>
+          </a:bodyPr>
+          <a:lstStyle/>
+          <a:p>
+            <a:pPr algn="l"/>
+            <a:r>
+              <a:rPr sz="2000" b="1" i="0">
+                <a:solidFill>
+                  <a:srgbClr val="202020"/>
+                </a:solidFill>
+              </a:rPr>
+              <a:t>Progress Validasi Ahli Psikologi</a:t>
+            </a:r>
+          </a:p>
+        </p:txBody>
+      </p:sp>
+      <p:sp>
+        <p:nvSpPr>
+          <p:cNvPr id="3" name="TextBox 2"/>
+          <p:cNvSpPr txBox="1"/>
+          <p:nvPr/>
+        </p:nvSpPr>
+        <p:spPr>
+          <a:xfrm>
+            <a:off x="274320" y="713232"/>
+            <a:ext cx="8595360" cy="640080"/>
+          </a:xfrm>
+          <a:prstGeom prst="rect">
+            <a:avLst/>
+          </a:prstGeom>
+          <a:solidFill>
+            <a:srgbClr val="E8F0FE"/>
+          </a:solidFill>
+        </p:spPr>
+        <p:txBody>
+          <a:bodyPr wrap="square">
+            <a:spAutoFit/>
+          </a:bodyPr>
+          <a:lstStyle/>
+          <a:p>
+            <a:pPr algn="l"/>
+            <a:r>
+              <a:rPr sz="1000" b="1" i="0">
+                <a:solidFill>
+                  <a:srgbClr val="202020"/>
+                </a:solidFill>
+              </a:rPr>
+              <a:t>Pendekatan: 1% stratified sampling (128 sampel front-only)</a:t>
+            </a:r>
+          </a:p>
+          <a:p>
+            <a:pPr algn="l"/>
+            <a:r>
+              <a:rPr sz="900" b="0" i="0">
+                <a:solidFill>
+                  <a:srgbClr val="666666"/>
+                </a:solidFill>
+              </a:rPr>
+              <a:t>Mengacu MER2024 (Lian et al., 2024): 1% labeled + 99% SSL verification</a:t>
+            </a:r>
+          </a:p>
+          <a:p>
+            <a:pPr algn="l"/>
+            <a:r>
+              <a:rPr sz="900" b="0" i="0">
+                <a:solidFill>
+                  <a:srgbClr val="666666"/>
+                </a:solidFill>
+              </a:rPr>
+              <a:t>Target: 3 validator, Fleiss Kappa &gt;= 0.61 (Landis &amp; Koch, 1977)</a:t>
+            </a:r>
+          </a:p>
+        </p:txBody>
+      </p:sp>
+      <p:graphicFrame>
+        <p:nvGraphicFramePr>
+          <p:cNvPr id="4" name="Table 3"/>
+          <p:cNvGraphicFramePr>
+            <a:graphicFrameLocks noGrp="1"/>
+          </p:cNvGraphicFramePr>
+          <p:nvPr/>
+        </p:nvGraphicFramePr>
+        <p:xfrm>
+          <a:off x="274320" y="1508760"/>
+          <a:ext cx="8595360" cy="1188720"/>
+        </p:xfrm>
+        <a:graphic>
+          <a:graphicData uri="http://schemas.openxmlformats.org/drawingml/2006/table">
+            <a:tbl>
+              <a:tblPr firstRow="1" bandRow="1"/>
+              <a:tblGrid>
+                <a:gridCol w="1371600"/>
+                <a:gridCol w="1828800"/>
+                <a:gridCol w="1828800"/>
+                <a:gridCol w="3566160"/>
+              </a:tblGrid>
+              <a:tr h="297180">
+                <a:tc>
+                  <a:txBody>
+                    <a:bodyPr/>
+                    <a:lstStyle/>
+                    <a:p>
+                      <a:pPr algn="ctr"/>
+                      <a:r>
+                        <a:rPr sz="1000" b="1">
+                          <a:solidFill>
+                            <a:srgbClr val="FFFFFF"/>
+                          </a:solidFill>
+                        </a:rPr>
+                        <a:t>Validator</a:t>
+                      </a:r>
+                    </a:p>
+                  </a:txBody>
+                  <a:tcPr>
+                    <a:solidFill>
+                      <a:srgbClr val="1A73E8"/>
+                    </a:solidFill>
+                  </a:tcPr>
+                </a:tc>
+                <a:tc>
+                  <a:txBody>
+                    <a:bodyPr/>
+                    <a:lstStyle/>
+                    <a:p>
+                      <a:pPr algn="ctr"/>
+                      <a:r>
+                        <a:rPr sz="1000" b="1">
+                          <a:solidFill>
+                            <a:srgbClr val="FFFFFF"/>
+                          </a:solidFill>
+                        </a:rPr>
+                        <a:t>Sumber</a:t>
+                      </a:r>
+                    </a:p>
+                  </a:txBody>
+                  <a:tcPr>
+                    <a:solidFill>
+                      <a:srgbClr val="1A73E8"/>
+                    </a:solidFill>
+                  </a:tcPr>
+                </a:tc>
+                <a:tc>
+                  <a:txBody>
+                    <a:bodyPr/>
+                    <a:lstStyle/>
+                    <a:p>
+                      <a:pPr algn="ctr"/>
+                      <a:r>
+                        <a:rPr sz="1000" b="1">
+                          <a:solidFill>
+                            <a:srgbClr val="FFFFFF"/>
+                          </a:solidFill>
+                        </a:rPr>
+                        <a:t>Status</a:t>
+                      </a:r>
+                    </a:p>
+                  </a:txBody>
+                  <a:tcPr>
+                    <a:solidFill>
+                      <a:srgbClr val="1A73E8"/>
+                    </a:solidFill>
+                  </a:tcPr>
+                </a:tc>
+                <a:tc>
+                  <a:txBody>
+                    <a:bodyPr/>
+                    <a:lstStyle/>
+                    <a:p>
+                      <a:pPr algn="ctr"/>
+                      <a:r>
+                        <a:rPr sz="1000" b="1">
+                          <a:solidFill>
+                            <a:srgbClr val="FFFFFF"/>
+                          </a:solidFill>
+                        </a:rPr>
+                        <a:t>Keterangan</a:t>
+                      </a:r>
+                    </a:p>
+                  </a:txBody>
+                  <a:tcPr>
+                    <a:solidFill>
+                      <a:srgbClr val="1A73E8"/>
+                    </a:solidFill>
+                  </a:tcPr>
+                </a:tc>
+              </a:tr>
+              <a:tr h="297180">
+                <a:tc>
+                  <a:txBody>
+                    <a:bodyPr/>
+                    <a:lstStyle/>
+                    <a:p>
+                      <a:pPr algn="l"/>
+                      <a:r>
+                        <a:rPr sz="1000" b="1">
+                          <a:solidFill>
+                            <a:srgbClr val="202020"/>
+                          </a:solidFill>
+                        </a:rPr>
+                        <a:t>Validator 1</a:t>
+                      </a:r>
+                    </a:p>
+                  </a:txBody>
+                  <a:tcPr>
+                    <a:solidFill>
+                      <a:srgbClr val="E8F0FE"/>
+                    </a:solidFill>
+                  </a:tcPr>
+                </a:tc>
+                <a:tc>
+                  <a:txBody>
+                    <a:bodyPr/>
+                    <a:lstStyle/>
+                    <a:p>
+                      <a:pPr algn="ctr"/>
+                      <a:r>
+                        <a:rPr sz="1000" b="0">
+                          <a:solidFill>
+                            <a:srgbClr val="202020"/>
+                          </a:solidFill>
+                        </a:rPr>
+                        <a:t>Dari mahasiswa (saya)</a:t>
+                      </a:r>
+                    </a:p>
+                  </a:txBody>
+                  <a:tcPr>
+                    <a:solidFill>
+                      <a:srgbClr val="E8F0FE"/>
+                    </a:solidFill>
+                  </a:tcPr>
+                </a:tc>
+                <a:tc>
+                  <a:txBody>
+                    <a:bodyPr/>
+                    <a:lstStyle/>
+                    <a:p>
+                      <a:pPr algn="ctr"/>
+                      <a:r>
+                        <a:rPr sz="1000" b="0">
+                          <a:solidFill>
+                            <a:srgbClr val="202020"/>
+                          </a:solidFill>
+                        </a:rPr>
+                        <a:t>Sedang proses</a:t>
+                      </a:r>
+                    </a:p>
+                  </a:txBody>
+                  <a:tcPr>
+                    <a:solidFill>
+                      <a:srgbClr val="C6EFCE"/>
+                    </a:solidFill>
+                  </a:tcPr>
+                </a:tc>
+                <a:tc>
+                  <a:txBody>
+                    <a:bodyPr/>
+                    <a:lstStyle/>
+                    <a:p>
+                      <a:pPr algn="l"/>
+                      <a:r>
+                        <a:rPr sz="1000" b="0">
+                          <a:solidFill>
+                            <a:srgbClr val="202020"/>
+                          </a:solidFill>
+                        </a:rPr>
+                        <a:t>Sudah bersedia, sedang validasi</a:t>
+                      </a:r>
+                    </a:p>
+                  </a:txBody>
+                  <a:tcPr>
+                    <a:solidFill>
+                      <a:srgbClr val="E8F0FE"/>
+                    </a:solidFill>
+                  </a:tcPr>
+                </a:tc>
+              </a:tr>
+              <a:tr h="297180">
+                <a:tc>
+                  <a:txBody>
+                    <a:bodyPr/>
+                    <a:lstStyle/>
+                    <a:p>
+                      <a:pPr algn="l"/>
+                      <a:r>
+                        <a:rPr sz="1000" b="1">
+                          <a:solidFill>
+                            <a:srgbClr val="202020"/>
+                          </a:solidFill>
+                        </a:rPr>
+                        <a:t>Validator 2</a:t>
+                      </a:r>
+                    </a:p>
+                  </a:txBody>
+                  <a:tcPr>
+                    <a:solidFill>
+                      <a:srgbClr val="FFFFFF"/>
+                    </a:solidFill>
+                  </a:tcPr>
+                </a:tc>
+                <a:tc>
+                  <a:txBody>
+                    <a:bodyPr/>
+                    <a:lstStyle/>
+                    <a:p>
+                      <a:pPr algn="ctr"/>
+                      <a:r>
+                        <a:rPr sz="1000" b="0">
+                          <a:solidFill>
+                            <a:srgbClr val="202020"/>
+                          </a:solidFill>
+                        </a:rPr>
+                        <a:t>Dari Pak Fitra</a:t>
+                      </a:r>
+                    </a:p>
+                  </a:txBody>
+                  <a:tcPr>
+                    <a:solidFill>
+                      <a:srgbClr val="FFFFFF"/>
+                    </a:solidFill>
+                  </a:tcPr>
+                </a:tc>
+                <a:tc>
+                  <a:txBody>
+                    <a:bodyPr/>
+                    <a:lstStyle/>
+                    <a:p>
+                      <a:pPr algn="ctr"/>
+                      <a:r>
+                        <a:rPr sz="1000" b="0">
+                          <a:solidFill>
+                            <a:srgbClr val="202020"/>
+                          </a:solidFill>
+                        </a:rPr>
+                        <a:t>Menunggu rekomendasi</a:t>
+                      </a:r>
+                    </a:p>
+                  </a:txBody>
+                  <a:tcPr>
+                    <a:solidFill>
+                      <a:srgbClr val="FFF0CC"/>
+                    </a:solidFill>
+                  </a:tcPr>
+                </a:tc>
+                <a:tc>
+                  <a:txBody>
+                    <a:bodyPr/>
+                    <a:lstStyle/>
+                    <a:p>
+                      <a:pPr algn="l"/>
+                      <a:r>
+                        <a:rPr sz="1000" b="0">
+                          <a:solidFill>
+                            <a:srgbClr val="202020"/>
+                          </a:solidFill>
+                        </a:rPr>
+                        <a:t>Mohon rekomendasi dari Pak Fitra</a:t>
+                      </a:r>
+                    </a:p>
+                  </a:txBody>
+                  <a:tcPr>
+                    <a:solidFill>
+                      <a:srgbClr val="FFFFFF"/>
+                    </a:solidFill>
+                  </a:tcPr>
+                </a:tc>
+              </a:tr>
+              <a:tr h="297180">
+                <a:tc>
+                  <a:txBody>
+                    <a:bodyPr/>
+                    <a:lstStyle/>
+                    <a:p>
+                      <a:pPr algn="l"/>
+                      <a:r>
+                        <a:rPr sz="1000" b="1">
+                          <a:solidFill>
+                            <a:srgbClr val="202020"/>
+                          </a:solidFill>
+                        </a:rPr>
+                        <a:t>Validator 3</a:t>
+                      </a:r>
+                    </a:p>
+                  </a:txBody>
+                  <a:tcPr>
+                    <a:solidFill>
+                      <a:srgbClr val="E8F0FE"/>
+                    </a:solidFill>
+                  </a:tcPr>
+                </a:tc>
+                <a:tc>
+                  <a:txBody>
+                    <a:bodyPr/>
+                    <a:lstStyle/>
+                    <a:p>
+                      <a:pPr algn="ctr"/>
+                      <a:r>
+                        <a:rPr sz="1000" b="0">
+                          <a:solidFill>
+                            <a:srgbClr val="202020"/>
+                          </a:solidFill>
+                        </a:rPr>
+                        <a:t>Dari Pak Fitra</a:t>
+                      </a:r>
+                    </a:p>
+                  </a:txBody>
+                  <a:tcPr>
+                    <a:solidFill>
+                      <a:srgbClr val="E8F0FE"/>
+                    </a:solidFill>
+                  </a:tcPr>
+                </a:tc>
+                <a:tc>
+                  <a:txBody>
+                    <a:bodyPr/>
+                    <a:lstStyle/>
+                    <a:p>
+                      <a:pPr algn="ctr"/>
+                      <a:r>
+                        <a:rPr sz="1000" b="0">
+                          <a:solidFill>
+                            <a:srgbClr val="202020"/>
+                          </a:solidFill>
+                        </a:rPr>
+                        <a:t>Menunggu rekomendasi</a:t>
+                      </a:r>
+                    </a:p>
+                  </a:txBody>
+                  <a:tcPr>
+                    <a:solidFill>
+                      <a:srgbClr val="FFF0CC"/>
+                    </a:solidFill>
+                  </a:tcPr>
+                </a:tc>
+                <a:tc>
+                  <a:txBody>
+                    <a:bodyPr/>
+                    <a:lstStyle/>
+                    <a:p>
+                      <a:pPr algn="l"/>
+                      <a:r>
+                        <a:rPr sz="1000" b="0">
+                          <a:solidFill>
+                            <a:srgbClr val="202020"/>
+                          </a:solidFill>
+                        </a:rPr>
+                        <a:t>Mohon rekomendasi dari Pak Fitra</a:t>
+                      </a:r>
+                    </a:p>
+                  </a:txBody>
+                  <a:tcPr>
+                    <a:solidFill>
+                      <a:srgbClr val="E8F0FE"/>
+                    </a:solidFill>
+                  </a:tcPr>
+                </a:tc>
+              </a:tr>
+            </a:tbl>
+          </a:graphicData>
+        </a:graphic>
+      </p:graphicFrame>
+      <p:sp>
+        <p:nvSpPr>
+          <p:cNvPr id="5" name="TextBox 4"/>
+          <p:cNvSpPr txBox="1"/>
+          <p:nvPr/>
+        </p:nvSpPr>
+        <p:spPr>
+          <a:xfrm>
+            <a:off x="274320" y="2834640"/>
+            <a:ext cx="4114800" cy="1097280"/>
+          </a:xfrm>
+          <a:prstGeom prst="rect">
+            <a:avLst/>
+          </a:prstGeom>
+          <a:solidFill>
+            <a:srgbClr val="F1F3F4"/>
+          </a:solidFill>
+        </p:spPr>
+        <p:txBody>
+          <a:bodyPr wrap="square">
+            <a:spAutoFit/>
+          </a:bodyPr>
+          <a:lstStyle/>
+          <a:p>
+            <a:pPr algn="l"/>
+            <a:r>
+              <a:rPr sz="1000" b="1" i="0">
+                <a:solidFill>
+                  <a:srgbClr val="202020"/>
+                </a:solidFill>
+              </a:rPr>
+              <a:t>Tool Validasi (Streamlit)</a:t>
+            </a:r>
+          </a:p>
+          <a:p>
+            <a:pPr algn="l"/>
+            <a:r>
+              <a:rPr sz="400" b="0" i="0"/>
+              <a:t/>
+            </a:r>
+          </a:p>
+          <a:p>
+            <a:pPr algn="l"/>
+            <a:r>
+              <a:rPr sz="900" b="0" i="0">
+                <a:solidFill>
+                  <a:srgbClr val="202020"/>
+                </a:solidFill>
+              </a:rPr>
+              <a:t>Link: taufikhdyt-emo-validation.streamlit.app</a:t>
+            </a:r>
+          </a:p>
+          <a:p>
+            <a:pPr algn="l"/>
+            <a:r>
+              <a:rPr sz="900" b="0" i="0">
+                <a:solidFill>
+                  <a:srgbClr val="202020"/>
+                </a:solidFill>
+              </a:rPr>
+              <a:t>Dataset: 128 sampel (front-only, 7 emosi)</a:t>
+            </a:r>
+          </a:p>
+          <a:p>
+            <a:pPr algn="l"/>
+            <a:r>
+              <a:rPr sz="900" b="0" i="0">
+                <a:solidFill>
+                  <a:srgbClr val="202020"/>
+                </a:solidFill>
+              </a:rPr>
+              <a:t>Waktu: ~30-45 menit per validator</a:t>
+            </a:r>
+          </a:p>
+          <a:p>
+            <a:pPr algn="l"/>
+            <a:r>
+              <a:rPr sz="900" b="0" i="0">
+                <a:solidFill>
+                  <a:srgbClr val="202020"/>
+                </a:solidFill>
+              </a:rPr>
+              <a:t>Admin panel tersedia untuk monitoring</a:t>
+            </a:r>
+          </a:p>
+        </p:txBody>
+      </p:sp>
+      <p:sp>
+        <p:nvSpPr>
+          <p:cNvPr id="6" name="TextBox 5"/>
+          <p:cNvSpPr txBox="1"/>
+          <p:nvPr/>
+        </p:nvSpPr>
+        <p:spPr>
+          <a:xfrm>
+            <a:off x="4572000" y="2834640"/>
+            <a:ext cx="4297680" cy="1097280"/>
+          </a:xfrm>
+          <a:prstGeom prst="rect">
+            <a:avLst/>
+          </a:prstGeom>
+          <a:solidFill>
+            <a:srgbClr val="FFF0CC"/>
+          </a:solidFill>
+        </p:spPr>
+        <p:txBody>
+          <a:bodyPr wrap="square">
+            <a:spAutoFit/>
+          </a:bodyPr>
+          <a:lstStyle/>
+          <a:p>
+            <a:pPr algn="l"/>
+            <a:r>
+              <a:rPr sz="1000" b="1" i="0">
+                <a:solidFill>
+                  <a:srgbClr val="E65100"/>
+                </a:solidFill>
+              </a:rPr>
+              <a:t>Pertanyaan untuk Pak Fitra:</a:t>
+            </a:r>
+          </a:p>
+          <a:p>
+            <a:pPr algn="l"/>
+            <a:r>
+              <a:rPr sz="400" b="0" i="0"/>
+              <a:t/>
+            </a:r>
+          </a:p>
+          <a:p>
+            <a:pPr algn="l"/>
+            <a:r>
+              <a:rPr sz="950" b="0" i="0">
+                <a:solidFill>
+                  <a:srgbClr val="202020"/>
+                </a:solidFill>
+              </a:rPr>
+              <a:t>1. Apakah Pak Fitra punya rekomendasi</a:t>
+            </a:r>
+          </a:p>
+          <a:p>
+            <a:pPr algn="l"/>
+            <a:r>
+              <a:rPr sz="950" b="0" i="0">
+                <a:solidFill>
+                  <a:srgbClr val="202020"/>
+                </a:solidFill>
+              </a:rPr>
+              <a:t>   2 orang berlatar psikologi?</a:t>
+            </a:r>
+          </a:p>
+          <a:p>
+            <a:pPr algn="l"/>
+            <a:r>
+              <a:rPr sz="950" b="0" i="0">
+                <a:solidFill>
+                  <a:srgbClr val="202020"/>
+                </a:solidFill>
+              </a:rPr>
+              <a:t>2. Boleh mahasiswa S2/S3 psikologi?</a:t>
+            </a:r>
+          </a:p>
+          <a:p>
+            <a:pPr algn="l"/>
+            <a:r>
+              <a:rPr sz="950" b="0" i="0">
+                <a:solidFill>
+                  <a:srgbClr val="202020"/>
+                </a:solidFill>
+              </a:rPr>
+              <a:t>3. Apakah perlu honorarium?</a:t>
+            </a:r>
+          </a:p>
+        </p:txBody>
+      </p:sp>
+      <p:sp>
+        <p:nvSpPr>
+          <p:cNvPr id="7" name="TextBox 6"/>
+          <p:cNvSpPr txBox="1"/>
+          <p:nvPr/>
+        </p:nvSpPr>
+        <p:spPr>
+          <a:xfrm>
+            <a:off x="274320" y="4069080"/>
+            <a:ext cx="8595360" cy="320040"/>
+          </a:xfrm>
+          <a:prstGeom prst="rect">
+            <a:avLst/>
+          </a:prstGeom>
+          <a:solidFill>
+            <a:srgbClr val="1A73E8"/>
+          </a:solidFill>
+        </p:spPr>
+        <p:txBody>
+          <a:bodyPr wrap="square">
+            <a:spAutoFit/>
+          </a:bodyPr>
+          <a:lstStyle/>
+          <a:p>
+            <a:pPr algn="ctr"/>
+            <a:r>
+              <a:rPr sz="950" b="1" i="0">
+                <a:solidFill>
+                  <a:srgbClr val="FFFFFF"/>
+                </a:solidFill>
+              </a:rPr>
+              <a:t>Target: validasi selesai dalam 1-2 minggu setelah validator confirmed</a:t>
+            </a:r>
+          </a:p>
+        </p:txBody>
+      </p:sp>
+    </p:spTree>
+  </p:cSld>
+  <p:clrMapOvr>
+    <a:masterClrMapping/>
+  </p:clrMapOvr>
+</p:sld>
+</file>
+
 <file path=ppt/slides/slide11.xml><?xml version="1.0" encoding="utf-8"?>
 <p:sld xmlns:a="http://schemas.openxmlformats.org/drawingml/2006/main" xmlns:r="http://schemas.openxmlformats.org/officeDocument/2006/relationships" xmlns:mc="http://schemas.openxmlformats.org/markup-compatibility/2006" xmlns:mv="urn:schemas-microsoft-com:mac:vml" xmlns:p="http://schemas.openxmlformats.org/presentationml/2006/main" xmlns:c="http://schemas.openxmlformats.org/drawingml/2006/chart" xmlns:dgm="http://schemas.openxmlformats.org/drawingml/2006/diagram" xmlns:o="urn:schemas-microsoft-com:office:office" xmlns:v="urn:schemas-microsoft-com:vml" xmlns:pvml="urn:schemas-microsoft-com:office:powerpoint" xmlns:com="http://schemas.openxmlformats.org/drawingml/2006/compatibility" xmlns:p14="http://schemas.microsoft.com/office/powerpoint/2010/main" xmlns:p15="http://schemas.microsoft.com/office/powerpoint/2012/main" xmlns:ahyp="http://schemas.microsoft.com/office/drawing/2018/hyperlinkcolor">
   <p:cSld>

</xml_diff>

<commit_message>
Update validation slide: Pak Fitra already contacted 2 validators
Changed from "mohon rekomendasi" to "sudah dihubungi, menunggu konfirmasi"
Questions updated: ask about their availability, honorarium, timeline

Co-Authored-By: Claude Opus 4.6 (1M context) <noreply@anthropic.com>
</commit_message>
<xml_diff>
--- a/docs/PPT Bimbingan.pptx
+++ b/docs/PPT Bimbingan.pptx
@@ -16178,786 +16178,6 @@
         </p:nvSpPr>
         <p:spPr>
           <a:xfrm>
-            <a:off x="301752" y="429768"/>
-            <a:ext cx="8321040" cy="548640"/>
-          </a:xfrm>
-          <a:prstGeom prst="rect">
-            <a:avLst/>
-          </a:prstGeom>
-          <a:noFill/>
-        </p:spPr>
-        <p:txBody>
-          <a:bodyPr wrap="none">
-            <a:spAutoFit/>
-          </a:bodyPr>
-          <a:lstStyle/>
-          <a:p>
-            <a:pPr>
-              <a:defRPr sz="2400" b="1">
-                <a:solidFill>
-                  <a:srgbClr val="202020"/>
-                </a:solidFill>
-              </a:defRPr>
-            </a:pPr>
-            <a:r>
-              <a:t>Diskusi &amp; Konsultasi</a:t>
-            </a:r>
-          </a:p>
-        </p:txBody>
-      </p:sp>
-      <p:graphicFrame>
-        <p:nvGraphicFramePr>
-          <p:cNvPr id="3" name="Table 2"/>
-          <p:cNvGraphicFramePr>
-            <a:graphicFrameLocks noGrp="1"/>
-          </p:cNvGraphicFramePr>
-          <p:nvPr/>
-        </p:nvGraphicFramePr>
-        <p:xfrm>
-          <a:off x="457200" y="1097280"/>
-          <a:ext cx="8229600" cy="1828800"/>
-        </p:xfrm>
-        <a:graphic>
-          <a:graphicData uri="http://schemas.openxmlformats.org/drawingml/2006/table">
-            <a:tbl>
-              <a:tblPr firstRow="1" bandRow="1">
-                <a:tableStyleId>{5C22544A-7EE6-4342-B048-85BDC9FD1C3A}</a:tableStyleId>
-              </a:tblPr>
-              <a:tblGrid>
-                <a:gridCol w="548640"/>
-                <a:gridCol w="2286000"/>
-                <a:gridCol w="5394960"/>
-              </a:tblGrid>
-              <a:tr h="457200">
-                <a:tc>
-                  <a:txBody>
-                    <a:bodyPr/>
-                    <a:lstStyle/>
-                    <a:p>
-                      <a:pPr algn="ctr"/>
-                      <a:r>
-                        <a:rPr sz="1000" b="1">
-                          <a:solidFill>
-                            <a:srgbClr val="FFFFFF"/>
-                          </a:solidFill>
-                        </a:rPr>
-                        <a:t>RQ</a:t>
-                      </a:r>
-                    </a:p>
-                  </a:txBody>
-                  <a:tcPr>
-                    <a:solidFill>
-                      <a:srgbClr val="1A73E8"/>
-                    </a:solidFill>
-                  </a:tcPr>
-                </a:tc>
-                <a:tc>
-                  <a:txBody>
-                    <a:bodyPr/>
-                    <a:lstStyle/>
-                    <a:p>
-                      <a:pPr algn="ctr"/>
-                      <a:r>
-                        <a:rPr sz="1000" b="1">
-                          <a:solidFill>
-                            <a:srgbClr val="FFFFFF"/>
-                          </a:solidFill>
-                        </a:rPr>
-                        <a:t>Pertanyaan Penelitian</a:t>
-                      </a:r>
-                    </a:p>
-                  </a:txBody>
-                  <a:tcPr>
-                    <a:solidFill>
-                      <a:srgbClr val="1A73E8"/>
-                    </a:solidFill>
-                  </a:tcPr>
-                </a:tc>
-                <a:tc>
-                  <a:txBody>
-                    <a:bodyPr/>
-                    <a:lstStyle/>
-                    <a:p>
-                      <a:pPr algn="ctr"/>
-                      <a:r>
-                        <a:rPr sz="1000" b="1">
-                          <a:solidFill>
-                            <a:srgbClr val="FFFFFF"/>
-                          </a:solidFill>
-                        </a:rPr>
-                        <a:t>Jawaban / Hasil</a:t>
-                      </a:r>
-                    </a:p>
-                  </a:txBody>
-                  <a:tcPr>
-                    <a:solidFill>
-                      <a:srgbClr val="1A73E8"/>
-                    </a:solidFill>
-                  </a:tcPr>
-                </a:tc>
-              </a:tr>
-              <a:tr h="457200">
-                <a:tc>
-                  <a:txBody>
-                    <a:bodyPr/>
-                    <a:lstStyle/>
-                    <a:p>
-                      <a:pPr algn="l"/>
-                      <a:r>
-                        <a:rPr sz="900">
-                          <a:solidFill>
-                            <a:srgbClr val="202020"/>
-                          </a:solidFill>
-                        </a:rPr>
-                        <a:t>RQ1</a:t>
-                      </a:r>
-                    </a:p>
-                  </a:txBody>
-                  <a:tcPr>
-                    <a:solidFill>
-                      <a:srgbClr val="E8F0FE"/>
-                    </a:solidFill>
-                  </a:tcPr>
-                </a:tc>
-                <a:tc>
-                  <a:txBody>
-                    <a:bodyPr/>
-                    <a:lstStyle/>
-                    <a:p>
-                      <a:pPr algn="ctr"/>
-                      <a:r>
-                        <a:rPr sz="900">
-                          <a:solidFill>
-                            <a:srgbClr val="202020"/>
-                          </a:solidFill>
-                        </a:rPr>
-                        <a:t>Performa CNN</a:t>
-                      </a:r>
-                    </a:p>
-                  </a:txBody>
-                  <a:tcPr>
-                    <a:solidFill>
-                      <a:srgbClr val="E8F0FE"/>
-                    </a:solidFill>
-                  </a:tcPr>
-                </a:tc>
-                <a:tc>
-                  <a:txBody>
-                    <a:bodyPr/>
-                    <a:lstStyle/>
-                    <a:p>
-                      <a:pPr algn="ctr"/>
-                      <a:r>
-                        <a:rPr sz="900">
-                          <a:solidFill>
-                            <a:srgbClr val="202020"/>
-                          </a:solidFill>
-                        </a:rPr>
-                        <a:t>From scratch: 0.134 (7c) / 0.296 (4c)
-Transfer Learning: 0.177 (7c) / 0.407 (4c, +37%)</a:t>
-                      </a:r>
-                    </a:p>
-                    <a:p>
-                      <a:r>
-                        <a:t>Transfer Learning: 0.177 (7c) / 0.407 (4c, +37%)</a:t>
-                      </a:r>
-                    </a:p>
-                  </a:txBody>
-                  <a:tcPr>
-                    <a:solidFill>
-                      <a:srgbClr val="E8F0FE"/>
-                    </a:solidFill>
-                  </a:tcPr>
-                </a:tc>
-              </a:tr>
-              <a:tr h="457200">
-                <a:tc>
-                  <a:txBody>
-                    <a:bodyPr/>
-                    <a:lstStyle/>
-                    <a:p>
-                      <a:pPr algn="l"/>
-                      <a:r>
-                        <a:rPr sz="900">
-                          <a:solidFill>
-                            <a:srgbClr val="202020"/>
-                          </a:solidFill>
-                        </a:rPr>
-                        <a:t>RQ2</a:t>
-                      </a:r>
-                    </a:p>
-                  </a:txBody>
-                  <a:tcPr>
-                    <a:solidFill>
-                      <a:srgbClr val="FFFFFF"/>
-                    </a:solidFill>
-                  </a:tcPr>
-                </a:tc>
-                <a:tc>
-                  <a:txBody>
-                    <a:bodyPr/>
-                    <a:lstStyle/>
-                    <a:p>
-                      <a:pPr algn="ctr"/>
-                      <a:r>
-                        <a:rPr sz="900">
-                          <a:solidFill>
-                            <a:srgbClr val="202020"/>
-                          </a:solidFill>
-                        </a:rPr>
-                        <a:t>Performa FCNN</a:t>
-                      </a:r>
-                    </a:p>
-                  </a:txBody>
-                  <a:tcPr>
-                    <a:solidFill>
-                      <a:srgbClr val="FFFFFF"/>
-                    </a:solidFill>
-                  </a:tcPr>
-                </a:tc>
-                <a:tc>
-                  <a:txBody>
-                    <a:bodyPr/>
-                    <a:lstStyle/>
-                    <a:p>
-                      <a:pPr algn="ctr"/>
-                      <a:r>
-                        <a:rPr sz="900">
-                          <a:solidFill>
-                            <a:srgbClr val="202020"/>
-                          </a:solidFill>
-                        </a:rPr>
-                        <a:t>0.234 (7-class) / 0.394 (4-class)
-Landmark terbukti lebih robust</a:t>
-                      </a:r>
-                    </a:p>
-                    <a:p>
-                      <a:r>
-                        <a:t>Landmark terbukti lebih robust</a:t>
-                      </a:r>
-                    </a:p>
-                  </a:txBody>
-                  <a:tcPr>
-                    <a:solidFill>
-                      <a:srgbClr val="FFFFFF"/>
-                    </a:solidFill>
-                  </a:tcPr>
-                </a:tc>
-              </a:tr>
-              <a:tr h="457200">
-                <a:tc>
-                  <a:txBody>
-                    <a:bodyPr/>
-                    <a:lstStyle/>
-                    <a:p>
-                      <a:pPr algn="l"/>
-                      <a:r>
-                        <a:rPr sz="900">
-                          <a:solidFill>
-                            <a:srgbClr val="202020"/>
-                          </a:solidFill>
-                        </a:rPr>
-                        <a:t>RQ3</a:t>
-                      </a:r>
-                    </a:p>
-                  </a:txBody>
-                  <a:tcPr>
-                    <a:solidFill>
-                      <a:srgbClr val="E8F0FE"/>
-                    </a:solidFill>
-                  </a:tcPr>
-                </a:tc>
-                <a:tc>
-                  <a:txBody>
-                    <a:bodyPr/>
-                    <a:lstStyle/>
-                    <a:p>
-                      <a:pPr algn="ctr"/>
-                      <a:r>
-                        <a:rPr sz="900">
-                          <a:solidFill>
-                            <a:srgbClr val="202020"/>
-                          </a:solidFill>
-                        </a:rPr>
-                        <a:t>Perbandingan Fusion</a:t>
-                      </a:r>
-                    </a:p>
-                  </a:txBody>
-                  <a:tcPr>
-                    <a:solidFill>
-                      <a:srgbClr val="E8F0FE"/>
-                    </a:solidFill>
-                  </a:tcPr>
-                </a:tc>
-                <a:tc>
-                  <a:txBody>
-                    <a:bodyPr/>
-                    <a:lstStyle/>
-                    <a:p>
-                      <a:pPr algn="ctr"/>
-                      <a:r>
-                        <a:rPr sz="900">
-                          <a:solidFill>
-                            <a:srgbClr val="202020"/>
-                          </a:solidFill>
-                        </a:rPr>
-                        <a:t>From scratch: FCNN &gt; Late Fusion &gt; Intermediate
-TL: Late Fusion TL terbaik (0.442)</a:t>
-                      </a:r>
-                    </a:p>
-                    <a:p>
-                      <a:r>
-                        <a:t>TL: Late Fusion TL terbaik (0.442)</a:t>
-                      </a:r>
-                    </a:p>
-                  </a:txBody>
-                  <a:tcPr>
-                    <a:solidFill>
-                      <a:srgbClr val="E8F0FE"/>
-                    </a:solidFill>
-                  </a:tcPr>
-                </a:tc>
-              </a:tr>
-            </a:tbl>
-          </a:graphicData>
-        </a:graphic>
-      </p:graphicFrame>
-      <p:graphicFrame>
-        <p:nvGraphicFramePr>
-          <p:cNvPr id="4" name="Table 3"/>
-          <p:cNvGraphicFramePr>
-            <a:graphicFrameLocks noGrp="1"/>
-          </p:cNvGraphicFramePr>
-          <p:nvPr/>
-        </p:nvGraphicFramePr>
-        <p:xfrm>
-          <a:off x="457200" y="3017520"/>
-          <a:ext cx="8229600" cy="1828800"/>
-        </p:xfrm>
-        <a:graphic>
-          <a:graphicData uri="http://schemas.openxmlformats.org/drawingml/2006/table">
-            <a:tbl>
-              <a:tblPr firstRow="1" bandRow="1">
-                <a:tableStyleId>{5C22544A-7EE6-4342-B048-85BDC9FD1C3A}</a:tableStyleId>
-              </a:tblPr>
-              <a:tblGrid>
-                <a:gridCol w="365760"/>
-                <a:gridCol w="2286000"/>
-                <a:gridCol w="5577840"/>
-              </a:tblGrid>
-              <a:tr h="365760">
-                <a:tc>
-                  <a:txBody>
-                    <a:bodyPr/>
-                    <a:lstStyle/>
-                    <a:p>
-                      <a:pPr algn="ctr"/>
-                      <a:r>
-                        <a:rPr sz="1000" b="1">
-                          <a:solidFill>
-                            <a:srgbClr val="FFFFFF"/>
-                          </a:solidFill>
-                        </a:rPr>
-                        <a:t>No</a:t>
-                      </a:r>
-                    </a:p>
-                  </a:txBody>
-                  <a:tcPr>
-                    <a:solidFill>
-                      <a:srgbClr val="1A73E8"/>
-                    </a:solidFill>
-                  </a:tcPr>
-                </a:tc>
-                <a:tc>
-                  <a:txBody>
-                    <a:bodyPr/>
-                    <a:lstStyle/>
-                    <a:p>
-                      <a:pPr algn="ctr"/>
-                      <a:r>
-                        <a:rPr sz="1000" b="1">
-                          <a:solidFill>
-                            <a:srgbClr val="FFFFFF"/>
-                          </a:solidFill>
-                        </a:rPr>
-                        <a:t>Topik Konsultasi</a:t>
-                      </a:r>
-                    </a:p>
-                  </a:txBody>
-                  <a:tcPr>
-                    <a:solidFill>
-                      <a:srgbClr val="1A73E8"/>
-                    </a:solidFill>
-                  </a:tcPr>
-                </a:tc>
-                <a:tc>
-                  <a:txBody>
-                    <a:bodyPr/>
-                    <a:lstStyle/>
-                    <a:p>
-                      <a:pPr algn="ctr"/>
-                      <a:r>
-                        <a:rPr sz="1000" b="1">
-                          <a:solidFill>
-                            <a:srgbClr val="FFFFFF"/>
-                          </a:solidFill>
-                        </a:rPr>
-                        <a:t>Pertanyaan</a:t>
-                      </a:r>
-                    </a:p>
-                  </a:txBody>
-                  <a:tcPr>
-                    <a:solidFill>
-                      <a:srgbClr val="1A73E8"/>
-                    </a:solidFill>
-                  </a:tcPr>
-                </a:tc>
-              </a:tr>
-              <a:tr h="365760">
-                <a:tc>
-                  <a:txBody>
-                    <a:bodyPr/>
-                    <a:lstStyle/>
-                    <a:p>
-                      <a:pPr algn="l"/>
-                      <a:r>
-                        <a:rPr sz="900">
-                          <a:solidFill>
-                            <a:srgbClr val="202020"/>
-                          </a:solidFill>
-                        </a:rPr>
-                        <a:t>1</a:t>
-                      </a:r>
-                    </a:p>
-                  </a:txBody>
-                  <a:tcPr>
-                    <a:solidFill>
-                      <a:srgbClr val="E8F0FE"/>
-                    </a:solidFill>
-                  </a:tcPr>
-                </a:tc>
-                <a:tc>
-                  <a:txBody>
-                    <a:bodyPr/>
-                    <a:lstStyle/>
-                    <a:p>
-                      <a:pPr algn="ctr"/>
-                      <a:r>
-                        <a:rPr sz="900">
-                          <a:solidFill>
-                            <a:srgbClr val="202020"/>
-                          </a:solidFill>
-                        </a:rPr>
-                        <a:t>Transfer Learning sebagai kontribusi</a:t>
-                      </a:r>
-                    </a:p>
-                  </a:txBody>
-                  <a:tcPr>
-                    <a:solidFill>
-                      <a:srgbClr val="E8F0FE"/>
-                    </a:solidFill>
-                  </a:tcPr>
-                </a:tc>
-                <a:tc>
-                  <a:txBody>
-                    <a:bodyPr/>
-                    <a:lstStyle/>
-                    <a:p>
-                      <a:pPr algn="ctr"/>
-                      <a:r>
-                        <a:rPr sz="900">
-                          <a:solidFill>
-                            <a:srgbClr val="202020"/>
-                          </a:solidFill>
-                        </a:rPr>
-                        <a:t>TL meningkatkan F1: 0.394 → 0.442. Cukup signifikan sebagai kontribusi tesis?</a:t>
-                      </a:r>
-                    </a:p>
-                  </a:txBody>
-                  <a:tcPr>
-                    <a:solidFill>
-                      <a:srgbClr val="E8F0FE"/>
-                    </a:solidFill>
-                  </a:tcPr>
-                </a:tc>
-              </a:tr>
-              <a:tr h="365760">
-                <a:tc>
-                  <a:txBody>
-                    <a:bodyPr/>
-                    <a:lstStyle/>
-                    <a:p>
-                      <a:pPr algn="l"/>
-                      <a:r>
-                        <a:rPr sz="900">
-                          <a:solidFill>
-                            <a:srgbClr val="202020"/>
-                          </a:solidFill>
-                        </a:rPr>
-                        <a:t>2</a:t>
-                      </a:r>
-                    </a:p>
-                  </a:txBody>
-                  <a:tcPr>
-                    <a:solidFill>
-                      <a:srgbClr val="FFFFFF"/>
-                    </a:solidFill>
-                  </a:tcPr>
-                </a:tc>
-                <a:tc>
-                  <a:txBody>
-                    <a:bodyPr/>
-                    <a:lstStyle/>
-                    <a:p>
-                      <a:pPr algn="ctr"/>
-                      <a:r>
-                        <a:rPr sz="900">
-                          <a:solidFill>
-                            <a:srgbClr val="202020"/>
-                          </a:solidFill>
-                        </a:rPr>
-                        <a:t>FCNN &gt; Fusion (from scratch)</a:t>
-                      </a:r>
-                    </a:p>
-                  </a:txBody>
-                  <a:tcPr>
-                    <a:solidFill>
-                      <a:srgbClr val="FFFFFF"/>
-                    </a:solidFill>
-                  </a:tcPr>
-                </a:tc>
-                <a:tc>
-                  <a:txBody>
-                    <a:bodyPr/>
-                    <a:lstStyle/>
-                    <a:p>
-                      <a:pPr algn="ctr"/>
-                      <a:r>
-                        <a:rPr sz="900">
-                          <a:solidFill>
-                            <a:srgbClr val="202020"/>
-                          </a:solidFill>
-                        </a:rPr>
-                        <a:t>Bertentangan hipotesis proposal — namun dengan TL, fusion akhirnya terbaik. Narasi tesis?</a:t>
-                      </a:r>
-                    </a:p>
-                  </a:txBody>
-                  <a:tcPr>
-                    <a:solidFill>
-                      <a:srgbClr val="FFFFFF"/>
-                    </a:solidFill>
-                  </a:tcPr>
-                </a:tc>
-              </a:tr>
-              <a:tr h="365760">
-                <a:tc>
-                  <a:txBody>
-                    <a:bodyPr/>
-                    <a:lstStyle/>
-                    <a:p>
-                      <a:pPr algn="l"/>
-                      <a:r>
-                        <a:rPr sz="900">
-                          <a:solidFill>
-                            <a:srgbClr val="202020"/>
-                          </a:solidFill>
-                        </a:rPr>
-                        <a:t>3</a:t>
-                      </a:r>
-                    </a:p>
-                  </a:txBody>
-                  <a:tcPr>
-                    <a:solidFill>
-                      <a:srgbClr val="E8F0FE"/>
-                    </a:solidFill>
-                  </a:tcPr>
-                </a:tc>
-                <a:tc>
-                  <a:txBody>
-                    <a:bodyPr/>
-                    <a:lstStyle/>
-                    <a:p>
-                      <a:pPr algn="ctr"/>
-                      <a:r>
-                        <a:rPr sz="900">
-                          <a:solidFill>
-                            <a:srgbClr val="202020"/>
-                          </a:solidFill>
-                        </a:rPr>
-                        <a:t>Macro F1 0.442</a:t>
-                      </a:r>
-                    </a:p>
-                  </a:txBody>
-                  <a:tcPr>
-                    <a:solidFill>
-                      <a:srgbClr val="E8F0FE"/>
-                    </a:solidFill>
-                  </a:tcPr>
-                </a:tc>
-                <a:tc>
-                  <a:txBody>
-                    <a:bodyPr/>
-                    <a:lstStyle/>
-                    <a:p>
-                      <a:pPr algn="ctr"/>
-                      <a:r>
-                        <a:rPr sz="900">
-                          <a:solidFill>
-                            <a:srgbClr val="202020"/>
-                          </a:solidFill>
-                        </a:rPr>
-                        <a:t>Acceptable untuk tesis S2? Dataset naturalistik, nyata, sangat imbalanced</a:t>
-                      </a:r>
-                    </a:p>
-                  </a:txBody>
-                  <a:tcPr>
-                    <a:solidFill>
-                      <a:srgbClr val="E8F0FE"/>
-                    </a:solidFill>
-                  </a:tcPr>
-                </a:tc>
-              </a:tr>
-              <a:tr h="365760">
-                <a:tc>
-                  <a:txBody>
-                    <a:bodyPr/>
-                    <a:lstStyle/>
-                    <a:p>
-                      <a:pPr algn="l"/>
-                      <a:r>
-                        <a:rPr sz="900">
-                          <a:solidFill>
-                            <a:srgbClr val="202020"/>
-                          </a:solidFill>
-                        </a:rPr>
-                        <a:t>4</a:t>
-                      </a:r>
-                    </a:p>
-                  </a:txBody>
-                  <a:tcPr>
-                    <a:solidFill>
-                      <a:srgbClr val="FFFFFF"/>
-                    </a:solidFill>
-                  </a:tcPr>
-                </a:tc>
-                <a:tc>
-                  <a:txBody>
-                    <a:bodyPr/>
-                    <a:lstStyle/>
-                    <a:p>
-                      <a:pPr algn="ctr"/>
-                      <a:r>
-                        <a:rPr sz="900">
-                          <a:solidFill>
-                            <a:srgbClr val="202020"/>
-                          </a:solidFill>
-                        </a:rPr>
-                        <a:t>Validasi ahli psikologi</a:t>
-                      </a:r>
-                    </a:p>
-                  </a:txBody>
-                  <a:tcPr>
-                    <a:solidFill>
-                      <a:srgbClr val="FFFFFF"/>
-                    </a:solidFill>
-                  </a:tcPr>
-                </a:tc>
-                <a:tc>
-                  <a:txBody>
-                    <a:bodyPr/>
-                    <a:lstStyle/>
-                    <a:p>
-                      <a:pPr algn="ctr"/>
-                      <a:r>
-                        <a:rPr sz="900">
-                          <a:solidFill>
-                            <a:srgbClr val="202020"/>
-                          </a:solidFill>
-                        </a:rPr>
-                        <a:t>Opsi A/B/C? 1 atau 2 ahli? Perlu honorarium?</a:t>
-                      </a:r>
-                    </a:p>
-                  </a:txBody>
-                  <a:tcPr>
-                    <a:solidFill>
-                      <a:srgbClr val="FFFFFF"/>
-                    </a:solidFill>
-                  </a:tcPr>
-                </a:tc>
-              </a:tr>
-            </a:tbl>
-          </a:graphicData>
-        </a:graphic>
-      </p:graphicFrame>
-    </p:spTree>
-  </p:cSld>
-  <p:clrMapOvr>
-    <a:masterClrMapping/>
-  </p:clrMapOvr>
-</p:sld>
-</file>
-
-<file path=ppt/slides/slide106.xml><?xml version="1.0" encoding="utf-8"?>
-<p:sld xmlns:a="http://schemas.openxmlformats.org/drawingml/2006/main" xmlns:p="http://schemas.openxmlformats.org/presentationml/2006/main" xmlns:r="http://schemas.openxmlformats.org/officeDocument/2006/relationships">
-  <p:cSld>
-    <p:spTree>
-      <p:sp>
-        <p:nvSpPr>
-          <p:cNvPr id="1" name="TextBox 0"/>
-          <p:cNvSpPr txBox="1"/>
-          <p:nvPr/>
-        </p:nvSpPr>
-        <p:spPr>
-          <a:xfrm>
-            <a:off x="914400" y="1920240"/>
-            <a:ext cx="7315200" cy="1097280"/>
-          </a:xfrm>
-          <a:prstGeom prst="rect">
-            <a:avLst/>
-          </a:prstGeom>
-          <a:noFill/>
-        </p:spPr>
-        <p:txBody>
-          <a:bodyPr wrap="none">
-            <a:spAutoFit/>
-          </a:bodyPr>
-          <a:lstStyle/>
-          <a:p>
-            <a:pPr algn="ctr">
-              <a:defRPr sz="4000" b="1"/>
-            </a:pPr>
-            <a:r>
-              <a:t>Terimakasih</a:t>
-            </a:r>
-          </a:p>
-        </p:txBody>
-      </p:sp>
-    </p:spTree>
-  </p:cSld>
-  <p:clrMapOvr>
-    <a:masterClrMapping/>
-  </p:clrMapOvr>
-</p:sld>
-</file>
-
-<file path=ppt/slides/slide107.xml><?xml version="1.0" encoding="utf-8"?>
-<p:sld xmlns:a="http://schemas.openxmlformats.org/drawingml/2006/main" xmlns:p="http://schemas.openxmlformats.org/presentationml/2006/main" xmlns:r="http://schemas.openxmlformats.org/officeDocument/2006/relationships">
-  <p:cSld>
-    <p:spTree>
-      <p:nvGrpSpPr>
-        <p:cNvPr id="1" name=""/>
-        <p:cNvGrpSpPr/>
-        <p:nvPr/>
-      </p:nvGrpSpPr>
-      <p:grpSpPr/>
-      <p:sp>
-        <p:nvSpPr>
-          <p:cNvPr id="2" name="TextBox 1"/>
-          <p:cNvSpPr txBox="1"/>
-          <p:nvPr/>
-        </p:nvSpPr>
-        <p:spPr>
-          <a:xfrm>
             <a:off x="274320" y="109728"/>
             <a:ext cx="8595360" cy="502920"/>
           </a:xfrm>
@@ -17272,13 +16492,7 @@
                     <a:bodyPr/>
                     <a:lstStyle/>
                     <a:p>
-                      <a:pPr algn="ctr"/>
-                      <a:r>
-                        <a:rPr sz="1000" b="0">
-                          <a:solidFill>
-                            <a:srgbClr val="202020"/>
-                          </a:solidFill>
-                        </a:rPr>
+                      <a:r>
                         <a:t>Dari Pak Fitra</a:t>
                       </a:r>
                     </a:p>
@@ -17294,14 +16508,8 @@
                     <a:bodyPr/>
                     <a:lstStyle/>
                     <a:p>
-                      <a:pPr algn="ctr"/>
-                      <a:r>
-                        <a:rPr sz="1000" b="0">
-                          <a:solidFill>
-                            <a:srgbClr val="202020"/>
-                          </a:solidFill>
-                        </a:rPr>
-                        <a:t>Menunggu rekomendasi</a:t>
+                      <a:r>
+                        <a:t>Menunggu konfirmasi</a:t>
                       </a:r>
                     </a:p>
                   </a:txBody>
@@ -17316,14 +16524,8 @@
                     <a:bodyPr/>
                     <a:lstStyle/>
                     <a:p>
-                      <a:pPr algn="l"/>
-                      <a:r>
-                        <a:rPr sz="1000" b="0">
-                          <a:solidFill>
-                            <a:srgbClr val="202020"/>
-                          </a:solidFill>
-                        </a:rPr>
-                        <a:t>Mohon rekomendasi dari Pak Fitra</a:t>
+                      <a:r>
+                        <a:t>Sudah dihubungi Pak Fitra</a:t>
                       </a:r>
                     </a:p>
                   </a:txBody>
@@ -17362,13 +16564,7 @@
                     <a:bodyPr/>
                     <a:lstStyle/>
                     <a:p>
-                      <a:pPr algn="ctr"/>
-                      <a:r>
-                        <a:rPr sz="1000" b="0">
-                          <a:solidFill>
-                            <a:srgbClr val="202020"/>
-                          </a:solidFill>
-                        </a:rPr>
+                      <a:r>
                         <a:t>Dari Pak Fitra</a:t>
                       </a:r>
                     </a:p>
@@ -17384,14 +16580,8 @@
                     <a:bodyPr/>
                     <a:lstStyle/>
                     <a:p>
-                      <a:pPr algn="ctr"/>
-                      <a:r>
-                        <a:rPr sz="1000" b="0">
-                          <a:solidFill>
-                            <a:srgbClr val="202020"/>
-                          </a:solidFill>
-                        </a:rPr>
-                        <a:t>Menunggu rekomendasi</a:t>
+                      <a:r>
+                        <a:t>Menunggu konfirmasi</a:t>
                       </a:r>
                     </a:p>
                   </a:txBody>
@@ -17406,14 +16596,8 @@
                     <a:bodyPr/>
                     <a:lstStyle/>
                     <a:p>
-                      <a:pPr algn="l"/>
-                      <a:r>
-                        <a:rPr sz="1000" b="0">
-                          <a:solidFill>
-                            <a:srgbClr val="202020"/>
-                          </a:solidFill>
-                        </a:rPr>
-                        <a:t>Mohon rekomendasi dari Pak Fitra</a:t>
+                      <a:r>
+                        <a:t>Sudah dihubungi Pak Fitra</a:t>
                       </a:r>
                     </a:p>
                   </a:txBody>
@@ -17541,7 +16725,7 @@
           <a:p>
             <a:pPr algn="l"/>
             <a:r>
-              <a:rPr sz="1000" b="1" i="0">
+              <a:rPr sz="1000" b="1">
                 <a:solidFill>
                   <a:srgbClr val="E65100"/>
                 </a:solidFill>
@@ -17551,53 +16735,72 @@
           </a:p>
           <a:p>
             <a:pPr algn="l"/>
-            <a:r>
-              <a:rPr sz="400" b="0" i="0"/>
-              <a:t/>
-            </a:r>
           </a:p>
           <a:p>
             <a:pPr algn="l"/>
-            <a:r>
-              <a:rPr sz="950" b="0" i="0">
+          </a:p>
+          <a:p>
+            <a:pPr algn="l"/>
+          </a:p>
+          <a:p>
+            <a:pPr algn="l"/>
+          </a:p>
+          <a:p>
+            <a:pPr algn="l"/>
+          </a:p>
+          <a:p>
+            <a:pPr algn="l"/>
+            <a:r>
+              <a:rPr sz="950">
                 <a:solidFill>
                   <a:srgbClr val="202020"/>
                 </a:solidFill>
               </a:rPr>
-              <a:t>1. Apakah Pak Fitra punya rekomendasi</a:t>
+              <a:t/>
             </a:r>
           </a:p>
           <a:p>
             <a:pPr algn="l"/>
             <a:r>
-              <a:rPr sz="950" b="0" i="0">
+              <a:rPr sz="950">
                 <a:solidFill>
                   <a:srgbClr val="202020"/>
                 </a:solidFill>
               </a:rPr>
-              <a:t>   2 orang berlatar psikologi?</a:t>
+              <a:t>1. Bagaimana kesediaan 2 validator</a:t>
             </a:r>
           </a:p>
           <a:p>
             <a:pPr algn="l"/>
             <a:r>
-              <a:rPr sz="950" b="0" i="0">
+              <a:rPr sz="950">
                 <a:solidFill>
                   <a:srgbClr val="202020"/>
                 </a:solidFill>
               </a:rPr>
-              <a:t>2. Boleh mahasiswa S2/S3 psikologi?</a:t>
+              <a:t>   yang sudah dihubungi?</a:t>
             </a:r>
           </a:p>
           <a:p>
             <a:pPr algn="l"/>
             <a:r>
-              <a:rPr sz="950" b="0" i="0">
+              <a:rPr sz="950">
                 <a:solidFill>
                   <a:srgbClr val="202020"/>
                 </a:solidFill>
               </a:rPr>
-              <a:t>3. Apakah perlu honorarium?</a:t>
+              <a:t>2. Apakah perlu honorarium?</a:t>
+            </a:r>
+          </a:p>
+          <a:p>
+            <a:pPr algn="l"/>
+            <a:r>
+              <a:rPr sz="950">
+                <a:solidFill>
+                  <a:srgbClr val="202020"/>
+                </a:solidFill>
+              </a:rPr>
+              <a:t>3. Kapan estimasi bisa mulai validasi?</a:t>
             </a:r>
           </a:p>
         </p:txBody>
@@ -17634,6 +16837,786 @@
                 </a:solidFill>
               </a:rPr>
               <a:t>Target: validasi selesai dalam 1-2 minggu setelah validator confirmed</a:t>
+            </a:r>
+          </a:p>
+        </p:txBody>
+      </p:sp>
+    </p:spTree>
+  </p:cSld>
+  <p:clrMapOvr>
+    <a:masterClrMapping/>
+  </p:clrMapOvr>
+</p:sld>
+</file>
+
+<file path=ppt/slides/slide106.xml><?xml version="1.0" encoding="utf-8"?>
+<p:sld xmlns:a="http://schemas.openxmlformats.org/drawingml/2006/main" xmlns:p="http://schemas.openxmlformats.org/presentationml/2006/main" xmlns:r="http://schemas.openxmlformats.org/officeDocument/2006/relationships">
+  <p:cSld>
+    <p:spTree>
+      <p:nvGrpSpPr>
+        <p:cNvPr id="1" name=""/>
+        <p:cNvGrpSpPr/>
+        <p:nvPr/>
+      </p:nvGrpSpPr>
+      <p:grpSpPr/>
+      <p:sp>
+        <p:nvSpPr>
+          <p:cNvPr id="2" name="TextBox 1"/>
+          <p:cNvSpPr txBox="1"/>
+          <p:nvPr/>
+        </p:nvSpPr>
+        <p:spPr>
+          <a:xfrm>
+            <a:off x="301752" y="429768"/>
+            <a:ext cx="8321040" cy="548640"/>
+          </a:xfrm>
+          <a:prstGeom prst="rect">
+            <a:avLst/>
+          </a:prstGeom>
+          <a:noFill/>
+        </p:spPr>
+        <p:txBody>
+          <a:bodyPr wrap="none">
+            <a:spAutoFit/>
+          </a:bodyPr>
+          <a:lstStyle/>
+          <a:p>
+            <a:pPr>
+              <a:defRPr sz="2400" b="1">
+                <a:solidFill>
+                  <a:srgbClr val="202020"/>
+                </a:solidFill>
+              </a:defRPr>
+            </a:pPr>
+            <a:r>
+              <a:t>Diskusi &amp; Konsultasi</a:t>
+            </a:r>
+          </a:p>
+        </p:txBody>
+      </p:sp>
+      <p:graphicFrame>
+        <p:nvGraphicFramePr>
+          <p:cNvPr id="3" name="Table 2"/>
+          <p:cNvGraphicFramePr>
+            <a:graphicFrameLocks noGrp="1"/>
+          </p:cNvGraphicFramePr>
+          <p:nvPr/>
+        </p:nvGraphicFramePr>
+        <p:xfrm>
+          <a:off x="457200" y="1097280"/>
+          <a:ext cx="8229600" cy="1828800"/>
+        </p:xfrm>
+        <a:graphic>
+          <a:graphicData uri="http://schemas.openxmlformats.org/drawingml/2006/table">
+            <a:tbl>
+              <a:tblPr firstRow="1" bandRow="1">
+                <a:tableStyleId>{5C22544A-7EE6-4342-B048-85BDC9FD1C3A}</a:tableStyleId>
+              </a:tblPr>
+              <a:tblGrid>
+                <a:gridCol w="548640"/>
+                <a:gridCol w="2286000"/>
+                <a:gridCol w="5394960"/>
+              </a:tblGrid>
+              <a:tr h="457200">
+                <a:tc>
+                  <a:txBody>
+                    <a:bodyPr/>
+                    <a:lstStyle/>
+                    <a:p>
+                      <a:pPr algn="ctr"/>
+                      <a:r>
+                        <a:rPr sz="1000" b="1">
+                          <a:solidFill>
+                            <a:srgbClr val="FFFFFF"/>
+                          </a:solidFill>
+                        </a:rPr>
+                        <a:t>RQ</a:t>
+                      </a:r>
+                    </a:p>
+                  </a:txBody>
+                  <a:tcPr>
+                    <a:solidFill>
+                      <a:srgbClr val="1A73E8"/>
+                    </a:solidFill>
+                  </a:tcPr>
+                </a:tc>
+                <a:tc>
+                  <a:txBody>
+                    <a:bodyPr/>
+                    <a:lstStyle/>
+                    <a:p>
+                      <a:pPr algn="ctr"/>
+                      <a:r>
+                        <a:rPr sz="1000" b="1">
+                          <a:solidFill>
+                            <a:srgbClr val="FFFFFF"/>
+                          </a:solidFill>
+                        </a:rPr>
+                        <a:t>Pertanyaan Penelitian</a:t>
+                      </a:r>
+                    </a:p>
+                  </a:txBody>
+                  <a:tcPr>
+                    <a:solidFill>
+                      <a:srgbClr val="1A73E8"/>
+                    </a:solidFill>
+                  </a:tcPr>
+                </a:tc>
+                <a:tc>
+                  <a:txBody>
+                    <a:bodyPr/>
+                    <a:lstStyle/>
+                    <a:p>
+                      <a:pPr algn="ctr"/>
+                      <a:r>
+                        <a:rPr sz="1000" b="1">
+                          <a:solidFill>
+                            <a:srgbClr val="FFFFFF"/>
+                          </a:solidFill>
+                        </a:rPr>
+                        <a:t>Jawaban / Hasil</a:t>
+                      </a:r>
+                    </a:p>
+                  </a:txBody>
+                  <a:tcPr>
+                    <a:solidFill>
+                      <a:srgbClr val="1A73E8"/>
+                    </a:solidFill>
+                  </a:tcPr>
+                </a:tc>
+              </a:tr>
+              <a:tr h="457200">
+                <a:tc>
+                  <a:txBody>
+                    <a:bodyPr/>
+                    <a:lstStyle/>
+                    <a:p>
+                      <a:pPr algn="l"/>
+                      <a:r>
+                        <a:rPr sz="900">
+                          <a:solidFill>
+                            <a:srgbClr val="202020"/>
+                          </a:solidFill>
+                        </a:rPr>
+                        <a:t>RQ1</a:t>
+                      </a:r>
+                    </a:p>
+                  </a:txBody>
+                  <a:tcPr>
+                    <a:solidFill>
+                      <a:srgbClr val="E8F0FE"/>
+                    </a:solidFill>
+                  </a:tcPr>
+                </a:tc>
+                <a:tc>
+                  <a:txBody>
+                    <a:bodyPr/>
+                    <a:lstStyle/>
+                    <a:p>
+                      <a:pPr algn="ctr"/>
+                      <a:r>
+                        <a:rPr sz="900">
+                          <a:solidFill>
+                            <a:srgbClr val="202020"/>
+                          </a:solidFill>
+                        </a:rPr>
+                        <a:t>Performa CNN</a:t>
+                      </a:r>
+                    </a:p>
+                  </a:txBody>
+                  <a:tcPr>
+                    <a:solidFill>
+                      <a:srgbClr val="E8F0FE"/>
+                    </a:solidFill>
+                  </a:tcPr>
+                </a:tc>
+                <a:tc>
+                  <a:txBody>
+                    <a:bodyPr/>
+                    <a:lstStyle/>
+                    <a:p>
+                      <a:pPr algn="ctr"/>
+                      <a:r>
+                        <a:rPr sz="900">
+                          <a:solidFill>
+                            <a:srgbClr val="202020"/>
+                          </a:solidFill>
+                        </a:rPr>
+                        <a:t>From scratch: 0.134 (7c) / 0.296 (4c)
+Transfer Learning: 0.177 (7c) / 0.407 (4c, +37%)</a:t>
+                      </a:r>
+                    </a:p>
+                    <a:p>
+                      <a:r>
+                        <a:t>Transfer Learning: 0.177 (7c) / 0.407 (4c, +37%)</a:t>
+                      </a:r>
+                    </a:p>
+                  </a:txBody>
+                  <a:tcPr>
+                    <a:solidFill>
+                      <a:srgbClr val="E8F0FE"/>
+                    </a:solidFill>
+                  </a:tcPr>
+                </a:tc>
+              </a:tr>
+              <a:tr h="457200">
+                <a:tc>
+                  <a:txBody>
+                    <a:bodyPr/>
+                    <a:lstStyle/>
+                    <a:p>
+                      <a:pPr algn="l"/>
+                      <a:r>
+                        <a:rPr sz="900">
+                          <a:solidFill>
+                            <a:srgbClr val="202020"/>
+                          </a:solidFill>
+                        </a:rPr>
+                        <a:t>RQ2</a:t>
+                      </a:r>
+                    </a:p>
+                  </a:txBody>
+                  <a:tcPr>
+                    <a:solidFill>
+                      <a:srgbClr val="FFFFFF"/>
+                    </a:solidFill>
+                  </a:tcPr>
+                </a:tc>
+                <a:tc>
+                  <a:txBody>
+                    <a:bodyPr/>
+                    <a:lstStyle/>
+                    <a:p>
+                      <a:pPr algn="ctr"/>
+                      <a:r>
+                        <a:rPr sz="900">
+                          <a:solidFill>
+                            <a:srgbClr val="202020"/>
+                          </a:solidFill>
+                        </a:rPr>
+                        <a:t>Performa FCNN</a:t>
+                      </a:r>
+                    </a:p>
+                  </a:txBody>
+                  <a:tcPr>
+                    <a:solidFill>
+                      <a:srgbClr val="FFFFFF"/>
+                    </a:solidFill>
+                  </a:tcPr>
+                </a:tc>
+                <a:tc>
+                  <a:txBody>
+                    <a:bodyPr/>
+                    <a:lstStyle/>
+                    <a:p>
+                      <a:pPr algn="ctr"/>
+                      <a:r>
+                        <a:rPr sz="900">
+                          <a:solidFill>
+                            <a:srgbClr val="202020"/>
+                          </a:solidFill>
+                        </a:rPr>
+                        <a:t>0.234 (7-class) / 0.394 (4-class)
+Landmark terbukti lebih robust</a:t>
+                      </a:r>
+                    </a:p>
+                    <a:p>
+                      <a:r>
+                        <a:t>Landmark terbukti lebih robust</a:t>
+                      </a:r>
+                    </a:p>
+                  </a:txBody>
+                  <a:tcPr>
+                    <a:solidFill>
+                      <a:srgbClr val="FFFFFF"/>
+                    </a:solidFill>
+                  </a:tcPr>
+                </a:tc>
+              </a:tr>
+              <a:tr h="457200">
+                <a:tc>
+                  <a:txBody>
+                    <a:bodyPr/>
+                    <a:lstStyle/>
+                    <a:p>
+                      <a:pPr algn="l"/>
+                      <a:r>
+                        <a:rPr sz="900">
+                          <a:solidFill>
+                            <a:srgbClr val="202020"/>
+                          </a:solidFill>
+                        </a:rPr>
+                        <a:t>RQ3</a:t>
+                      </a:r>
+                    </a:p>
+                  </a:txBody>
+                  <a:tcPr>
+                    <a:solidFill>
+                      <a:srgbClr val="E8F0FE"/>
+                    </a:solidFill>
+                  </a:tcPr>
+                </a:tc>
+                <a:tc>
+                  <a:txBody>
+                    <a:bodyPr/>
+                    <a:lstStyle/>
+                    <a:p>
+                      <a:pPr algn="ctr"/>
+                      <a:r>
+                        <a:rPr sz="900">
+                          <a:solidFill>
+                            <a:srgbClr val="202020"/>
+                          </a:solidFill>
+                        </a:rPr>
+                        <a:t>Perbandingan Fusion</a:t>
+                      </a:r>
+                    </a:p>
+                  </a:txBody>
+                  <a:tcPr>
+                    <a:solidFill>
+                      <a:srgbClr val="E8F0FE"/>
+                    </a:solidFill>
+                  </a:tcPr>
+                </a:tc>
+                <a:tc>
+                  <a:txBody>
+                    <a:bodyPr/>
+                    <a:lstStyle/>
+                    <a:p>
+                      <a:pPr algn="ctr"/>
+                      <a:r>
+                        <a:rPr sz="900">
+                          <a:solidFill>
+                            <a:srgbClr val="202020"/>
+                          </a:solidFill>
+                        </a:rPr>
+                        <a:t>From scratch: FCNN &gt; Late Fusion &gt; Intermediate
+TL: Late Fusion TL terbaik (0.442)</a:t>
+                      </a:r>
+                    </a:p>
+                    <a:p>
+                      <a:r>
+                        <a:t>TL: Late Fusion TL terbaik (0.442)</a:t>
+                      </a:r>
+                    </a:p>
+                  </a:txBody>
+                  <a:tcPr>
+                    <a:solidFill>
+                      <a:srgbClr val="E8F0FE"/>
+                    </a:solidFill>
+                  </a:tcPr>
+                </a:tc>
+              </a:tr>
+            </a:tbl>
+          </a:graphicData>
+        </a:graphic>
+      </p:graphicFrame>
+      <p:graphicFrame>
+        <p:nvGraphicFramePr>
+          <p:cNvPr id="4" name="Table 3"/>
+          <p:cNvGraphicFramePr>
+            <a:graphicFrameLocks noGrp="1"/>
+          </p:cNvGraphicFramePr>
+          <p:nvPr/>
+        </p:nvGraphicFramePr>
+        <p:xfrm>
+          <a:off x="457200" y="3017520"/>
+          <a:ext cx="8229600" cy="1828800"/>
+        </p:xfrm>
+        <a:graphic>
+          <a:graphicData uri="http://schemas.openxmlformats.org/drawingml/2006/table">
+            <a:tbl>
+              <a:tblPr firstRow="1" bandRow="1">
+                <a:tableStyleId>{5C22544A-7EE6-4342-B048-85BDC9FD1C3A}</a:tableStyleId>
+              </a:tblPr>
+              <a:tblGrid>
+                <a:gridCol w="365760"/>
+                <a:gridCol w="2286000"/>
+                <a:gridCol w="5577840"/>
+              </a:tblGrid>
+              <a:tr h="365760">
+                <a:tc>
+                  <a:txBody>
+                    <a:bodyPr/>
+                    <a:lstStyle/>
+                    <a:p>
+                      <a:pPr algn="ctr"/>
+                      <a:r>
+                        <a:rPr sz="1000" b="1">
+                          <a:solidFill>
+                            <a:srgbClr val="FFFFFF"/>
+                          </a:solidFill>
+                        </a:rPr>
+                        <a:t>No</a:t>
+                      </a:r>
+                    </a:p>
+                  </a:txBody>
+                  <a:tcPr>
+                    <a:solidFill>
+                      <a:srgbClr val="1A73E8"/>
+                    </a:solidFill>
+                  </a:tcPr>
+                </a:tc>
+                <a:tc>
+                  <a:txBody>
+                    <a:bodyPr/>
+                    <a:lstStyle/>
+                    <a:p>
+                      <a:pPr algn="ctr"/>
+                      <a:r>
+                        <a:rPr sz="1000" b="1">
+                          <a:solidFill>
+                            <a:srgbClr val="FFFFFF"/>
+                          </a:solidFill>
+                        </a:rPr>
+                        <a:t>Topik Konsultasi</a:t>
+                      </a:r>
+                    </a:p>
+                  </a:txBody>
+                  <a:tcPr>
+                    <a:solidFill>
+                      <a:srgbClr val="1A73E8"/>
+                    </a:solidFill>
+                  </a:tcPr>
+                </a:tc>
+                <a:tc>
+                  <a:txBody>
+                    <a:bodyPr/>
+                    <a:lstStyle/>
+                    <a:p>
+                      <a:pPr algn="ctr"/>
+                      <a:r>
+                        <a:rPr sz="1000" b="1">
+                          <a:solidFill>
+                            <a:srgbClr val="FFFFFF"/>
+                          </a:solidFill>
+                        </a:rPr>
+                        <a:t>Pertanyaan</a:t>
+                      </a:r>
+                    </a:p>
+                  </a:txBody>
+                  <a:tcPr>
+                    <a:solidFill>
+                      <a:srgbClr val="1A73E8"/>
+                    </a:solidFill>
+                  </a:tcPr>
+                </a:tc>
+              </a:tr>
+              <a:tr h="365760">
+                <a:tc>
+                  <a:txBody>
+                    <a:bodyPr/>
+                    <a:lstStyle/>
+                    <a:p>
+                      <a:pPr algn="l"/>
+                      <a:r>
+                        <a:rPr sz="900">
+                          <a:solidFill>
+                            <a:srgbClr val="202020"/>
+                          </a:solidFill>
+                        </a:rPr>
+                        <a:t>1</a:t>
+                      </a:r>
+                    </a:p>
+                  </a:txBody>
+                  <a:tcPr>
+                    <a:solidFill>
+                      <a:srgbClr val="E8F0FE"/>
+                    </a:solidFill>
+                  </a:tcPr>
+                </a:tc>
+                <a:tc>
+                  <a:txBody>
+                    <a:bodyPr/>
+                    <a:lstStyle/>
+                    <a:p>
+                      <a:pPr algn="ctr"/>
+                      <a:r>
+                        <a:rPr sz="900">
+                          <a:solidFill>
+                            <a:srgbClr val="202020"/>
+                          </a:solidFill>
+                        </a:rPr>
+                        <a:t>Transfer Learning sebagai kontribusi</a:t>
+                      </a:r>
+                    </a:p>
+                  </a:txBody>
+                  <a:tcPr>
+                    <a:solidFill>
+                      <a:srgbClr val="E8F0FE"/>
+                    </a:solidFill>
+                  </a:tcPr>
+                </a:tc>
+                <a:tc>
+                  <a:txBody>
+                    <a:bodyPr/>
+                    <a:lstStyle/>
+                    <a:p>
+                      <a:pPr algn="ctr"/>
+                      <a:r>
+                        <a:rPr sz="900">
+                          <a:solidFill>
+                            <a:srgbClr val="202020"/>
+                          </a:solidFill>
+                        </a:rPr>
+                        <a:t>TL meningkatkan F1: 0.394 → 0.442. Cukup signifikan sebagai kontribusi tesis?</a:t>
+                      </a:r>
+                    </a:p>
+                  </a:txBody>
+                  <a:tcPr>
+                    <a:solidFill>
+                      <a:srgbClr val="E8F0FE"/>
+                    </a:solidFill>
+                  </a:tcPr>
+                </a:tc>
+              </a:tr>
+              <a:tr h="365760">
+                <a:tc>
+                  <a:txBody>
+                    <a:bodyPr/>
+                    <a:lstStyle/>
+                    <a:p>
+                      <a:pPr algn="l"/>
+                      <a:r>
+                        <a:rPr sz="900">
+                          <a:solidFill>
+                            <a:srgbClr val="202020"/>
+                          </a:solidFill>
+                        </a:rPr>
+                        <a:t>2</a:t>
+                      </a:r>
+                    </a:p>
+                  </a:txBody>
+                  <a:tcPr>
+                    <a:solidFill>
+                      <a:srgbClr val="FFFFFF"/>
+                    </a:solidFill>
+                  </a:tcPr>
+                </a:tc>
+                <a:tc>
+                  <a:txBody>
+                    <a:bodyPr/>
+                    <a:lstStyle/>
+                    <a:p>
+                      <a:pPr algn="ctr"/>
+                      <a:r>
+                        <a:rPr sz="900">
+                          <a:solidFill>
+                            <a:srgbClr val="202020"/>
+                          </a:solidFill>
+                        </a:rPr>
+                        <a:t>FCNN &gt; Fusion (from scratch)</a:t>
+                      </a:r>
+                    </a:p>
+                  </a:txBody>
+                  <a:tcPr>
+                    <a:solidFill>
+                      <a:srgbClr val="FFFFFF"/>
+                    </a:solidFill>
+                  </a:tcPr>
+                </a:tc>
+                <a:tc>
+                  <a:txBody>
+                    <a:bodyPr/>
+                    <a:lstStyle/>
+                    <a:p>
+                      <a:pPr algn="ctr"/>
+                      <a:r>
+                        <a:rPr sz="900">
+                          <a:solidFill>
+                            <a:srgbClr val="202020"/>
+                          </a:solidFill>
+                        </a:rPr>
+                        <a:t>Bertentangan hipotesis proposal — namun dengan TL, fusion akhirnya terbaik. Narasi tesis?</a:t>
+                      </a:r>
+                    </a:p>
+                  </a:txBody>
+                  <a:tcPr>
+                    <a:solidFill>
+                      <a:srgbClr val="FFFFFF"/>
+                    </a:solidFill>
+                  </a:tcPr>
+                </a:tc>
+              </a:tr>
+              <a:tr h="365760">
+                <a:tc>
+                  <a:txBody>
+                    <a:bodyPr/>
+                    <a:lstStyle/>
+                    <a:p>
+                      <a:pPr algn="l"/>
+                      <a:r>
+                        <a:rPr sz="900">
+                          <a:solidFill>
+                            <a:srgbClr val="202020"/>
+                          </a:solidFill>
+                        </a:rPr>
+                        <a:t>3</a:t>
+                      </a:r>
+                    </a:p>
+                  </a:txBody>
+                  <a:tcPr>
+                    <a:solidFill>
+                      <a:srgbClr val="E8F0FE"/>
+                    </a:solidFill>
+                  </a:tcPr>
+                </a:tc>
+                <a:tc>
+                  <a:txBody>
+                    <a:bodyPr/>
+                    <a:lstStyle/>
+                    <a:p>
+                      <a:pPr algn="ctr"/>
+                      <a:r>
+                        <a:rPr sz="900">
+                          <a:solidFill>
+                            <a:srgbClr val="202020"/>
+                          </a:solidFill>
+                        </a:rPr>
+                        <a:t>Macro F1 0.442</a:t>
+                      </a:r>
+                    </a:p>
+                  </a:txBody>
+                  <a:tcPr>
+                    <a:solidFill>
+                      <a:srgbClr val="E8F0FE"/>
+                    </a:solidFill>
+                  </a:tcPr>
+                </a:tc>
+                <a:tc>
+                  <a:txBody>
+                    <a:bodyPr/>
+                    <a:lstStyle/>
+                    <a:p>
+                      <a:pPr algn="ctr"/>
+                      <a:r>
+                        <a:rPr sz="900">
+                          <a:solidFill>
+                            <a:srgbClr val="202020"/>
+                          </a:solidFill>
+                        </a:rPr>
+                        <a:t>Acceptable untuk tesis S2? Dataset naturalistik, nyata, sangat imbalanced</a:t>
+                      </a:r>
+                    </a:p>
+                  </a:txBody>
+                  <a:tcPr>
+                    <a:solidFill>
+                      <a:srgbClr val="E8F0FE"/>
+                    </a:solidFill>
+                  </a:tcPr>
+                </a:tc>
+              </a:tr>
+              <a:tr h="365760">
+                <a:tc>
+                  <a:txBody>
+                    <a:bodyPr/>
+                    <a:lstStyle/>
+                    <a:p>
+                      <a:pPr algn="l"/>
+                      <a:r>
+                        <a:rPr sz="900">
+                          <a:solidFill>
+                            <a:srgbClr val="202020"/>
+                          </a:solidFill>
+                        </a:rPr>
+                        <a:t>4</a:t>
+                      </a:r>
+                    </a:p>
+                  </a:txBody>
+                  <a:tcPr>
+                    <a:solidFill>
+                      <a:srgbClr val="FFFFFF"/>
+                    </a:solidFill>
+                  </a:tcPr>
+                </a:tc>
+                <a:tc>
+                  <a:txBody>
+                    <a:bodyPr/>
+                    <a:lstStyle/>
+                    <a:p>
+                      <a:pPr algn="ctr"/>
+                      <a:r>
+                        <a:rPr sz="900">
+                          <a:solidFill>
+                            <a:srgbClr val="202020"/>
+                          </a:solidFill>
+                        </a:rPr>
+                        <a:t>Validasi ahli psikologi</a:t>
+                      </a:r>
+                    </a:p>
+                  </a:txBody>
+                  <a:tcPr>
+                    <a:solidFill>
+                      <a:srgbClr val="FFFFFF"/>
+                    </a:solidFill>
+                  </a:tcPr>
+                </a:tc>
+                <a:tc>
+                  <a:txBody>
+                    <a:bodyPr/>
+                    <a:lstStyle/>
+                    <a:p>
+                      <a:pPr algn="ctr"/>
+                      <a:r>
+                        <a:rPr sz="900">
+                          <a:solidFill>
+                            <a:srgbClr val="202020"/>
+                          </a:solidFill>
+                        </a:rPr>
+                        <a:t>Opsi A/B/C? 1 atau 2 ahli? Perlu honorarium?</a:t>
+                      </a:r>
+                    </a:p>
+                  </a:txBody>
+                  <a:tcPr>
+                    <a:solidFill>
+                      <a:srgbClr val="FFFFFF"/>
+                    </a:solidFill>
+                  </a:tcPr>
+                </a:tc>
+              </a:tr>
+            </a:tbl>
+          </a:graphicData>
+        </a:graphic>
+      </p:graphicFrame>
+    </p:spTree>
+  </p:cSld>
+  <p:clrMapOvr>
+    <a:masterClrMapping/>
+  </p:clrMapOvr>
+</p:sld>
+</file>
+
+<file path=ppt/slides/slide107.xml><?xml version="1.0" encoding="utf-8"?>
+<p:sld xmlns:a="http://schemas.openxmlformats.org/drawingml/2006/main" xmlns:p="http://schemas.openxmlformats.org/presentationml/2006/main" xmlns:r="http://schemas.openxmlformats.org/officeDocument/2006/relationships">
+  <p:cSld>
+    <p:spTree>
+      <p:sp>
+        <p:nvSpPr>
+          <p:cNvPr id="1" name="TextBox 0"/>
+          <p:cNvSpPr txBox="1"/>
+          <p:nvPr/>
+        </p:nvSpPr>
+        <p:spPr>
+          <a:xfrm>
+            <a:off x="914400" y="1920240"/>
+            <a:ext cx="7315200" cy="1097280"/>
+          </a:xfrm>
+          <a:prstGeom prst="rect">
+            <a:avLst/>
+          </a:prstGeom>
+          <a:noFill/>
+        </p:spPr>
+        <p:txBody>
+          <a:bodyPr wrap="none">
+            <a:spAutoFit/>
+          </a:bodyPr>
+          <a:lstStyle/>
+          <a:p>
+            <a:pPr algn="ctr">
+              <a:defRPr sz="4000" b="1"/>
+            </a:pPr>
+            <a:r>
+              <a:t>Terimakasih</a:t>
             </a:r>
           </a:p>
         </p:txBody>

</xml_diff>

<commit_message>
Add paper progress slide (slide 106)
- T&F paper: revision completed, ask for next steps
- JITECH paper: ask which data/experiments to use for akselerasi
  (front-only vs front+side, 4/7 class, benchmark, TL scope)

Co-Authored-By: Claude Opus 4.6 (1M context) <noreply@anthropic.com>
</commit_message>
<xml_diff>
--- a/docs/PPT Bimbingan.pptx
+++ b/docs/PPT Bimbingan.pptx
@@ -113,6 +113,7 @@
     <p:sldId id="356" r:id="rId106"/>
     <p:sldId id="357" r:id="rId107"/>
     <p:sldId id="363" r:id="rId113"/>
+    <p:sldId id="364" r:id="rId114"/>
     <p:sldId id="337" r:id="rId87"/>
     <p:sldId id="338" r:id="rId65"/>
   </p:sldIdLst>
@@ -17629,6 +17630,311 @@
 </p:sld>
 </file>
 
+<file path=ppt/slides/slide108.xml><?xml version="1.0" encoding="utf-8"?>
+<p:sld xmlns:a="http://schemas.openxmlformats.org/drawingml/2006/main" xmlns:p="http://schemas.openxmlformats.org/presentationml/2006/main" xmlns:r="http://schemas.openxmlformats.org/officeDocument/2006/relationships">
+  <p:cSld>
+    <p:spTree>
+      <p:nvGrpSpPr>
+        <p:cNvPr id="1" name=""/>
+        <p:cNvGrpSpPr/>
+        <p:nvPr/>
+      </p:nvGrpSpPr>
+      <p:grpSpPr/>
+      <p:sp>
+        <p:nvSpPr>
+          <p:cNvPr id="2" name="TextBox 1"/>
+          <p:cNvSpPr txBox="1"/>
+          <p:nvPr/>
+        </p:nvSpPr>
+        <p:spPr>
+          <a:xfrm>
+            <a:off x="274320" y="109728"/>
+            <a:ext cx="8595360" cy="502920"/>
+          </a:xfrm>
+          <a:prstGeom prst="rect">
+            <a:avLst/>
+          </a:prstGeom>
+          <a:noFill/>
+        </p:spPr>
+        <p:txBody>
+          <a:bodyPr wrap="none">
+            <a:spAutoFit/>
+          </a:bodyPr>
+          <a:lstStyle/>
+          <a:p>
+            <a:pPr algn="l"/>
+            <a:r>
+              <a:rPr sz="2000" b="1" i="0">
+                <a:solidFill>
+                  <a:srgbClr val="202020"/>
+                </a:solidFill>
+              </a:rPr>
+              <a:t>Progress &amp; Konsultasi Paper</a:t>
+            </a:r>
+          </a:p>
+        </p:txBody>
+      </p:sp>
+      <p:sp>
+        <p:nvSpPr>
+          <p:cNvPr id="3" name="TextBox 2"/>
+          <p:cNvSpPr txBox="1"/>
+          <p:nvPr/>
+        </p:nvSpPr>
+        <p:spPr>
+          <a:xfrm>
+            <a:off x="274320" y="731520"/>
+            <a:ext cx="8595360" cy="1097280"/>
+          </a:xfrm>
+          <a:prstGeom prst="rect">
+            <a:avLst/>
+          </a:prstGeom>
+          <a:solidFill>
+            <a:srgbClr val="E6F4EA"/>
+          </a:solidFill>
+        </p:spPr>
+        <p:txBody>
+          <a:bodyPr wrap="square">
+            <a:spAutoFit/>
+          </a:bodyPr>
+          <a:lstStyle/>
+          <a:p>
+            <a:pPr algn="l"/>
+            <a:r>
+              <a:rPr sz="1100" b="1" i="0">
+                <a:solidFill>
+                  <a:srgbClr val="0F9D58"/>
+                </a:solidFill>
+              </a:rPr>
+              <a:t>1. Draft Paper Taylor &amp; Francis (T&amp;F)</a:t>
+            </a:r>
+          </a:p>
+          <a:p>
+            <a:pPr algn="l"/>
+            <a:r>
+              <a:rPr sz="400" b="0" i="0"/>
+              <a:t/>
+            </a:r>
+          </a:p>
+          <a:p>
+            <a:pPr algn="l"/>
+            <a:r>
+              <a:rPr sz="1000" b="1" i="0">
+                <a:solidFill>
+                  <a:srgbClr val="202020"/>
+                </a:solidFill>
+              </a:rPr>
+              <a:t>Status: Revisi draft sudah selesai</a:t>
+            </a:r>
+          </a:p>
+          <a:p>
+            <a:pPr algn="l"/>
+            <a:r>
+              <a:rPr sz="950" b="0" i="0">
+                <a:solidFill>
+                  <a:srgbClr val="666666"/>
+                </a:solidFill>
+              </a:rPr>
+              <a:t>(sebelumnya sempat pending)</a:t>
+            </a:r>
+          </a:p>
+          <a:p>
+            <a:pPr algn="l"/>
+            <a:r>
+              <a:rPr sz="400" b="0" i="0"/>
+              <a:t/>
+            </a:r>
+          </a:p>
+          <a:p>
+            <a:pPr algn="l"/>
+            <a:r>
+              <a:rPr sz="1000" b="0" i="0">
+                <a:solidFill>
+                  <a:srgbClr val="202020"/>
+                </a:solidFill>
+              </a:rPr>
+              <a:t>Pertanyaan: Mohon arahan selanjutnya untuk proses submit/review</a:t>
+            </a:r>
+          </a:p>
+        </p:txBody>
+      </p:sp>
+      <p:sp>
+        <p:nvSpPr>
+          <p:cNvPr id="4" name="TextBox 3"/>
+          <p:cNvSpPr txBox="1"/>
+          <p:nvPr/>
+        </p:nvSpPr>
+        <p:spPr>
+          <a:xfrm>
+            <a:off x="274320" y="1965960"/>
+            <a:ext cx="8595360" cy="1645920"/>
+          </a:xfrm>
+          <a:prstGeom prst="rect">
+            <a:avLst/>
+          </a:prstGeom>
+          <a:solidFill>
+            <a:srgbClr val="FFF0CC"/>
+          </a:solidFill>
+        </p:spPr>
+        <p:txBody>
+          <a:bodyPr wrap="square">
+            <a:spAutoFit/>
+          </a:bodyPr>
+          <a:lstStyle/>
+          <a:p>
+            <a:pPr algn="l"/>
+            <a:r>
+              <a:rPr sz="1100" b="1" i="0">
+                <a:solidFill>
+                  <a:srgbClr val="E65100"/>
+                </a:solidFill>
+              </a:rPr>
+              <a:t>2. Draft Paper JITECH (untuk akselerasi)</a:t>
+            </a:r>
+          </a:p>
+          <a:p>
+            <a:pPr algn="l"/>
+            <a:r>
+              <a:rPr sz="400" b="0" i="0"/>
+              <a:t/>
+            </a:r>
+          </a:p>
+          <a:p>
+            <a:pPr algn="l"/>
+            <a:r>
+              <a:rPr sz="1000" b="1" i="0">
+                <a:solidFill>
+                  <a:srgbClr val="202020"/>
+                </a:solidFill>
+              </a:rPr>
+              <a:t>Pertanyaan:</a:t>
+            </a:r>
+          </a:p>
+          <a:p>
+            <a:pPr algn="l"/>
+            <a:r>
+              <a:rPr sz="400" b="0" i="0"/>
+              <a:t/>
+            </a:r>
+          </a:p>
+          <a:p>
+            <a:pPr algn="l"/>
+            <a:r>
+              <a:rPr sz="1000" b="0" i="0">
+                <a:solidFill>
+                  <a:srgbClr val="202020"/>
+                </a:solidFill>
+              </a:rPr>
+              <a:t>a. Apakah paper JITECH menggunakan data dari penelitian tesis ini?</a:t>
+            </a:r>
+          </a:p>
+          <a:p>
+            <a:pPr algn="l"/>
+            <a:r>
+              <a:rPr sz="300" b="0" i="0"/>
+              <a:t/>
+            </a:r>
+          </a:p>
+          <a:p>
+            <a:pPr algn="l"/>
+            <a:r>
+              <a:rPr sz="1000" b="0" i="0">
+                <a:solidFill>
+                  <a:srgbClr val="202020"/>
+                </a:solidFill>
+              </a:rPr>
+              <a:t>b. Jika iya, eksperimen mana yang digunakan?</a:t>
+            </a:r>
+          </a:p>
+          <a:p>
+            <a:pPr algn="l"/>
+            <a:r>
+              <a:rPr sz="950" b="0" i="0">
+                <a:solidFill>
+                  <a:srgbClr val="666666"/>
+                </a:solidFill>
+              </a:rPr>
+              <a:t>   - Front-only saja atau termasuk front+side?</a:t>
+            </a:r>
+          </a:p>
+          <a:p>
+            <a:pPr algn="l"/>
+            <a:r>
+              <a:rPr sz="950" b="0" i="0">
+                <a:solidFill>
+                  <a:srgbClr val="666666"/>
+                </a:solidFill>
+              </a:rPr>
+              <a:t>   - 4-class saja atau 7-class juga?</a:t>
+            </a:r>
+          </a:p>
+          <a:p>
+            <a:pPr algn="l"/>
+            <a:r>
+              <a:rPr sz="950" b="0" i="0">
+                <a:solidFill>
+                  <a:srgbClr val="666666"/>
+                </a:solidFill>
+              </a:rPr>
+              <a:t>   - Termasuk benchmark (JAFFE/CK+)?</a:t>
+            </a:r>
+          </a:p>
+          <a:p>
+            <a:pPr algn="l"/>
+            <a:r>
+              <a:rPr sz="950" b="0" i="0">
+                <a:solidFill>
+                  <a:srgbClr val="666666"/>
+                </a:solidFill>
+              </a:rPr>
+              <a:t>   - Transfer Learning saja atau semua model?</a:t>
+            </a:r>
+          </a:p>
+        </p:txBody>
+      </p:sp>
+      <p:sp>
+        <p:nvSpPr>
+          <p:cNvPr id="5" name="TextBox 4"/>
+          <p:cNvSpPr txBox="1"/>
+          <p:nvPr/>
+        </p:nvSpPr>
+        <p:spPr>
+          <a:xfrm>
+            <a:off x="274320" y="3749039"/>
+            <a:ext cx="8595360" cy="320040"/>
+          </a:xfrm>
+          <a:prstGeom prst="rect">
+            <a:avLst/>
+          </a:prstGeom>
+          <a:solidFill>
+            <a:srgbClr val="E8F0FE"/>
+          </a:solidFill>
+        </p:spPr>
+        <p:txBody>
+          <a:bodyPr wrap="square">
+            <a:spAutoFit/>
+          </a:bodyPr>
+          <a:lstStyle/>
+          <a:p>
+            <a:pPr algn="ctr"/>
+            <a:r>
+              <a:rPr sz="950" b="1" i="0">
+                <a:solidFill>
+                  <a:srgbClr val="202020"/>
+                </a:solidFill>
+              </a:rPr>
+              <a:t>Mohon arahan Pak Fitra terkait scope dan timeline kedua paper ini</a:t>
+            </a:r>
+          </a:p>
+        </p:txBody>
+      </p:sp>
+    </p:spTree>
+  </p:cSld>
+  <p:clrMapOvr>
+    <a:masterClrMapping/>
+  </p:clrMapOvr>
+</p:sld>
+</file>
+
 <file path=ppt/slides/slide11.xml><?xml version="1.0" encoding="utf-8"?>
 <p:sld xmlns:a="http://schemas.openxmlformats.org/drawingml/2006/main" xmlns:r="http://schemas.openxmlformats.org/officeDocument/2006/relationships" xmlns:mc="http://schemas.openxmlformats.org/markup-compatibility/2006" xmlns:mv="urn:schemas-microsoft-com:mac:vml" xmlns:p="http://schemas.openxmlformats.org/presentationml/2006/main" xmlns:c="http://schemas.openxmlformats.org/drawingml/2006/chart" xmlns:dgm="http://schemas.openxmlformats.org/drawingml/2006/diagram" xmlns:o="urn:schemas-microsoft-com:office:office" xmlns:v="urn:schemas-microsoft-com:vml" xmlns:pvml="urn:schemas-microsoft-com:office:powerpoint" xmlns:com="http://schemas.openxmlformats.org/drawingml/2006/compatibility" xmlns:p14="http://schemas.microsoft.com/office/powerpoint/2010/main" xmlns:p15="http://schemas.microsoft.com/office/powerpoint/2012/main" xmlns:ahyp="http://schemas.microsoft.com/office/drawing/2018/hyperlinkcolor">
   <p:cSld>

</xml_diff>

<commit_message>
Update paper slide with T&F (v0.3 sent), EECCIS (20 Apr), JITECH
- T&F: revision v0.3 completed, sent to Pak Fitra, ask about parallel review
- EECCIS/APDM: waiting for announcement April 20
- JITECH: ask about data scope for akselerasi paper

Co-Authored-By: Claude Opus 4.6 (1M context) <noreply@anthropic.com>
</commit_message>
<xml_diff>
--- a/docs/PPT Bimbingan.pptx
+++ b/docs/PPT Bimbingan.pptx
@@ -16868,6 +16868,376 @@
         </p:nvSpPr>
         <p:spPr>
           <a:xfrm>
+            <a:off x="274320" y="109728"/>
+            <a:ext cx="8595360" cy="502920"/>
+          </a:xfrm>
+          <a:prstGeom prst="rect">
+            <a:avLst/>
+          </a:prstGeom>
+          <a:noFill/>
+        </p:spPr>
+        <p:txBody>
+          <a:bodyPr wrap="none">
+            <a:spAutoFit/>
+          </a:bodyPr>
+          <a:lstStyle/>
+          <a:p>
+            <a:pPr algn="l"/>
+            <a:r>
+              <a:rPr sz="2000" b="1" i="0">
+                <a:solidFill>
+                  <a:srgbClr val="202020"/>
+                </a:solidFill>
+              </a:rPr>
+              <a:t>Progress &amp; Konsultasi Paper</a:t>
+            </a:r>
+          </a:p>
+        </p:txBody>
+      </p:sp>
+      <p:sp>
+        <p:nvSpPr>
+          <p:cNvPr id="3" name="TextBox 2"/>
+          <p:cNvSpPr txBox="1"/>
+          <p:nvPr/>
+        </p:nvSpPr>
+        <p:spPr>
+          <a:xfrm>
+            <a:off x="274320" y="685800"/>
+            <a:ext cx="8595360" cy="914400"/>
+          </a:xfrm>
+          <a:prstGeom prst="rect">
+            <a:avLst/>
+          </a:prstGeom>
+          <a:solidFill>
+            <a:srgbClr val="E6F4EA"/>
+          </a:solidFill>
+        </p:spPr>
+        <p:txBody>
+          <a:bodyPr wrap="square">
+            <a:spAutoFit/>
+          </a:bodyPr>
+          <a:lstStyle/>
+          <a:p>
+            <a:pPr algn="l"/>
+            <a:r>
+              <a:rPr sz="1100" b="1" i="0">
+                <a:solidFill>
+                  <a:srgbClr val="0F9D58"/>
+                </a:solidFill>
+              </a:rPr>
+              <a:t>1. Draft Paper Taylor &amp; Francis (T&amp;F)</a:t>
+            </a:r>
+          </a:p>
+          <a:p>
+            <a:pPr algn="l"/>
+            <a:r>
+              <a:rPr sz="300" b="0" i="0"/>
+              <a:t/>
+            </a:r>
+          </a:p>
+          <a:p>
+            <a:pPr algn="l"/>
+            <a:r>
+              <a:rPr sz="1000" b="1" i="0">
+                <a:solidFill>
+                  <a:srgbClr val="202020"/>
+                </a:solidFill>
+              </a:rPr>
+              <a:t>Status: Revisi draft v0.3 sudah selesai dan dikirim ke Pak Fitra via WA</a:t>
+            </a:r>
+          </a:p>
+          <a:p>
+            <a:pPr algn="l"/>
+            <a:r>
+              <a:rPr sz="900" b="0" i="1">
+                <a:solidFill>
+                  <a:srgbClr val="666666"/>
+                </a:solidFill>
+              </a:rPr>
+              <a:t>Link: drive.google.com/.../Taufik-Publikasi v0.3</a:t>
+            </a:r>
+          </a:p>
+          <a:p>
+            <a:pPr algn="l"/>
+            <a:r>
+              <a:rPr sz="300" b="0" i="0"/>
+              <a:t/>
+            </a:r>
+          </a:p>
+          <a:p>
+            <a:pPr algn="l"/>
+            <a:r>
+              <a:rPr sz="950" b="0" i="0">
+                <a:solidFill>
+                  <a:srgbClr val="202020"/>
+                </a:solidFill>
+              </a:rPr>
+              <a:t>Pertanyaan: Apakah draft sudah bisa dikirim ke Pak Budi &amp; Pak Fajar untuk review paralel,</a:t>
+            </a:r>
+          </a:p>
+          <a:p>
+            <a:pPr algn="l"/>
+            <a:r>
+              <a:rPr sz="950" b="0" i="0">
+                <a:solidFill>
+                  <a:srgbClr val="202020"/>
+                </a:solidFill>
+              </a:rPr>
+              <a:t>atau menunggu arahan dari Pak Fitra terlebih dahulu?</a:t>
+            </a:r>
+          </a:p>
+        </p:txBody>
+      </p:sp>
+      <p:sp>
+        <p:nvSpPr>
+          <p:cNvPr id="4" name="TextBox 3"/>
+          <p:cNvSpPr txBox="1"/>
+          <p:nvPr/>
+        </p:nvSpPr>
+        <p:spPr>
+          <a:xfrm>
+            <a:off x="274320" y="1737360"/>
+            <a:ext cx="8595360" cy="640080"/>
+          </a:xfrm>
+          <a:prstGeom prst="rect">
+            <a:avLst/>
+          </a:prstGeom>
+          <a:solidFill>
+            <a:srgbClr val="E8F0FE"/>
+          </a:solidFill>
+        </p:spPr>
+        <p:txBody>
+          <a:bodyPr wrap="square">
+            <a:spAutoFit/>
+          </a:bodyPr>
+          <a:lstStyle/>
+          <a:p>
+            <a:pPr algn="l"/>
+            <a:r>
+              <a:rPr sz="1100" b="1" i="0">
+                <a:solidFill>
+                  <a:srgbClr val="1A73E8"/>
+                </a:solidFill>
+              </a:rPr>
+              <a:t>2. Paper EECCIS (subset APDM)</a:t>
+            </a:r>
+          </a:p>
+          <a:p>
+            <a:pPr algn="l"/>
+            <a:r>
+              <a:rPr sz="300" b="0" i="0"/>
+              <a:t/>
+            </a:r>
+          </a:p>
+          <a:p>
+            <a:pPr algn="l"/>
+            <a:r>
+              <a:rPr sz="1000" b="1" i="0">
+                <a:solidFill>
+                  <a:srgbClr val="202020"/>
+                </a:solidFill>
+              </a:rPr>
+              <a:t>Status: Menunggu pengumuman -- tanggal 20 April 2026</a:t>
+            </a:r>
+          </a:p>
+        </p:txBody>
+      </p:sp>
+      <p:sp>
+        <p:nvSpPr>
+          <p:cNvPr id="5" name="TextBox 4"/>
+          <p:cNvSpPr txBox="1"/>
+          <p:nvPr/>
+        </p:nvSpPr>
+        <p:spPr>
+          <a:xfrm>
+            <a:off x="274320" y="2514600"/>
+            <a:ext cx="8595360" cy="1463040"/>
+          </a:xfrm>
+          <a:prstGeom prst="rect">
+            <a:avLst/>
+          </a:prstGeom>
+          <a:solidFill>
+            <a:srgbClr val="FFF0CC"/>
+          </a:solidFill>
+        </p:spPr>
+        <p:txBody>
+          <a:bodyPr wrap="square">
+            <a:spAutoFit/>
+          </a:bodyPr>
+          <a:lstStyle/>
+          <a:p>
+            <a:pPr algn="l"/>
+            <a:r>
+              <a:rPr sz="1100" b="1" i="0">
+                <a:solidFill>
+                  <a:srgbClr val="E65100"/>
+                </a:solidFill>
+              </a:rPr>
+              <a:t>3. Draft Paper JITECH (untuk akselerasi)</a:t>
+            </a:r>
+          </a:p>
+          <a:p>
+            <a:pPr algn="l"/>
+            <a:r>
+              <a:rPr sz="300" b="0" i="0"/>
+              <a:t/>
+            </a:r>
+          </a:p>
+          <a:p>
+            <a:pPr algn="l"/>
+            <a:r>
+              <a:rPr sz="1000" b="1" i="0">
+                <a:solidFill>
+                  <a:srgbClr val="202020"/>
+                </a:solidFill>
+              </a:rPr>
+              <a:t>Pertanyaan:</a:t>
+            </a:r>
+          </a:p>
+          <a:p>
+            <a:pPr algn="l"/>
+            <a:r>
+              <a:rPr sz="300" b="0" i="0"/>
+              <a:t/>
+            </a:r>
+          </a:p>
+          <a:p>
+            <a:pPr algn="l"/>
+            <a:r>
+              <a:rPr sz="1000" b="0" i="0">
+                <a:solidFill>
+                  <a:srgbClr val="202020"/>
+                </a:solidFill>
+              </a:rPr>
+              <a:t>a. Apakah paper JITECH menggunakan data dari penelitian tesis ini?</a:t>
+            </a:r>
+          </a:p>
+          <a:p>
+            <a:pPr algn="l"/>
+            <a:r>
+              <a:rPr sz="300" b="0" i="0"/>
+              <a:t/>
+            </a:r>
+          </a:p>
+          <a:p>
+            <a:pPr algn="l"/>
+            <a:r>
+              <a:rPr sz="1000" b="0" i="0">
+                <a:solidFill>
+                  <a:srgbClr val="202020"/>
+                </a:solidFill>
+              </a:rPr>
+              <a:t>b. Jika iya, eksperimen mana yang digunakan?</a:t>
+            </a:r>
+          </a:p>
+          <a:p>
+            <a:pPr algn="l"/>
+            <a:r>
+              <a:rPr sz="900" b="0" i="0">
+                <a:solidFill>
+                  <a:srgbClr val="666666"/>
+                </a:solidFill>
+              </a:rPr>
+              <a:t>   - Front-only saja atau termasuk front+side?</a:t>
+            </a:r>
+          </a:p>
+          <a:p>
+            <a:pPr algn="l"/>
+            <a:r>
+              <a:rPr sz="900" b="0" i="0">
+                <a:solidFill>
+                  <a:srgbClr val="666666"/>
+                </a:solidFill>
+              </a:rPr>
+              <a:t>   - 4-class saja atau 7-class juga?</a:t>
+            </a:r>
+          </a:p>
+          <a:p>
+            <a:pPr algn="l"/>
+            <a:r>
+              <a:rPr sz="900" b="0" i="0">
+                <a:solidFill>
+                  <a:srgbClr val="666666"/>
+                </a:solidFill>
+              </a:rPr>
+              <a:t>   - Termasuk benchmark (JAFFE/CK+)?</a:t>
+            </a:r>
+          </a:p>
+          <a:p>
+            <a:pPr algn="l"/>
+            <a:r>
+              <a:rPr sz="900" b="0" i="0">
+                <a:solidFill>
+                  <a:srgbClr val="666666"/>
+                </a:solidFill>
+              </a:rPr>
+              <a:t>   - Transfer Learning saja atau semua model?</a:t>
+            </a:r>
+          </a:p>
+        </p:txBody>
+      </p:sp>
+      <p:sp>
+        <p:nvSpPr>
+          <p:cNvPr id="6" name="TextBox 5"/>
+          <p:cNvSpPr txBox="1"/>
+          <p:nvPr/>
+        </p:nvSpPr>
+        <p:spPr>
+          <a:xfrm>
+            <a:off x="274320" y="4114800"/>
+            <a:ext cx="8595360" cy="274320"/>
+          </a:xfrm>
+          <a:prstGeom prst="rect">
+            <a:avLst/>
+          </a:prstGeom>
+          <a:solidFill>
+            <a:srgbClr val="1A73E8"/>
+          </a:solidFill>
+        </p:spPr>
+        <p:txBody>
+          <a:bodyPr wrap="square">
+            <a:spAutoFit/>
+          </a:bodyPr>
+          <a:lstStyle/>
+          <a:p>
+            <a:pPr algn="ctr"/>
+            <a:r>
+              <a:rPr sz="950" b="1" i="0">
+                <a:solidFill>
+                  <a:srgbClr val="FFFFFF"/>
+                </a:solidFill>
+              </a:rPr>
+              <a:t>Mohon arahan Pak Fitra terkait scope dan timeline ketiga paper ini</a:t>
+            </a:r>
+          </a:p>
+        </p:txBody>
+      </p:sp>
+    </p:spTree>
+  </p:cSld>
+  <p:clrMapOvr>
+    <a:masterClrMapping/>
+  </p:clrMapOvr>
+</p:sld>
+</file>
+
+<file path=ppt/slides/slide107.xml><?xml version="1.0" encoding="utf-8"?>
+<p:sld xmlns:a="http://schemas.openxmlformats.org/drawingml/2006/main" xmlns:p="http://schemas.openxmlformats.org/presentationml/2006/main" xmlns:r="http://schemas.openxmlformats.org/officeDocument/2006/relationships">
+  <p:cSld>
+    <p:spTree>
+      <p:nvGrpSpPr>
+        <p:cNvPr id="1" name=""/>
+        <p:cNvGrpSpPr/>
+        <p:nvPr/>
+      </p:nvGrpSpPr>
+      <p:grpSpPr/>
+      <p:sp>
+        <p:nvSpPr>
+          <p:cNvPr id="2" name="TextBox 1"/>
+          <p:cNvSpPr txBox="1"/>
+          <p:nvPr/>
+        </p:nvSpPr>
+        <p:spPr>
+          <a:xfrm>
             <a:off x="301752" y="429768"/>
             <a:ext cx="8321040" cy="548640"/>
           </a:xfrm>
@@ -17587,7 +17957,7 @@
 </p:sld>
 </file>
 
-<file path=ppt/slides/slide107.xml><?xml version="1.0" encoding="utf-8"?>
+<file path=ppt/slides/slide108.xml><?xml version="1.0" encoding="utf-8"?>
 <p:sld xmlns:a="http://schemas.openxmlformats.org/drawingml/2006/main" xmlns:p="http://schemas.openxmlformats.org/presentationml/2006/main" xmlns:r="http://schemas.openxmlformats.org/officeDocument/2006/relationships">
   <p:cSld>
     <p:spTree>
@@ -17618,311 +17988,6 @@
             </a:pPr>
             <a:r>
               <a:t>Terimakasih</a:t>
-            </a:r>
-          </a:p>
-        </p:txBody>
-      </p:sp>
-    </p:spTree>
-  </p:cSld>
-  <p:clrMapOvr>
-    <a:masterClrMapping/>
-  </p:clrMapOvr>
-</p:sld>
-</file>
-
-<file path=ppt/slides/slide108.xml><?xml version="1.0" encoding="utf-8"?>
-<p:sld xmlns:a="http://schemas.openxmlformats.org/drawingml/2006/main" xmlns:p="http://schemas.openxmlformats.org/presentationml/2006/main" xmlns:r="http://schemas.openxmlformats.org/officeDocument/2006/relationships">
-  <p:cSld>
-    <p:spTree>
-      <p:nvGrpSpPr>
-        <p:cNvPr id="1" name=""/>
-        <p:cNvGrpSpPr/>
-        <p:nvPr/>
-      </p:nvGrpSpPr>
-      <p:grpSpPr/>
-      <p:sp>
-        <p:nvSpPr>
-          <p:cNvPr id="2" name="TextBox 1"/>
-          <p:cNvSpPr txBox="1"/>
-          <p:nvPr/>
-        </p:nvSpPr>
-        <p:spPr>
-          <a:xfrm>
-            <a:off x="274320" y="109728"/>
-            <a:ext cx="8595360" cy="502920"/>
-          </a:xfrm>
-          <a:prstGeom prst="rect">
-            <a:avLst/>
-          </a:prstGeom>
-          <a:noFill/>
-        </p:spPr>
-        <p:txBody>
-          <a:bodyPr wrap="none">
-            <a:spAutoFit/>
-          </a:bodyPr>
-          <a:lstStyle/>
-          <a:p>
-            <a:pPr algn="l"/>
-            <a:r>
-              <a:rPr sz="2000" b="1" i="0">
-                <a:solidFill>
-                  <a:srgbClr val="202020"/>
-                </a:solidFill>
-              </a:rPr>
-              <a:t>Progress &amp; Konsultasi Paper</a:t>
-            </a:r>
-          </a:p>
-        </p:txBody>
-      </p:sp>
-      <p:sp>
-        <p:nvSpPr>
-          <p:cNvPr id="3" name="TextBox 2"/>
-          <p:cNvSpPr txBox="1"/>
-          <p:nvPr/>
-        </p:nvSpPr>
-        <p:spPr>
-          <a:xfrm>
-            <a:off x="274320" y="731520"/>
-            <a:ext cx="8595360" cy="1097280"/>
-          </a:xfrm>
-          <a:prstGeom prst="rect">
-            <a:avLst/>
-          </a:prstGeom>
-          <a:solidFill>
-            <a:srgbClr val="E6F4EA"/>
-          </a:solidFill>
-        </p:spPr>
-        <p:txBody>
-          <a:bodyPr wrap="square">
-            <a:spAutoFit/>
-          </a:bodyPr>
-          <a:lstStyle/>
-          <a:p>
-            <a:pPr algn="l"/>
-            <a:r>
-              <a:rPr sz="1100" b="1" i="0">
-                <a:solidFill>
-                  <a:srgbClr val="0F9D58"/>
-                </a:solidFill>
-              </a:rPr>
-              <a:t>1. Draft Paper Taylor &amp; Francis (T&amp;F)</a:t>
-            </a:r>
-          </a:p>
-          <a:p>
-            <a:pPr algn="l"/>
-            <a:r>
-              <a:rPr sz="400" b="0" i="0"/>
-              <a:t/>
-            </a:r>
-          </a:p>
-          <a:p>
-            <a:pPr algn="l"/>
-            <a:r>
-              <a:rPr sz="1000" b="1" i="0">
-                <a:solidFill>
-                  <a:srgbClr val="202020"/>
-                </a:solidFill>
-              </a:rPr>
-              <a:t>Status: Revisi draft sudah selesai</a:t>
-            </a:r>
-          </a:p>
-          <a:p>
-            <a:pPr algn="l"/>
-            <a:r>
-              <a:rPr sz="950" b="0" i="0">
-                <a:solidFill>
-                  <a:srgbClr val="666666"/>
-                </a:solidFill>
-              </a:rPr>
-              <a:t>(sebelumnya sempat pending)</a:t>
-            </a:r>
-          </a:p>
-          <a:p>
-            <a:pPr algn="l"/>
-            <a:r>
-              <a:rPr sz="400" b="0" i="0"/>
-              <a:t/>
-            </a:r>
-          </a:p>
-          <a:p>
-            <a:pPr algn="l"/>
-            <a:r>
-              <a:rPr sz="1000" b="0" i="0">
-                <a:solidFill>
-                  <a:srgbClr val="202020"/>
-                </a:solidFill>
-              </a:rPr>
-              <a:t>Pertanyaan: Mohon arahan selanjutnya untuk proses submit/review</a:t>
-            </a:r>
-          </a:p>
-        </p:txBody>
-      </p:sp>
-      <p:sp>
-        <p:nvSpPr>
-          <p:cNvPr id="4" name="TextBox 3"/>
-          <p:cNvSpPr txBox="1"/>
-          <p:nvPr/>
-        </p:nvSpPr>
-        <p:spPr>
-          <a:xfrm>
-            <a:off x="274320" y="1965960"/>
-            <a:ext cx="8595360" cy="1645920"/>
-          </a:xfrm>
-          <a:prstGeom prst="rect">
-            <a:avLst/>
-          </a:prstGeom>
-          <a:solidFill>
-            <a:srgbClr val="FFF0CC"/>
-          </a:solidFill>
-        </p:spPr>
-        <p:txBody>
-          <a:bodyPr wrap="square">
-            <a:spAutoFit/>
-          </a:bodyPr>
-          <a:lstStyle/>
-          <a:p>
-            <a:pPr algn="l"/>
-            <a:r>
-              <a:rPr sz="1100" b="1" i="0">
-                <a:solidFill>
-                  <a:srgbClr val="E65100"/>
-                </a:solidFill>
-              </a:rPr>
-              <a:t>2. Draft Paper JITECH (untuk akselerasi)</a:t>
-            </a:r>
-          </a:p>
-          <a:p>
-            <a:pPr algn="l"/>
-            <a:r>
-              <a:rPr sz="400" b="0" i="0"/>
-              <a:t/>
-            </a:r>
-          </a:p>
-          <a:p>
-            <a:pPr algn="l"/>
-            <a:r>
-              <a:rPr sz="1000" b="1" i="0">
-                <a:solidFill>
-                  <a:srgbClr val="202020"/>
-                </a:solidFill>
-              </a:rPr>
-              <a:t>Pertanyaan:</a:t>
-            </a:r>
-          </a:p>
-          <a:p>
-            <a:pPr algn="l"/>
-            <a:r>
-              <a:rPr sz="400" b="0" i="0"/>
-              <a:t/>
-            </a:r>
-          </a:p>
-          <a:p>
-            <a:pPr algn="l"/>
-            <a:r>
-              <a:rPr sz="1000" b="0" i="0">
-                <a:solidFill>
-                  <a:srgbClr val="202020"/>
-                </a:solidFill>
-              </a:rPr>
-              <a:t>a. Apakah paper JITECH menggunakan data dari penelitian tesis ini?</a:t>
-            </a:r>
-          </a:p>
-          <a:p>
-            <a:pPr algn="l"/>
-            <a:r>
-              <a:rPr sz="300" b="0" i="0"/>
-              <a:t/>
-            </a:r>
-          </a:p>
-          <a:p>
-            <a:pPr algn="l"/>
-            <a:r>
-              <a:rPr sz="1000" b="0" i="0">
-                <a:solidFill>
-                  <a:srgbClr val="202020"/>
-                </a:solidFill>
-              </a:rPr>
-              <a:t>b. Jika iya, eksperimen mana yang digunakan?</a:t>
-            </a:r>
-          </a:p>
-          <a:p>
-            <a:pPr algn="l"/>
-            <a:r>
-              <a:rPr sz="950" b="0" i="0">
-                <a:solidFill>
-                  <a:srgbClr val="666666"/>
-                </a:solidFill>
-              </a:rPr>
-              <a:t>   - Front-only saja atau termasuk front+side?</a:t>
-            </a:r>
-          </a:p>
-          <a:p>
-            <a:pPr algn="l"/>
-            <a:r>
-              <a:rPr sz="950" b="0" i="0">
-                <a:solidFill>
-                  <a:srgbClr val="666666"/>
-                </a:solidFill>
-              </a:rPr>
-              <a:t>   - 4-class saja atau 7-class juga?</a:t>
-            </a:r>
-          </a:p>
-          <a:p>
-            <a:pPr algn="l"/>
-            <a:r>
-              <a:rPr sz="950" b="0" i="0">
-                <a:solidFill>
-                  <a:srgbClr val="666666"/>
-                </a:solidFill>
-              </a:rPr>
-              <a:t>   - Termasuk benchmark (JAFFE/CK+)?</a:t>
-            </a:r>
-          </a:p>
-          <a:p>
-            <a:pPr algn="l"/>
-            <a:r>
-              <a:rPr sz="950" b="0" i="0">
-                <a:solidFill>
-                  <a:srgbClr val="666666"/>
-                </a:solidFill>
-              </a:rPr>
-              <a:t>   - Transfer Learning saja atau semua model?</a:t>
-            </a:r>
-          </a:p>
-        </p:txBody>
-      </p:sp>
-      <p:sp>
-        <p:nvSpPr>
-          <p:cNvPr id="5" name="TextBox 4"/>
-          <p:cNvSpPr txBox="1"/>
-          <p:nvPr/>
-        </p:nvSpPr>
-        <p:spPr>
-          <a:xfrm>
-            <a:off x="274320" y="3749039"/>
-            <a:ext cx="8595360" cy="320040"/>
-          </a:xfrm>
-          <a:prstGeom prst="rect">
-            <a:avLst/>
-          </a:prstGeom>
-          <a:solidFill>
-            <a:srgbClr val="E8F0FE"/>
-          </a:solidFill>
-        </p:spPr>
-        <p:txBody>
-          <a:bodyPr wrap="square">
-            <a:spAutoFit/>
-          </a:bodyPr>
-          <a:lstStyle/>
-          <a:p>
-            <a:pPr algn="ctr"/>
-            <a:r>
-              <a:rPr sz="950" b="1" i="0">
-                <a:solidFill>
-                  <a:srgbClr val="202020"/>
-                </a:solidFill>
-              </a:rPr>
-              <a:t>Mohon arahan Pak Fitra terkait scope dan timeline kedua paper ini</a:t>
             </a:r>
           </a:p>
         </p:txBody>

</xml_diff>

<commit_message>
Add planned experiments slide: Focal Loss + FER2013 pre-training
Slide 107: two strategies (Focal Loss, FER2013 two-stage TL),
8 planned experiments, status: scripts ready, FER2013 downloaded

Co-Authored-By: Claude Opus 4.6 (1M context) <noreply@anthropic.com>
</commit_message>
<xml_diff>
--- a/docs/PPT Bimbingan.pptx
+++ b/docs/PPT Bimbingan.pptx
@@ -114,6 +114,7 @@
     <p:sldId id="357" r:id="rId107"/>
     <p:sldId id="363" r:id="rId113"/>
     <p:sldId id="364" r:id="rId114"/>
+    <p:sldId id="365" r:id="rId115"/>
     <p:sldId id="337" r:id="rId87"/>
     <p:sldId id="338" r:id="rId65"/>
   </p:sldIdLst>
@@ -18000,6 +18001,474 @@
 </p:sld>
 </file>
 
+<file path=ppt/slides/slide109.xml><?xml version="1.0" encoding="utf-8"?>
+<p:sld xmlns:a="http://schemas.openxmlformats.org/drawingml/2006/main" xmlns:p="http://schemas.openxmlformats.org/presentationml/2006/main" xmlns:r="http://schemas.openxmlformats.org/officeDocument/2006/relationships">
+  <p:cSld>
+    <p:spTree>
+      <p:nvGrpSpPr>
+        <p:cNvPr id="1" name=""/>
+        <p:cNvGrpSpPr/>
+        <p:nvPr/>
+      </p:nvGrpSpPr>
+      <p:grpSpPr/>
+      <p:sp>
+        <p:nvSpPr>
+          <p:cNvPr id="2" name="TextBox 1"/>
+          <p:cNvSpPr txBox="1"/>
+          <p:nvPr/>
+        </p:nvSpPr>
+        <p:spPr>
+          <a:xfrm>
+            <a:off x="274320" y="109728"/>
+            <a:ext cx="8595360" cy="502920"/>
+          </a:xfrm>
+          <a:prstGeom prst="rect">
+            <a:avLst/>
+          </a:prstGeom>
+          <a:noFill/>
+        </p:spPr>
+        <p:txBody>
+          <a:bodyPr wrap="none">
+            <a:spAutoFit/>
+          </a:bodyPr>
+          <a:lstStyle/>
+          <a:p>
+            <a:pPr algn="l"/>
+            <a:r>
+              <a:rPr sz="1800" b="1" i="0">
+                <a:solidFill>
+                  <a:srgbClr val="202020"/>
+                </a:solidFill>
+              </a:rPr>
+              <a:t>Rencana Eksperimen Lanjutan: Peningkatan Performa</a:t>
+            </a:r>
+          </a:p>
+        </p:txBody>
+      </p:sp>
+      <p:sp>
+        <p:nvSpPr>
+          <p:cNvPr id="3" name="TextBox 2"/>
+          <p:cNvSpPr txBox="1"/>
+          <p:nvPr/>
+        </p:nvSpPr>
+        <p:spPr>
+          <a:xfrm>
+            <a:off x="274320" y="685800"/>
+            <a:ext cx="8595360" cy="640080"/>
+          </a:xfrm>
+          <a:prstGeom prst="rect">
+            <a:avLst/>
+          </a:prstGeom>
+          <a:solidFill>
+            <a:srgbClr val="FFF0CC"/>
+          </a:solidFill>
+        </p:spPr>
+        <p:txBody>
+          <a:bodyPr wrap="square">
+            <a:spAutoFit/>
+          </a:bodyPr>
+          <a:lstStyle/>
+          <a:p>
+            <a:pPr algn="l"/>
+            <a:r>
+              <a:rPr sz="1000" b="1" i="0">
+                <a:solidFill>
+                  <a:srgbClr val="202020"/>
+                </a:solidFill>
+              </a:rPr>
+              <a:t>Motivasi: Macro F1 terbaik saat ini 0.412 (single split) / 0.370 (LOSO).</a:t>
+            </a:r>
+          </a:p>
+          <a:p>
+            <a:pPr algn="l"/>
+            <a:r>
+              <a:rPr sz="950" b="0" i="0">
+                <a:solidFill>
+                  <a:srgbClr val="202020"/>
+                </a:solidFill>
+              </a:rPr>
+              <a:t>Dua strategi yang sedang disiapkan untuk meningkatkan performa:</a:t>
+            </a:r>
+          </a:p>
+        </p:txBody>
+      </p:sp>
+      <p:sp>
+        <p:nvSpPr>
+          <p:cNvPr id="4" name="TextBox 3"/>
+          <p:cNvSpPr txBox="1"/>
+          <p:nvPr/>
+        </p:nvSpPr>
+        <p:spPr>
+          <a:xfrm>
+            <a:off x="274320" y="1463040"/>
+            <a:ext cx="4114800" cy="1463040"/>
+          </a:xfrm>
+          <a:prstGeom prst="rect">
+            <a:avLst/>
+          </a:prstGeom>
+          <a:solidFill>
+            <a:srgbClr val="E6F4EA"/>
+          </a:solidFill>
+        </p:spPr>
+        <p:txBody>
+          <a:bodyPr wrap="square">
+            <a:spAutoFit/>
+          </a:bodyPr>
+          <a:lstStyle/>
+          <a:p>
+            <a:pPr algn="l"/>
+            <a:r>
+              <a:rPr sz="1100" b="1" i="0">
+                <a:solidFill>
+                  <a:srgbClr val="0F9D58"/>
+                </a:solidFill>
+              </a:rPr>
+              <a:t>Strategi 1: Focal Loss</a:t>
+            </a:r>
+          </a:p>
+          <a:p>
+            <a:pPr algn="l"/>
+            <a:r>
+              <a:rPr sz="800" b="0" i="1">
+                <a:solidFill>
+                  <a:srgbClr val="666666"/>
+                </a:solidFill>
+              </a:rPr>
+              <a:t>(Lin et al., 2017)</a:t>
+            </a:r>
+          </a:p>
+          <a:p>
+            <a:pPr algn="l"/>
+            <a:r>
+              <a:rPr sz="400" b="0" i="0"/>
+              <a:t/>
+            </a:r>
+          </a:p>
+          <a:p>
+            <a:pPr algn="l"/>
+            <a:r>
+              <a:rPr sz="950" b="0" i="0">
+                <a:solidFill>
+                  <a:srgbClr val="202020"/>
+                </a:solidFill>
+              </a:rPr>
+              <a:t>Mengganti CrossEntropyLoss dengan</a:t>
+            </a:r>
+          </a:p>
+          <a:p>
+            <a:pPr algn="l"/>
+            <a:r>
+              <a:rPr sz="950" b="0" i="0">
+                <a:solidFill>
+                  <a:srgbClr val="202020"/>
+                </a:solidFill>
+              </a:rPr>
+              <a:t>Focal Loss yang fokus ke sampel sulit.</a:t>
+            </a:r>
+          </a:p>
+          <a:p>
+            <a:pPr algn="l"/>
+            <a:r>
+              <a:rPr sz="300" b="0" i="0"/>
+              <a:t/>
+            </a:r>
+          </a:p>
+          <a:p>
+            <a:pPr algn="l"/>
+            <a:r>
+              <a:rPr sz="900" b="0" i="1">
+                <a:solidFill>
+                  <a:srgbClr val="666666"/>
+                </a:solidFill>
+              </a:rPr>
+              <a:t>FL(p) = -alpha * (1-p)^gamma * log(p)</a:t>
+            </a:r>
+          </a:p>
+          <a:p>
+            <a:pPr algn="l"/>
+            <a:r>
+              <a:rPr sz="300" b="0" i="0"/>
+              <a:t/>
+            </a:r>
+          </a:p>
+          <a:p>
+            <a:pPr algn="l"/>
+            <a:r>
+              <a:rPr sz="950" b="0" i="0">
+                <a:solidFill>
+                  <a:srgbClr val="202020"/>
+                </a:solidFill>
+              </a:rPr>
+              <a:t>Dirancang khusus untuk imbalanced data.</a:t>
+            </a:r>
+          </a:p>
+          <a:p>
+            <a:pPr algn="l"/>
+            <a:r>
+              <a:rPr sz="950" b="1" i="0">
+                <a:solidFill>
+                  <a:srgbClr val="0F9D58"/>
+                </a:solidFill>
+              </a:rPr>
+              <a:t>Estimasi improvement: +5-15% F1</a:t>
+            </a:r>
+          </a:p>
+        </p:txBody>
+      </p:sp>
+      <p:sp>
+        <p:nvSpPr>
+          <p:cNvPr id="5" name="TextBox 4"/>
+          <p:cNvSpPr txBox="1"/>
+          <p:nvPr/>
+        </p:nvSpPr>
+        <p:spPr>
+          <a:xfrm>
+            <a:off x="4572000" y="1463040"/>
+            <a:ext cx="4297680" cy="1463040"/>
+          </a:xfrm>
+          <a:prstGeom prst="rect">
+            <a:avLst/>
+          </a:prstGeom>
+          <a:solidFill>
+            <a:srgbClr val="E8F0FE"/>
+          </a:solidFill>
+        </p:spPr>
+        <p:txBody>
+          <a:bodyPr wrap="square">
+            <a:spAutoFit/>
+          </a:bodyPr>
+          <a:lstStyle/>
+          <a:p>
+            <a:pPr algn="l"/>
+            <a:r>
+              <a:rPr sz="1100" b="1" i="0">
+                <a:solidFill>
+                  <a:srgbClr val="1A73E8"/>
+                </a:solidFill>
+              </a:rPr>
+              <a:t>Strategi 2: Pre-train FER2013</a:t>
+            </a:r>
+          </a:p>
+          <a:p>
+            <a:pPr algn="l"/>
+            <a:r>
+              <a:rPr sz="800" b="0" i="1">
+                <a:solidFill>
+                  <a:srgbClr val="666666"/>
+                </a:solidFill>
+              </a:rPr>
+              <a:t>(35,887 gambar emosi wajah)</a:t>
+            </a:r>
+          </a:p>
+          <a:p>
+            <a:pPr algn="l"/>
+            <a:r>
+              <a:rPr sz="400" b="0" i="0"/>
+              <a:t/>
+            </a:r>
+          </a:p>
+          <a:p>
+            <a:pPr algn="l"/>
+            <a:r>
+              <a:rPr sz="950" b="0" i="0">
+                <a:solidFill>
+                  <a:srgbClr val="202020"/>
+                </a:solidFill>
+              </a:rPr>
+              <a:t>Two-stage Transfer Learning:</a:t>
+            </a:r>
+          </a:p>
+          <a:p>
+            <a:pPr algn="l"/>
+            <a:r>
+              <a:rPr sz="950" b="1" i="0">
+                <a:solidFill>
+                  <a:srgbClr val="202020"/>
+                </a:solidFill>
+              </a:rPr>
+              <a:t>ImageNet -&gt; FER2013 -&gt; Dataset sendiri</a:t>
+            </a:r>
+          </a:p>
+          <a:p>
+            <a:pPr algn="l"/>
+            <a:r>
+              <a:rPr sz="300" b="0" i="0"/>
+              <a:t/>
+            </a:r>
+          </a:p>
+          <a:p>
+            <a:pPr algn="l"/>
+            <a:r>
+              <a:rPr sz="900" b="0" i="0">
+                <a:solidFill>
+                  <a:srgbClr val="666666"/>
+                </a:solidFill>
+              </a:rPr>
+              <a:t>ImageNet: fitur visual umum (kucing, mobil)</a:t>
+            </a:r>
+          </a:p>
+          <a:p>
+            <a:pPr algn="l"/>
+            <a:r>
+              <a:rPr sz="900" b="0" i="0">
+                <a:solidFill>
+                  <a:srgbClr val="666666"/>
+                </a:solidFill>
+              </a:rPr>
+              <a:t>FER2013: fitur ekspresi wajah (domain-specific)</a:t>
+            </a:r>
+          </a:p>
+          <a:p>
+            <a:pPr algn="l"/>
+            <a:r>
+              <a:rPr sz="300" b="0" i="0"/>
+              <a:t/>
+            </a:r>
+          </a:p>
+          <a:p>
+            <a:pPr algn="l"/>
+            <a:r>
+              <a:rPr sz="950" b="1" i="0">
+                <a:solidFill>
+                  <a:srgbClr val="1A73E8"/>
+                </a:solidFill>
+              </a:rPr>
+              <a:t>Estimasi improvement: +10-20% F1</a:t>
+            </a:r>
+          </a:p>
+        </p:txBody>
+      </p:sp>
+      <p:sp>
+        <p:nvSpPr>
+          <p:cNvPr id="6" name="TextBox 5"/>
+          <p:cNvSpPr txBox="1"/>
+          <p:nvPr/>
+        </p:nvSpPr>
+        <p:spPr>
+          <a:xfrm>
+            <a:off x="274320" y="3063240"/>
+            <a:ext cx="8595360" cy="914400"/>
+          </a:xfrm>
+          <a:prstGeom prst="rect">
+            <a:avLst/>
+          </a:prstGeom>
+          <a:solidFill>
+            <a:srgbClr val="F1F3F4"/>
+          </a:solidFill>
+        </p:spPr>
+        <p:txBody>
+          <a:bodyPr wrap="square">
+            <a:spAutoFit/>
+          </a:bodyPr>
+          <a:lstStyle/>
+          <a:p>
+            <a:pPr algn="l"/>
+            <a:r>
+              <a:rPr sz="1000" b="1" i="0">
+                <a:solidFill>
+                  <a:srgbClr val="202020"/>
+                </a:solidFill>
+              </a:rPr>
+              <a:t>Eksperimen yang akan dijalankan (8 kombinasi, 4-class front-only):</a:t>
+            </a:r>
+          </a:p>
+          <a:p>
+            <a:pPr algn="l"/>
+            <a:r>
+              <a:rPr sz="300" b="0" i="0"/>
+              <a:t/>
+            </a:r>
+          </a:p>
+          <a:p>
+            <a:pPr algn="l"/>
+            <a:r>
+              <a:rPr sz="900" b="0" i="0">
+                <a:solidFill>
+                  <a:srgbClr val="202020"/>
+                </a:solidFill>
+              </a:rPr>
+              <a:t>1. CNN TL + Focal Loss                    5. CNN FER2013 + Focal Loss (best combo)</a:t>
+            </a:r>
+          </a:p>
+          <a:p>
+            <a:pPr algn="l"/>
+            <a:r>
+              <a:rPr sz="900" b="0" i="0">
+                <a:solidFill>
+                  <a:srgbClr val="202020"/>
+                </a:solidFill>
+              </a:rPr>
+              <a:t>2. FCNN + Focal Loss                       6. Intermediate FER2013 + Focal Loss</a:t>
+            </a:r>
+          </a:p>
+          <a:p>
+            <a:pPr algn="l"/>
+            <a:r>
+              <a:rPr sz="900" b="0" i="0">
+                <a:solidFill>
+                  <a:srgbClr val="202020"/>
+                </a:solidFill>
+              </a:rPr>
+              <a:t>3. Intermediate TL + Focal Loss       7. Late Fusion FER2013 + Focal Loss</a:t>
+            </a:r>
+          </a:p>
+          <a:p>
+            <a:pPr algn="l"/>
+            <a:r>
+              <a:rPr sz="900" b="0" i="0">
+                <a:solidFill>
+                  <a:srgbClr val="202020"/>
+                </a:solidFill>
+              </a:rPr>
+              <a:t>4. CNN FER2013 + CrossEntropy        8. Intermediate FER2013 + CrossEntropy</a:t>
+            </a:r>
+          </a:p>
+        </p:txBody>
+      </p:sp>
+      <p:sp>
+        <p:nvSpPr>
+          <p:cNvPr id="7" name="TextBox 6"/>
+          <p:cNvSpPr txBox="1"/>
+          <p:nvPr/>
+        </p:nvSpPr>
+        <p:spPr>
+          <a:xfrm>
+            <a:off x="274320" y="4069080"/>
+            <a:ext cx="8595360" cy="320040"/>
+          </a:xfrm>
+          <a:prstGeom prst="rect">
+            <a:avLst/>
+          </a:prstGeom>
+          <a:solidFill>
+            <a:srgbClr val="1A73E8"/>
+          </a:solidFill>
+        </p:spPr>
+        <p:txBody>
+          <a:bodyPr wrap="square">
+            <a:spAutoFit/>
+          </a:bodyPr>
+          <a:lstStyle/>
+          <a:p>
+            <a:pPr algn="ctr"/>
+            <a:r>
+              <a:rPr sz="950" b="1" i="0">
+                <a:solidFill>
+                  <a:srgbClr val="FFFFFF"/>
+                </a:solidFill>
+              </a:rPr>
+              <a:t>Status: Script &amp; notebook sudah siap | FER2013 sudah didownload | Estimasi ~3-5 jam di VPS</a:t>
+            </a:r>
+          </a:p>
+        </p:txBody>
+      </p:sp>
+    </p:spTree>
+  </p:cSld>
+  <p:clrMapOvr>
+    <a:masterClrMapping/>
+  </p:clrMapOvr>
+</p:sld>
+</file>
+
 <file path=ppt/slides/slide11.xml><?xml version="1.0" encoding="utf-8"?>
 <p:sld xmlns:a="http://schemas.openxmlformats.org/drawingml/2006/main" xmlns:r="http://schemas.openxmlformats.org/officeDocument/2006/relationships" xmlns:mc="http://schemas.openxmlformats.org/markup-compatibility/2006" xmlns:mv="urn:schemas-microsoft-com:mac:vml" xmlns:p="http://schemas.openxmlformats.org/presentationml/2006/main" xmlns:c="http://schemas.openxmlformats.org/drawingml/2006/chart" xmlns:dgm="http://schemas.openxmlformats.org/drawingml/2006/diagram" xmlns:o="urn:schemas-microsoft-com:office:office" xmlns:v="urn:schemas-microsoft-com:vml" xmlns:pvml="urn:schemas-microsoft-com:office:powerpoint" xmlns:com="http://schemas.openxmlformats.org/drawingml/2006/compatibility" xmlns:p14="http://schemas.microsoft.com/office/powerpoint/2010/main" xmlns:p15="http://schemas.microsoft.com/office/powerpoint/2012/main" xmlns:ahyp="http://schemas.microsoft.com/office/drawing/2018/hyperlinkcolor">
   <p:cSld>

</xml_diff>